<commit_message>
plantilla donde estudiar et al
</commit_message>
<xml_diff>
--- a/assets/template_islas_identidad.pptx
+++ b/assets/template_islas_identidad.pptx
@@ -1,48 +1,48 @@
 
 <file path=ppt/presentation.xml><?xml version="1.0" encoding="utf-8"?>
-<p:presentation xmlns:a="http://schemas.openxmlformats.org/drawingml/2006/main" xmlns:r="http://schemas.openxmlformats.org/officeDocument/2006/relationships" xmlns:mc="http://schemas.openxmlformats.org/markup-compatibility/2006" xmlns:mv="urn:schemas-microsoft-com:mac:vml" xmlns:p="http://schemas.openxmlformats.org/presentationml/2006/main" xmlns:c="http://schemas.openxmlformats.org/drawingml/2006/chart" xmlns:dgm="http://schemas.openxmlformats.org/drawingml/2006/diagram" xmlns:o="urn:schemas-microsoft-com:office:office" xmlns:v="urn:schemas-microsoft-com:vml" xmlns:pvml="urn:schemas-microsoft-com:office:powerpoint" xmlns:com="http://schemas.openxmlformats.org/drawingml/2006/compatibility" xmlns:p14="http://schemas.microsoft.com/office/powerpoint/2010/main" xmlns:p15="http://schemas.microsoft.com/office/powerpoint/2012/main" xmlns:ahyp="http://schemas.microsoft.com/office/drawing/2018/hyperlinkcolor" autoCompressPictures="0" embedTrueTypeFonts="1" strictFirstAndLastChars="0" saveSubsetFonts="1">
+<p:presentation xmlns:a="http://schemas.openxmlformats.org/drawingml/2006/main" xmlns:r="http://schemas.openxmlformats.org/officeDocument/2006/relationships" xmlns:p="http://schemas.openxmlformats.org/presentationml/2006/main" strictFirstAndLastChars="0" embedTrueTypeFonts="1" saveSubsetFonts="1" autoCompressPictures="0">
   <p:sldMasterIdLst>
-    <p:sldMasterId id="2147483659" r:id="rId3"/>
+    <p:sldMasterId id="2147483659" r:id="rId1"/>
   </p:sldMasterIdLst>
   <p:notesMasterIdLst>
-    <p:notesMasterId r:id="rId4"/>
+    <p:notesMasterId r:id="rId9"/>
   </p:notesMasterIdLst>
   <p:sldIdLst>
-    <p:sldId id="256" r:id="rId5"/>
-    <p:sldId id="257" r:id="rId6"/>
-    <p:sldId id="258" r:id="rId7"/>
-    <p:sldId id="259" r:id="rId8"/>
-    <p:sldId id="260" r:id="rId9"/>
-    <p:sldId id="261" r:id="rId10"/>
-    <p:sldId id="262" r:id="rId11"/>
+    <p:sldId id="256" r:id="rId2"/>
+    <p:sldId id="257" r:id="rId3"/>
+    <p:sldId id="258" r:id="rId4"/>
+    <p:sldId id="259" r:id="rId5"/>
+    <p:sldId id="260" r:id="rId6"/>
+    <p:sldId id="261" r:id="rId7"/>
+    <p:sldId id="262" r:id="rId8"/>
   </p:sldIdLst>
-  <p:sldSz cy="5143500" cx="9144000"/>
+  <p:sldSz cx="9144000" cy="5143500" type="screen16x9"/>
   <p:notesSz cx="6858000" cy="9144000"/>
   <p:embeddedFontLst>
     <p:embeddedFont>
-      <p:font typeface="Archivo Medium"/>
-      <p:regular r:id="rId12"/>
-      <p:bold r:id="rId13"/>
-      <p:italic r:id="rId14"/>
-      <p:boldItalic r:id="rId15"/>
+      <p:font typeface="Archivo" panose="020B0604020202020204" charset="0"/>
+      <p:regular r:id="rId10"/>
+      <p:bold r:id="rId11"/>
+      <p:italic r:id="rId12"/>
+      <p:boldItalic r:id="rId13"/>
     </p:embeddedFont>
     <p:embeddedFont>
-      <p:font typeface="Archivo"/>
-      <p:regular r:id="rId16"/>
-      <p:bold r:id="rId17"/>
-      <p:italic r:id="rId18"/>
-      <p:boldItalic r:id="rId19"/>
+      <p:font typeface="Archivo Medium" panose="020B0604020202020204" charset="0"/>
+      <p:regular r:id="rId14"/>
+      <p:bold r:id="rId15"/>
+      <p:italic r:id="rId16"/>
+      <p:boldItalic r:id="rId17"/>
     </p:embeddedFont>
     <p:embeddedFont>
-      <p:font typeface="Archivo SemiBold"/>
-      <p:regular r:id="rId20"/>
-      <p:bold r:id="rId21"/>
-      <p:italic r:id="rId22"/>
-      <p:boldItalic r:id="rId23"/>
+      <p:font typeface="Archivo SemiBold" panose="020B0604020202020204" charset="0"/>
+      <p:regular r:id="rId18"/>
+      <p:bold r:id="rId19"/>
+      <p:italic r:id="rId20"/>
+      <p:boldItalic r:id="rId21"/>
     </p:embeddedFont>
   </p:embeddedFontLst>
   <p:defaultTextStyle>
-    <a:defPPr lvl="0" marR="0" rtl="0" algn="l">
+    <a:defPPr marR="0" lvl="0" algn="l" rtl="0">
       <a:lnSpc>
         <a:spcPct val="100000"/>
       </a:lnSpc>
@@ -53,7 +53,7 @@
         <a:spcPts val="0"/>
       </a:spcAft>
     </a:defPPr>
-    <a:lvl1pPr lvl="0" marR="0" rtl="0" algn="l">
+    <a:lvl1pPr marR="0" lvl="0" algn="l" rtl="0">
       <a:lnSpc>
         <a:spcPct val="100000"/>
       </a:lnSpc>
@@ -67,7 +67,7 @@
         <a:srgbClr val="000000"/>
       </a:buClr>
       <a:buFont typeface="Arial"/>
-      <a:defRPr b="0" i="0" spc="0" sz="1400" u="none" cap="none" strike="noStrike">
+      <a:defRPr sz="1400" b="0" i="0" u="none" strike="noStrike" cap="none" spc="0">
         <a:solidFill>
           <a:srgbClr val="000000"/>
         </a:solidFill>
@@ -77,7 +77,7 @@
         <a:sym typeface="Arial"/>
       </a:defRPr>
     </a:lvl1pPr>
-    <a:lvl2pPr lvl="1" marR="0" rtl="0" algn="l">
+    <a:lvl2pPr marR="0" lvl="1" algn="l" rtl="0">
       <a:lnSpc>
         <a:spcPct val="100000"/>
       </a:lnSpc>
@@ -91,7 +91,7 @@
         <a:srgbClr val="000000"/>
       </a:buClr>
       <a:buFont typeface="Arial"/>
-      <a:defRPr b="0" i="0" spc="0" sz="1400" u="none" cap="none" strike="noStrike">
+      <a:defRPr sz="1400" b="0" i="0" u="none" strike="noStrike" cap="none" spc="0">
         <a:solidFill>
           <a:srgbClr val="000000"/>
         </a:solidFill>
@@ -101,7 +101,7 @@
         <a:sym typeface="Arial"/>
       </a:defRPr>
     </a:lvl2pPr>
-    <a:lvl3pPr lvl="2" marR="0" rtl="0" algn="l">
+    <a:lvl3pPr marR="0" lvl="2" algn="l" rtl="0">
       <a:lnSpc>
         <a:spcPct val="100000"/>
       </a:lnSpc>
@@ -115,7 +115,7 @@
         <a:srgbClr val="000000"/>
       </a:buClr>
       <a:buFont typeface="Arial"/>
-      <a:defRPr b="0" i="0" spc="0" sz="1400" u="none" cap="none" strike="noStrike">
+      <a:defRPr sz="1400" b="0" i="0" u="none" strike="noStrike" cap="none" spc="0">
         <a:solidFill>
           <a:srgbClr val="000000"/>
         </a:solidFill>
@@ -125,7 +125,7 @@
         <a:sym typeface="Arial"/>
       </a:defRPr>
     </a:lvl3pPr>
-    <a:lvl4pPr lvl="3" marR="0" rtl="0" algn="l">
+    <a:lvl4pPr marR="0" lvl="3" algn="l" rtl="0">
       <a:lnSpc>
         <a:spcPct val="100000"/>
       </a:lnSpc>
@@ -139,7 +139,7 @@
         <a:srgbClr val="000000"/>
       </a:buClr>
       <a:buFont typeface="Arial"/>
-      <a:defRPr b="0" i="0" spc="0" sz="1400" u="none" cap="none" strike="noStrike">
+      <a:defRPr sz="1400" b="0" i="0" u="none" strike="noStrike" cap="none" spc="0">
         <a:solidFill>
           <a:srgbClr val="000000"/>
         </a:solidFill>
@@ -149,7 +149,7 @@
         <a:sym typeface="Arial"/>
       </a:defRPr>
     </a:lvl4pPr>
-    <a:lvl5pPr lvl="4" marR="0" rtl="0" algn="l">
+    <a:lvl5pPr marR="0" lvl="4" algn="l" rtl="0">
       <a:lnSpc>
         <a:spcPct val="100000"/>
       </a:lnSpc>
@@ -163,7 +163,7 @@
         <a:srgbClr val="000000"/>
       </a:buClr>
       <a:buFont typeface="Arial"/>
-      <a:defRPr b="0" i="0" spc="0" sz="1400" u="none" cap="none" strike="noStrike">
+      <a:defRPr sz="1400" b="0" i="0" u="none" strike="noStrike" cap="none" spc="0">
         <a:solidFill>
           <a:srgbClr val="000000"/>
         </a:solidFill>
@@ -173,7 +173,7 @@
         <a:sym typeface="Arial"/>
       </a:defRPr>
     </a:lvl5pPr>
-    <a:lvl6pPr lvl="5" marR="0" rtl="0" algn="l">
+    <a:lvl6pPr marR="0" lvl="5" algn="l" rtl="0">
       <a:lnSpc>
         <a:spcPct val="100000"/>
       </a:lnSpc>
@@ -187,7 +187,7 @@
         <a:srgbClr val="000000"/>
       </a:buClr>
       <a:buFont typeface="Arial"/>
-      <a:defRPr b="0" i="0" spc="0" sz="1400" u="none" cap="none" strike="noStrike">
+      <a:defRPr sz="1400" b="0" i="0" u="none" strike="noStrike" cap="none" spc="0">
         <a:solidFill>
           <a:srgbClr val="000000"/>
         </a:solidFill>
@@ -197,7 +197,7 @@
         <a:sym typeface="Arial"/>
       </a:defRPr>
     </a:lvl6pPr>
-    <a:lvl7pPr lvl="6" marR="0" rtl="0" algn="l">
+    <a:lvl7pPr marR="0" lvl="6" algn="l" rtl="0">
       <a:lnSpc>
         <a:spcPct val="100000"/>
       </a:lnSpc>
@@ -211,7 +211,7 @@
         <a:srgbClr val="000000"/>
       </a:buClr>
       <a:buFont typeface="Arial"/>
-      <a:defRPr b="0" i="0" spc="0" sz="1400" u="none" cap="none" strike="noStrike">
+      <a:defRPr sz="1400" b="0" i="0" u="none" strike="noStrike" cap="none" spc="0">
         <a:solidFill>
           <a:srgbClr val="000000"/>
         </a:solidFill>
@@ -221,7 +221,7 @@
         <a:sym typeface="Arial"/>
       </a:defRPr>
     </a:lvl7pPr>
-    <a:lvl8pPr lvl="7" marR="0" rtl="0" algn="l">
+    <a:lvl8pPr marR="0" lvl="7" algn="l" rtl="0">
       <a:lnSpc>
         <a:spcPct val="100000"/>
       </a:lnSpc>
@@ -235,7 +235,7 @@
         <a:srgbClr val="000000"/>
       </a:buClr>
       <a:buFont typeface="Arial"/>
-      <a:defRPr b="0" i="0" spc="0" sz="1400" u="none" cap="none" strike="noStrike">
+      <a:defRPr sz="1400" b="0" i="0" u="none" strike="noStrike" cap="none" spc="0">
         <a:solidFill>
           <a:srgbClr val="000000"/>
         </a:solidFill>
@@ -245,7 +245,7 @@
         <a:sym typeface="Arial"/>
       </a:defRPr>
     </a:lvl8pPr>
-    <a:lvl9pPr lvl="8" marR="0" rtl="0" algn="l">
+    <a:lvl9pPr marR="0" lvl="8" algn="l" rtl="0">
       <a:lnSpc>
         <a:spcPct val="100000"/>
       </a:lnSpc>
@@ -259,7 +259,7 @@
         <a:srgbClr val="000000"/>
       </a:buClr>
       <a:buFont typeface="Arial"/>
-      <a:defRPr b="0" i="0" spc="0" sz="1400" u="none" cap="none" strike="noStrike">
+      <a:defRPr sz="1400" b="0" i="0" u="none" strike="noStrike" cap="none" spc="0">
         <a:solidFill>
           <a:srgbClr val="000000"/>
         </a:solidFill>
@@ -274,11 +274,16 @@
 </file>
 
 <file path=ppt/notesMasters/notesMaster1.xml><?xml version="1.0" encoding="utf-8"?>
-<p:notesMaster xmlns:a="http://schemas.openxmlformats.org/drawingml/2006/main" xmlns:r="http://schemas.openxmlformats.org/officeDocument/2006/relationships" xmlns:mc="http://schemas.openxmlformats.org/markup-compatibility/2006" xmlns:mv="urn:schemas-microsoft-com:mac:vml" xmlns:p="http://schemas.openxmlformats.org/presentationml/2006/main" xmlns:c="http://schemas.openxmlformats.org/drawingml/2006/chart" xmlns:dgm="http://schemas.openxmlformats.org/drawingml/2006/diagram" xmlns:o="urn:schemas-microsoft-com:office:office" xmlns:v="urn:schemas-microsoft-com:vml" xmlns:pvml="urn:schemas-microsoft-com:office:powerpoint" xmlns:com="http://schemas.openxmlformats.org/drawingml/2006/compatibility" xmlns:p14="http://schemas.microsoft.com/office/powerpoint/2010/main" xmlns:p15="http://schemas.microsoft.com/office/powerpoint/2012/main" xmlns:ahyp="http://schemas.microsoft.com/office/drawing/2018/hyperlinkcolor">
+<p:notesMaster xmlns:a="http://schemas.openxmlformats.org/drawingml/2006/main" xmlns:r="http://schemas.openxmlformats.org/officeDocument/2006/relationships" xmlns:p="http://schemas.openxmlformats.org/presentationml/2006/main">
   <p:cSld>
+    <p:bg>
+      <p:bgRef idx="1001">
+        <a:schemeClr val="bg1"/>
+      </p:bgRef>
+    </p:bg>
     <p:spTree>
       <p:nvGrpSpPr>
-        <p:cNvPr id="2" name="Shape 2"/>
+        <p:cNvPr id="1" name="Shape 2"/>
         <p:cNvGrpSpPr/>
         <p:nvPr/>
       </p:nvGrpSpPr>
@@ -293,9 +298,11 @@
       <p:sp>
         <p:nvSpPr>
           <p:cNvPr id="3" name="Google Shape;3;n"/>
-          <p:cNvSpPr/>
+          <p:cNvSpPr>
+            <a:spLocks noGrp="1" noRot="1" noChangeAspect="1"/>
+          </p:cNvSpPr>
           <p:nvPr>
-            <p:ph idx="2" type="sldImg"/>
+            <p:ph type="sldImg" idx="2"/>
           </p:nvPr>
         </p:nvSpPr>
         <p:spPr>
@@ -304,9 +311,13 @@
             <a:ext cx="6096075" cy="3429000"/>
           </a:xfrm>
           <a:custGeom>
-            <a:rect b="b" l="l" r="r" t="t"/>
+            <a:avLst/>
+            <a:gdLst/>
+            <a:ahLst/>
+            <a:cxnLst/>
+            <a:rect l="l" t="t" r="r" b="b"/>
             <a:pathLst>
-              <a:path extrusionOk="0" h="120000" w="120000">
+              <a:path w="120000" h="120000" extrusionOk="0">
                 <a:moveTo>
                   <a:pt x="0" y="0"/>
                 </a:moveTo>
@@ -324,23 +335,25 @@
             </a:pathLst>
           </a:custGeom>
           <a:noFill/>
-          <a:ln cap="flat" cmpd="sng" w="9525">
+          <a:ln w="9525" cap="flat" cmpd="sng">
             <a:solidFill>
               <a:srgbClr val="000000"/>
             </a:solidFill>
             <a:prstDash val="solid"/>
             <a:round/>
-            <a:headEnd len="sm" w="sm" type="none"/>
-            <a:tailEnd len="sm" w="sm" type="none"/>
+            <a:headEnd type="none" w="sm" len="sm"/>
+            <a:tailEnd type="none" w="sm" len="sm"/>
           </a:ln>
         </p:spPr>
       </p:sp>
       <p:sp>
         <p:nvSpPr>
           <p:cNvPr id="4" name="Google Shape;4;n"/>
-          <p:cNvSpPr txBox="1"/>
+          <p:cNvSpPr txBox="1">
+            <a:spLocks noGrp="1"/>
+          </p:cNvSpPr>
           <p:nvPr>
-            <p:ph idx="1" type="body"/>
+            <p:ph type="body" idx="1"/>
           </p:nvPr>
         </p:nvSpPr>
         <p:spPr>
@@ -357,11 +370,11 @@
           </a:ln>
         </p:spPr>
         <p:txBody>
-          <a:bodyPr anchorCtr="0" anchor="t" bIns="91425" lIns="91425" spcFirstLastPara="1" rIns="91425" wrap="square" tIns="91425">
+          <a:bodyPr spcFirstLastPara="1" wrap="square" lIns="91425" tIns="91425" rIns="91425" bIns="91425" anchor="t" anchorCtr="0">
             <a:noAutofit/>
           </a:bodyPr>
           <a:lstStyle>
-            <a:lvl1pPr indent="-298450" lvl="0" marL="457200">
+            <a:lvl1pPr marL="457200" lvl="0" indent="-298450">
               <a:spcBef>
                 <a:spcPts val="0"/>
               </a:spcBef>
@@ -372,7 +385,7 @@
               <a:buChar char="●"/>
               <a:defRPr sz="1100"/>
             </a:lvl1pPr>
-            <a:lvl2pPr indent="-298450" lvl="1" marL="914400">
+            <a:lvl2pPr marL="914400" lvl="1" indent="-298450">
               <a:spcBef>
                 <a:spcPts val="0"/>
               </a:spcBef>
@@ -383,7 +396,7 @@
               <a:buChar char="○"/>
               <a:defRPr sz="1100"/>
             </a:lvl2pPr>
-            <a:lvl3pPr indent="-298450" lvl="2" marL="1371600">
+            <a:lvl3pPr marL="1371600" lvl="2" indent="-298450">
               <a:spcBef>
                 <a:spcPts val="0"/>
               </a:spcBef>
@@ -394,7 +407,7 @@
               <a:buChar char="■"/>
               <a:defRPr sz="1100"/>
             </a:lvl3pPr>
-            <a:lvl4pPr indent="-298450" lvl="3" marL="1828800">
+            <a:lvl4pPr marL="1828800" lvl="3" indent="-298450">
               <a:spcBef>
                 <a:spcPts val="0"/>
               </a:spcBef>
@@ -405,7 +418,7 @@
               <a:buChar char="●"/>
               <a:defRPr sz="1100"/>
             </a:lvl4pPr>
-            <a:lvl5pPr indent="-298450" lvl="4" marL="2286000">
+            <a:lvl5pPr marL="2286000" lvl="4" indent="-298450">
               <a:spcBef>
                 <a:spcPts val="0"/>
               </a:spcBef>
@@ -416,7 +429,7 @@
               <a:buChar char="○"/>
               <a:defRPr sz="1100"/>
             </a:lvl5pPr>
-            <a:lvl6pPr indent="-298450" lvl="5" marL="2743200">
+            <a:lvl6pPr marL="2743200" lvl="5" indent="-298450">
               <a:spcBef>
                 <a:spcPts val="0"/>
               </a:spcBef>
@@ -427,7 +440,7 @@
               <a:buChar char="■"/>
               <a:defRPr sz="1100"/>
             </a:lvl6pPr>
-            <a:lvl7pPr indent="-298450" lvl="6" marL="3200400">
+            <a:lvl7pPr marL="3200400" lvl="6" indent="-298450">
               <a:spcBef>
                 <a:spcPts val="0"/>
               </a:spcBef>
@@ -438,7 +451,7 @@
               <a:buChar char="●"/>
               <a:defRPr sz="1100"/>
             </a:lvl7pPr>
-            <a:lvl8pPr indent="-298450" lvl="7" marL="3657600">
+            <a:lvl8pPr marL="3657600" lvl="7" indent="-298450">
               <a:spcBef>
                 <a:spcPts val="0"/>
               </a:spcBef>
@@ -449,7 +462,7 @@
               <a:buChar char="○"/>
               <a:defRPr sz="1100"/>
             </a:lvl8pPr>
-            <a:lvl9pPr indent="-298450" lvl="8" marL="4114800">
+            <a:lvl9pPr marL="4114800" lvl="8" indent="-298450">
               <a:spcBef>
                 <a:spcPts val="0"/>
               </a:spcBef>
@@ -461,14 +474,16 @@
               <a:defRPr sz="1100"/>
             </a:lvl9pPr>
           </a:lstStyle>
-          <a:p/>
+          <a:p>
+            <a:endParaRPr/>
+          </a:p>
         </p:txBody>
       </p:sp>
     </p:spTree>
   </p:cSld>
-  <p:clrMap accent1="accent1" accent2="accent2" accent3="accent3" accent4="accent4" accent5="accent5" accent6="accent6" bg1="lt1" bg2="dk2" tx1="dk1" tx2="lt2" folHlink="folHlink" hlink="hlink"/>
+  <p:clrMap bg1="lt1" tx1="dk1" bg2="dk2" tx2="lt2" accent1="accent1" accent2="accent2" accent3="accent3" accent4="accent4" accent5="accent5" accent6="accent6" hlink="hlink" folHlink="folHlink"/>
   <p:notesStyle>
-    <a:defPPr lvl="0" marR="0" rtl="0" algn="l">
+    <a:defPPr marR="0" lvl="0" algn="l" rtl="0">
       <a:lnSpc>
         <a:spcPct val="100000"/>
       </a:lnSpc>
@@ -479,7 +494,7 @@
         <a:spcPts val="0"/>
       </a:spcAft>
     </a:defPPr>
-    <a:lvl1pPr lvl="0" marR="0" rtl="0" algn="l">
+    <a:lvl1pPr marR="0" lvl="0" algn="l" rtl="0">
       <a:lnSpc>
         <a:spcPct val="100000"/>
       </a:lnSpc>
@@ -493,7 +508,7 @@
         <a:srgbClr val="000000"/>
       </a:buClr>
       <a:buFont typeface="Arial"/>
-      <a:defRPr b="0" i="0" spc="0" sz="1400" u="none" cap="none" strike="noStrike">
+      <a:defRPr sz="1400" b="0" i="0" u="none" strike="noStrike" cap="none" spc="0">
         <a:solidFill>
           <a:srgbClr val="000000"/>
         </a:solidFill>
@@ -503,7 +518,7 @@
         <a:sym typeface="Arial"/>
       </a:defRPr>
     </a:lvl1pPr>
-    <a:lvl2pPr lvl="1" marR="0" rtl="0" algn="l">
+    <a:lvl2pPr marR="0" lvl="1" algn="l" rtl="0">
       <a:lnSpc>
         <a:spcPct val="100000"/>
       </a:lnSpc>
@@ -517,7 +532,7 @@
         <a:srgbClr val="000000"/>
       </a:buClr>
       <a:buFont typeface="Arial"/>
-      <a:defRPr b="0" i="0" spc="0" sz="1400" u="none" cap="none" strike="noStrike">
+      <a:defRPr sz="1400" b="0" i="0" u="none" strike="noStrike" cap="none" spc="0">
         <a:solidFill>
           <a:srgbClr val="000000"/>
         </a:solidFill>
@@ -527,7 +542,7 @@
         <a:sym typeface="Arial"/>
       </a:defRPr>
     </a:lvl2pPr>
-    <a:lvl3pPr lvl="2" marR="0" rtl="0" algn="l">
+    <a:lvl3pPr marR="0" lvl="2" algn="l" rtl="0">
       <a:lnSpc>
         <a:spcPct val="100000"/>
       </a:lnSpc>
@@ -541,7 +556,7 @@
         <a:srgbClr val="000000"/>
       </a:buClr>
       <a:buFont typeface="Arial"/>
-      <a:defRPr b="0" i="0" spc="0" sz="1400" u="none" cap="none" strike="noStrike">
+      <a:defRPr sz="1400" b="0" i="0" u="none" strike="noStrike" cap="none" spc="0">
         <a:solidFill>
           <a:srgbClr val="000000"/>
         </a:solidFill>
@@ -551,7 +566,7 @@
         <a:sym typeface="Arial"/>
       </a:defRPr>
     </a:lvl3pPr>
-    <a:lvl4pPr lvl="3" marR="0" rtl="0" algn="l">
+    <a:lvl4pPr marR="0" lvl="3" algn="l" rtl="0">
       <a:lnSpc>
         <a:spcPct val="100000"/>
       </a:lnSpc>
@@ -565,7 +580,7 @@
         <a:srgbClr val="000000"/>
       </a:buClr>
       <a:buFont typeface="Arial"/>
-      <a:defRPr b="0" i="0" spc="0" sz="1400" u="none" cap="none" strike="noStrike">
+      <a:defRPr sz="1400" b="0" i="0" u="none" strike="noStrike" cap="none" spc="0">
         <a:solidFill>
           <a:srgbClr val="000000"/>
         </a:solidFill>
@@ -575,7 +590,7 @@
         <a:sym typeface="Arial"/>
       </a:defRPr>
     </a:lvl4pPr>
-    <a:lvl5pPr lvl="4" marR="0" rtl="0" algn="l">
+    <a:lvl5pPr marR="0" lvl="4" algn="l" rtl="0">
       <a:lnSpc>
         <a:spcPct val="100000"/>
       </a:lnSpc>
@@ -589,7 +604,7 @@
         <a:srgbClr val="000000"/>
       </a:buClr>
       <a:buFont typeface="Arial"/>
-      <a:defRPr b="0" i="0" spc="0" sz="1400" u="none" cap="none" strike="noStrike">
+      <a:defRPr sz="1400" b="0" i="0" u="none" strike="noStrike" cap="none" spc="0">
         <a:solidFill>
           <a:srgbClr val="000000"/>
         </a:solidFill>
@@ -599,7 +614,7 @@
         <a:sym typeface="Arial"/>
       </a:defRPr>
     </a:lvl5pPr>
-    <a:lvl6pPr lvl="5" marR="0" rtl="0" algn="l">
+    <a:lvl6pPr marR="0" lvl="5" algn="l" rtl="0">
       <a:lnSpc>
         <a:spcPct val="100000"/>
       </a:lnSpc>
@@ -613,7 +628,7 @@
         <a:srgbClr val="000000"/>
       </a:buClr>
       <a:buFont typeface="Arial"/>
-      <a:defRPr b="0" i="0" spc="0" sz="1400" u="none" cap="none" strike="noStrike">
+      <a:defRPr sz="1400" b="0" i="0" u="none" strike="noStrike" cap="none" spc="0">
         <a:solidFill>
           <a:srgbClr val="000000"/>
         </a:solidFill>
@@ -623,7 +638,7 @@
         <a:sym typeface="Arial"/>
       </a:defRPr>
     </a:lvl6pPr>
-    <a:lvl7pPr lvl="6" marR="0" rtl="0" algn="l">
+    <a:lvl7pPr marR="0" lvl="6" algn="l" rtl="0">
       <a:lnSpc>
         <a:spcPct val="100000"/>
       </a:lnSpc>
@@ -637,7 +652,7 @@
         <a:srgbClr val="000000"/>
       </a:buClr>
       <a:buFont typeface="Arial"/>
-      <a:defRPr b="0" i="0" spc="0" sz="1400" u="none" cap="none" strike="noStrike">
+      <a:defRPr sz="1400" b="0" i="0" u="none" strike="noStrike" cap="none" spc="0">
         <a:solidFill>
           <a:srgbClr val="000000"/>
         </a:solidFill>
@@ -647,7 +662,7 @@
         <a:sym typeface="Arial"/>
       </a:defRPr>
     </a:lvl7pPr>
-    <a:lvl8pPr lvl="7" marR="0" rtl="0" algn="l">
+    <a:lvl8pPr marR="0" lvl="7" algn="l" rtl="0">
       <a:lnSpc>
         <a:spcPct val="100000"/>
       </a:lnSpc>
@@ -661,7 +676,7 @@
         <a:srgbClr val="000000"/>
       </a:buClr>
       <a:buFont typeface="Arial"/>
-      <a:defRPr b="0" i="0" spc="0" sz="1400" u="none" cap="none" strike="noStrike">
+      <a:defRPr sz="1400" b="0" i="0" u="none" strike="noStrike" cap="none" spc="0">
         <a:solidFill>
           <a:srgbClr val="000000"/>
         </a:solidFill>
@@ -671,7 +686,7 @@
         <a:sym typeface="Arial"/>
       </a:defRPr>
     </a:lvl8pPr>
-    <a:lvl9pPr lvl="8" marR="0" rtl="0" algn="l">
+    <a:lvl9pPr marR="0" lvl="8" algn="l" rtl="0">
       <a:lnSpc>
         <a:spcPct val="100000"/>
       </a:lnSpc>
@@ -685,7 +700,7 @@
         <a:srgbClr val="000000"/>
       </a:buClr>
       <a:buFont typeface="Arial"/>
-      <a:defRPr b="0" i="0" spc="0" sz="1400" u="none" cap="none" strike="noStrike">
+      <a:defRPr sz="1400" b="0" i="0" u="none" strike="noStrike" cap="none" spc="0">
         <a:solidFill>
           <a:srgbClr val="000000"/>
         </a:solidFill>
@@ -700,11 +715,11 @@
 </file>
 
 <file path=ppt/notesSlides/notesSlide1.xml><?xml version="1.0" encoding="utf-8"?>
-<p:notes xmlns:a="http://schemas.openxmlformats.org/drawingml/2006/main" xmlns:r="http://schemas.openxmlformats.org/officeDocument/2006/relationships" xmlns:mc="http://schemas.openxmlformats.org/markup-compatibility/2006" xmlns:mv="urn:schemas-microsoft-com:mac:vml" xmlns:p="http://schemas.openxmlformats.org/presentationml/2006/main" xmlns:c="http://schemas.openxmlformats.org/drawingml/2006/chart" xmlns:dgm="http://schemas.openxmlformats.org/drawingml/2006/diagram" xmlns:o="urn:schemas-microsoft-com:office:office" xmlns:v="urn:schemas-microsoft-com:vml" xmlns:pvml="urn:schemas-microsoft-com:office:powerpoint" xmlns:com="http://schemas.openxmlformats.org/drawingml/2006/compatibility" xmlns:p14="http://schemas.microsoft.com/office/powerpoint/2010/main" xmlns:p15="http://schemas.microsoft.com/office/powerpoint/2012/main" xmlns:ahyp="http://schemas.microsoft.com/office/drawing/2018/hyperlinkcolor" showMasterPhAnim="0" showMasterSp="0">
+<p:notes xmlns:a="http://schemas.openxmlformats.org/drawingml/2006/main" xmlns:r="http://schemas.openxmlformats.org/officeDocument/2006/relationships" xmlns:p="http://schemas.openxmlformats.org/presentationml/2006/main" showMasterSp="0" showMasterPhAnim="0">
   <p:cSld>
     <p:spTree>
       <p:nvGrpSpPr>
-        <p:cNvPr id="50" name="Shape 50"/>
+        <p:cNvPr id="1" name="Shape 50"/>
         <p:cNvGrpSpPr/>
         <p:nvPr/>
       </p:nvGrpSpPr>
@@ -719,20 +734,26 @@
       <p:sp>
         <p:nvSpPr>
           <p:cNvPr id="51" name="Google Shape;51;p:notes"/>
-          <p:cNvSpPr/>
+          <p:cNvSpPr>
+            <a:spLocks noGrp="1" noRot="1" noChangeAspect="1"/>
+          </p:cNvSpPr>
           <p:nvPr>
-            <p:ph idx="2" type="sldImg"/>
+            <p:ph type="sldImg" idx="2"/>
           </p:nvPr>
         </p:nvSpPr>
         <p:spPr>
           <a:xfrm>
-            <a:off x="381300" y="685800"/>
-            <a:ext cx="6096075" cy="3429000"/>
+            <a:off x="381000" y="685800"/>
+            <a:ext cx="6096000" cy="3429000"/>
           </a:xfrm>
           <a:custGeom>
-            <a:rect b="b" l="l" r="r" t="t"/>
+            <a:avLst/>
+            <a:gdLst/>
+            <a:ahLst/>
+            <a:cxnLst/>
+            <a:rect l="l" t="t" r="r" b="b"/>
             <a:pathLst>
-              <a:path extrusionOk="0" h="120000" w="120000">
+              <a:path w="120000" h="120000" extrusionOk="0">
                 <a:moveTo>
                   <a:pt x="0" y="0"/>
                 </a:moveTo>
@@ -754,9 +775,11 @@
       <p:sp>
         <p:nvSpPr>
           <p:cNvPr id="52" name="Google Shape;52;p:notes"/>
-          <p:cNvSpPr txBox="1"/>
+          <p:cNvSpPr txBox="1">
+            <a:spLocks noGrp="1"/>
+          </p:cNvSpPr>
           <p:nvPr>
-            <p:ph idx="1" type="body"/>
+            <p:ph type="body" idx="1"/>
           </p:nvPr>
         </p:nvSpPr>
         <p:spPr>
@@ -769,12 +792,12 @@
           </a:prstGeom>
         </p:spPr>
         <p:txBody>
-          <a:bodyPr anchorCtr="0" anchor="t" bIns="91425" lIns="91425" spcFirstLastPara="1" rIns="91425" wrap="square" tIns="91425">
+          <a:bodyPr spcFirstLastPara="1" wrap="square" lIns="91425" tIns="91425" rIns="91425" bIns="91425" anchor="t" anchorCtr="0">
             <a:noAutofit/>
           </a:bodyPr>
           <a:lstStyle/>
           <a:p>
-            <a:pPr indent="0" lvl="0" marL="0" rtl="0" algn="l">
+            <a:pPr marL="0" lvl="0" indent="0" algn="l" rtl="0">
               <a:spcBef>
                 <a:spcPts val="0"/>
               </a:spcBef>
@@ -783,9 +806,6 @@
               </a:spcAft>
               <a:buNone/>
             </a:pPr>
-            <a:r>
-              <a:t/>
-            </a:r>
             <a:endParaRPr/>
           </a:p>
         </p:txBody>
@@ -799,11 +819,11 @@
 </file>
 
 <file path=ppt/notesSlides/notesSlide2.xml><?xml version="1.0" encoding="utf-8"?>
-<p:notes xmlns:a="http://schemas.openxmlformats.org/drawingml/2006/main" xmlns:r="http://schemas.openxmlformats.org/officeDocument/2006/relationships" xmlns:mc="http://schemas.openxmlformats.org/markup-compatibility/2006" xmlns:mv="urn:schemas-microsoft-com:mac:vml" xmlns:p="http://schemas.openxmlformats.org/presentationml/2006/main" xmlns:c="http://schemas.openxmlformats.org/drawingml/2006/chart" xmlns:dgm="http://schemas.openxmlformats.org/drawingml/2006/diagram" xmlns:o="urn:schemas-microsoft-com:office:office" xmlns:v="urn:schemas-microsoft-com:vml" xmlns:pvml="urn:schemas-microsoft-com:office:powerpoint" xmlns:com="http://schemas.openxmlformats.org/drawingml/2006/compatibility" xmlns:p14="http://schemas.microsoft.com/office/powerpoint/2010/main" xmlns:p15="http://schemas.microsoft.com/office/powerpoint/2012/main" xmlns:ahyp="http://schemas.microsoft.com/office/drawing/2018/hyperlinkcolor" showMasterPhAnim="0" showMasterSp="0">
+<p:notes xmlns:a="http://schemas.openxmlformats.org/drawingml/2006/main" xmlns:r="http://schemas.openxmlformats.org/officeDocument/2006/relationships" xmlns:p="http://schemas.openxmlformats.org/presentationml/2006/main" showMasterSp="0" showMasterPhAnim="0">
   <p:cSld>
     <p:spTree>
       <p:nvGrpSpPr>
-        <p:cNvPr id="55" name="Shape 55"/>
+        <p:cNvPr id="1" name="Shape 55"/>
         <p:cNvGrpSpPr/>
         <p:nvPr/>
       </p:nvGrpSpPr>
@@ -818,9 +838,11 @@
       <p:sp>
         <p:nvSpPr>
           <p:cNvPr id="56" name="Google Shape;56;g2203ca5f64b_0_0:notes"/>
-          <p:cNvSpPr/>
+          <p:cNvSpPr>
+            <a:spLocks noGrp="1" noRot="1" noChangeAspect="1"/>
+          </p:cNvSpPr>
           <p:nvPr>
-            <p:ph idx="2" type="sldImg"/>
+            <p:ph type="sldImg" idx="2"/>
           </p:nvPr>
         </p:nvSpPr>
         <p:spPr>
@@ -829,9 +851,13 @@
             <a:ext cx="6096000" cy="3429000"/>
           </a:xfrm>
           <a:custGeom>
-            <a:rect b="b" l="l" r="r" t="t"/>
+            <a:avLst/>
+            <a:gdLst/>
+            <a:ahLst/>
+            <a:cxnLst/>
+            <a:rect l="l" t="t" r="r" b="b"/>
             <a:pathLst>
-              <a:path extrusionOk="0" h="120000" w="120000">
+              <a:path w="120000" h="120000" extrusionOk="0">
                 <a:moveTo>
                   <a:pt x="0" y="0"/>
                 </a:moveTo>
@@ -853,9 +879,11 @@
       <p:sp>
         <p:nvSpPr>
           <p:cNvPr id="57" name="Google Shape;57;g2203ca5f64b_0_0:notes"/>
-          <p:cNvSpPr txBox="1"/>
+          <p:cNvSpPr txBox="1">
+            <a:spLocks noGrp="1"/>
+          </p:cNvSpPr>
           <p:nvPr>
-            <p:ph idx="1" type="body"/>
+            <p:ph type="body" idx="1"/>
           </p:nvPr>
         </p:nvSpPr>
         <p:spPr>
@@ -868,12 +896,12 @@
           </a:prstGeom>
         </p:spPr>
         <p:txBody>
-          <a:bodyPr anchorCtr="0" anchor="t" bIns="91425" lIns="91425" spcFirstLastPara="1" rIns="91425" wrap="square" tIns="91425">
+          <a:bodyPr spcFirstLastPara="1" wrap="square" lIns="91425" tIns="91425" rIns="91425" bIns="91425" anchor="t" anchorCtr="0">
             <a:noAutofit/>
           </a:bodyPr>
           <a:lstStyle/>
           <a:p>
-            <a:pPr indent="0" lvl="0" marL="0" rtl="0" algn="l">
+            <a:pPr marL="0" lvl="0" indent="0" algn="l" rtl="0">
               <a:spcBef>
                 <a:spcPts val="0"/>
               </a:spcBef>
@@ -882,9 +910,6 @@
               </a:spcAft>
               <a:buNone/>
             </a:pPr>
-            <a:r>
-              <a:t/>
-            </a:r>
             <a:endParaRPr/>
           </a:p>
         </p:txBody>
@@ -898,11 +923,11 @@
 </file>
 
 <file path=ppt/notesSlides/notesSlide3.xml><?xml version="1.0" encoding="utf-8"?>
-<p:notes xmlns:a="http://schemas.openxmlformats.org/drawingml/2006/main" xmlns:r="http://schemas.openxmlformats.org/officeDocument/2006/relationships" xmlns:mc="http://schemas.openxmlformats.org/markup-compatibility/2006" xmlns:mv="urn:schemas-microsoft-com:mac:vml" xmlns:p="http://schemas.openxmlformats.org/presentationml/2006/main" xmlns:c="http://schemas.openxmlformats.org/drawingml/2006/chart" xmlns:dgm="http://schemas.openxmlformats.org/drawingml/2006/diagram" xmlns:o="urn:schemas-microsoft-com:office:office" xmlns:v="urn:schemas-microsoft-com:vml" xmlns:pvml="urn:schemas-microsoft-com:office:powerpoint" xmlns:com="http://schemas.openxmlformats.org/drawingml/2006/compatibility" xmlns:p14="http://schemas.microsoft.com/office/powerpoint/2010/main" xmlns:p15="http://schemas.microsoft.com/office/powerpoint/2012/main" xmlns:ahyp="http://schemas.microsoft.com/office/drawing/2018/hyperlinkcolor" showMasterPhAnim="0" showMasterSp="0">
+<p:notes xmlns:a="http://schemas.openxmlformats.org/drawingml/2006/main" xmlns:r="http://schemas.openxmlformats.org/officeDocument/2006/relationships" xmlns:p="http://schemas.openxmlformats.org/presentationml/2006/main" showMasterSp="0" showMasterPhAnim="0">
   <p:cSld>
     <p:spTree>
       <p:nvGrpSpPr>
-        <p:cNvPr id="59" name="Shape 59"/>
+        <p:cNvPr id="1" name="Shape 59"/>
         <p:cNvGrpSpPr/>
         <p:nvPr/>
       </p:nvGrpSpPr>
@@ -917,20 +942,26 @@
       <p:sp>
         <p:nvSpPr>
           <p:cNvPr id="60" name="Google Shape;60;g2203ca5f64b_0_3:notes"/>
-          <p:cNvSpPr/>
+          <p:cNvSpPr>
+            <a:spLocks noGrp="1" noRot="1" noChangeAspect="1"/>
+          </p:cNvSpPr>
           <p:nvPr>
-            <p:ph idx="2" type="sldImg"/>
+            <p:ph type="sldImg" idx="2"/>
           </p:nvPr>
         </p:nvSpPr>
         <p:spPr>
           <a:xfrm>
-            <a:off x="381300" y="685800"/>
+            <a:off x="381000" y="685800"/>
             <a:ext cx="6096000" cy="3429000"/>
           </a:xfrm>
           <a:custGeom>
-            <a:rect b="b" l="l" r="r" t="t"/>
+            <a:avLst/>
+            <a:gdLst/>
+            <a:ahLst/>
+            <a:cxnLst/>
+            <a:rect l="l" t="t" r="r" b="b"/>
             <a:pathLst>
-              <a:path extrusionOk="0" h="120000" w="120000">
+              <a:path w="120000" h="120000" extrusionOk="0">
                 <a:moveTo>
                   <a:pt x="0" y="0"/>
                 </a:moveTo>
@@ -952,9 +983,11 @@
       <p:sp>
         <p:nvSpPr>
           <p:cNvPr id="61" name="Google Shape;61;g2203ca5f64b_0_3:notes"/>
-          <p:cNvSpPr txBox="1"/>
+          <p:cNvSpPr txBox="1">
+            <a:spLocks noGrp="1"/>
+          </p:cNvSpPr>
           <p:nvPr>
-            <p:ph idx="1" type="body"/>
+            <p:ph type="body" idx="1"/>
           </p:nvPr>
         </p:nvSpPr>
         <p:spPr>
@@ -967,12 +1000,12 @@
           </a:prstGeom>
         </p:spPr>
         <p:txBody>
-          <a:bodyPr anchorCtr="0" anchor="t" bIns="91425" lIns="91425" spcFirstLastPara="1" rIns="91425" wrap="square" tIns="91425">
+          <a:bodyPr spcFirstLastPara="1" wrap="square" lIns="91425" tIns="91425" rIns="91425" bIns="91425" anchor="t" anchorCtr="0">
             <a:noAutofit/>
           </a:bodyPr>
           <a:lstStyle/>
           <a:p>
-            <a:pPr indent="0" lvl="0" marL="0" rtl="0" algn="l">
+            <a:pPr marL="0" lvl="0" indent="0" algn="l" rtl="0">
               <a:spcBef>
                 <a:spcPts val="0"/>
               </a:spcBef>
@@ -981,9 +1014,6 @@
               </a:spcAft>
               <a:buNone/>
             </a:pPr>
-            <a:r>
-              <a:t/>
-            </a:r>
             <a:endParaRPr/>
           </a:p>
         </p:txBody>
@@ -997,11 +1027,11 @@
 </file>
 
 <file path=ppt/notesSlides/notesSlide4.xml><?xml version="1.0" encoding="utf-8"?>
-<p:notes xmlns:a="http://schemas.openxmlformats.org/drawingml/2006/main" xmlns:r="http://schemas.openxmlformats.org/officeDocument/2006/relationships" xmlns:mc="http://schemas.openxmlformats.org/markup-compatibility/2006" xmlns:mv="urn:schemas-microsoft-com:mac:vml" xmlns:p="http://schemas.openxmlformats.org/presentationml/2006/main" xmlns:c="http://schemas.openxmlformats.org/drawingml/2006/chart" xmlns:dgm="http://schemas.openxmlformats.org/drawingml/2006/diagram" xmlns:o="urn:schemas-microsoft-com:office:office" xmlns:v="urn:schemas-microsoft-com:vml" xmlns:pvml="urn:schemas-microsoft-com:office:powerpoint" xmlns:com="http://schemas.openxmlformats.org/drawingml/2006/compatibility" xmlns:p14="http://schemas.microsoft.com/office/powerpoint/2010/main" xmlns:p15="http://schemas.microsoft.com/office/powerpoint/2012/main" xmlns:ahyp="http://schemas.microsoft.com/office/drawing/2018/hyperlinkcolor" showMasterPhAnim="0" showMasterSp="0">
+<p:notes xmlns:a="http://schemas.openxmlformats.org/drawingml/2006/main" xmlns:r="http://schemas.openxmlformats.org/officeDocument/2006/relationships" xmlns:p="http://schemas.openxmlformats.org/presentationml/2006/main" showMasterSp="0" showMasterPhAnim="0">
   <p:cSld>
     <p:spTree>
       <p:nvGrpSpPr>
-        <p:cNvPr id="65" name="Shape 65"/>
+        <p:cNvPr id="1" name="Shape 65"/>
         <p:cNvGrpSpPr/>
         <p:nvPr/>
       </p:nvGrpSpPr>
@@ -1016,20 +1046,26 @@
       <p:sp>
         <p:nvSpPr>
           <p:cNvPr id="66" name="Google Shape;66;g2203ca5f64b_0_6:notes"/>
-          <p:cNvSpPr/>
+          <p:cNvSpPr>
+            <a:spLocks noGrp="1" noRot="1" noChangeAspect="1"/>
+          </p:cNvSpPr>
           <p:nvPr>
-            <p:ph idx="2" type="sldImg"/>
+            <p:ph type="sldImg" idx="2"/>
           </p:nvPr>
         </p:nvSpPr>
         <p:spPr>
           <a:xfrm>
-            <a:off x="381300" y="685800"/>
+            <a:off x="381000" y="685800"/>
             <a:ext cx="6096000" cy="3429000"/>
           </a:xfrm>
           <a:custGeom>
-            <a:rect b="b" l="l" r="r" t="t"/>
+            <a:avLst/>
+            <a:gdLst/>
+            <a:ahLst/>
+            <a:cxnLst/>
+            <a:rect l="l" t="t" r="r" b="b"/>
             <a:pathLst>
-              <a:path extrusionOk="0" h="120000" w="120000">
+              <a:path w="120000" h="120000" extrusionOk="0">
                 <a:moveTo>
                   <a:pt x="0" y="0"/>
                 </a:moveTo>
@@ -1051,9 +1087,11 @@
       <p:sp>
         <p:nvSpPr>
           <p:cNvPr id="67" name="Google Shape;67;g2203ca5f64b_0_6:notes"/>
-          <p:cNvSpPr txBox="1"/>
+          <p:cNvSpPr txBox="1">
+            <a:spLocks noGrp="1"/>
+          </p:cNvSpPr>
           <p:nvPr>
-            <p:ph idx="1" type="body"/>
+            <p:ph type="body" idx="1"/>
           </p:nvPr>
         </p:nvSpPr>
         <p:spPr>
@@ -1066,12 +1104,12 @@
           </a:prstGeom>
         </p:spPr>
         <p:txBody>
-          <a:bodyPr anchorCtr="0" anchor="t" bIns="91425" lIns="91425" spcFirstLastPara="1" rIns="91425" wrap="square" tIns="91425">
+          <a:bodyPr spcFirstLastPara="1" wrap="square" lIns="91425" tIns="91425" rIns="91425" bIns="91425" anchor="t" anchorCtr="0">
             <a:noAutofit/>
           </a:bodyPr>
           <a:lstStyle/>
           <a:p>
-            <a:pPr indent="0" lvl="0" marL="0" rtl="0" algn="l">
+            <a:pPr marL="0" lvl="0" indent="0" algn="l" rtl="0">
               <a:spcBef>
                 <a:spcPts val="0"/>
               </a:spcBef>
@@ -1080,9 +1118,6 @@
               </a:spcAft>
               <a:buNone/>
             </a:pPr>
-            <a:r>
-              <a:t/>
-            </a:r>
             <a:endParaRPr/>
           </a:p>
         </p:txBody>
@@ -1096,11 +1131,11 @@
 </file>
 
 <file path=ppt/notesSlides/notesSlide5.xml><?xml version="1.0" encoding="utf-8"?>
-<p:notes xmlns:a="http://schemas.openxmlformats.org/drawingml/2006/main" xmlns:r="http://schemas.openxmlformats.org/officeDocument/2006/relationships" xmlns:mc="http://schemas.openxmlformats.org/markup-compatibility/2006" xmlns:mv="urn:schemas-microsoft-com:mac:vml" xmlns:p="http://schemas.openxmlformats.org/presentationml/2006/main" xmlns:c="http://schemas.openxmlformats.org/drawingml/2006/chart" xmlns:dgm="http://schemas.openxmlformats.org/drawingml/2006/diagram" xmlns:o="urn:schemas-microsoft-com:office:office" xmlns:v="urn:schemas-microsoft-com:vml" xmlns:pvml="urn:schemas-microsoft-com:office:powerpoint" xmlns:com="http://schemas.openxmlformats.org/drawingml/2006/compatibility" xmlns:p14="http://schemas.microsoft.com/office/powerpoint/2010/main" xmlns:p15="http://schemas.microsoft.com/office/powerpoint/2012/main" xmlns:ahyp="http://schemas.microsoft.com/office/drawing/2018/hyperlinkcolor" showMasterPhAnim="0" showMasterSp="0">
+<p:notes xmlns:a="http://schemas.openxmlformats.org/drawingml/2006/main" xmlns:r="http://schemas.openxmlformats.org/officeDocument/2006/relationships" xmlns:p="http://schemas.openxmlformats.org/presentationml/2006/main" showMasterSp="0" showMasterPhAnim="0">
   <p:cSld>
     <p:spTree>
       <p:nvGrpSpPr>
-        <p:cNvPr id="75" name="Shape 75"/>
+        <p:cNvPr id="1" name="Shape 75"/>
         <p:cNvGrpSpPr/>
         <p:nvPr/>
       </p:nvGrpSpPr>
@@ -1115,20 +1150,26 @@
       <p:sp>
         <p:nvSpPr>
           <p:cNvPr id="76" name="Google Shape;76;g2203ca5f64b_0_9:notes"/>
-          <p:cNvSpPr/>
+          <p:cNvSpPr>
+            <a:spLocks noGrp="1" noRot="1" noChangeAspect="1"/>
+          </p:cNvSpPr>
           <p:nvPr>
-            <p:ph idx="2" type="sldImg"/>
+            <p:ph type="sldImg" idx="2"/>
           </p:nvPr>
         </p:nvSpPr>
         <p:spPr>
           <a:xfrm>
-            <a:off x="381300" y="685800"/>
+            <a:off x="381000" y="685800"/>
             <a:ext cx="6096000" cy="3429000"/>
           </a:xfrm>
           <a:custGeom>
-            <a:rect b="b" l="l" r="r" t="t"/>
+            <a:avLst/>
+            <a:gdLst/>
+            <a:ahLst/>
+            <a:cxnLst/>
+            <a:rect l="l" t="t" r="r" b="b"/>
             <a:pathLst>
-              <a:path extrusionOk="0" h="120000" w="120000">
+              <a:path w="120000" h="120000" extrusionOk="0">
                 <a:moveTo>
                   <a:pt x="0" y="0"/>
                 </a:moveTo>
@@ -1150,9 +1191,11 @@
       <p:sp>
         <p:nvSpPr>
           <p:cNvPr id="77" name="Google Shape;77;g2203ca5f64b_0_9:notes"/>
-          <p:cNvSpPr txBox="1"/>
+          <p:cNvSpPr txBox="1">
+            <a:spLocks noGrp="1"/>
+          </p:cNvSpPr>
           <p:nvPr>
-            <p:ph idx="1" type="body"/>
+            <p:ph type="body" idx="1"/>
           </p:nvPr>
         </p:nvSpPr>
         <p:spPr>
@@ -1165,12 +1208,12 @@
           </a:prstGeom>
         </p:spPr>
         <p:txBody>
-          <a:bodyPr anchorCtr="0" anchor="t" bIns="91425" lIns="91425" spcFirstLastPara="1" rIns="91425" wrap="square" tIns="91425">
+          <a:bodyPr spcFirstLastPara="1" wrap="square" lIns="91425" tIns="91425" rIns="91425" bIns="91425" anchor="t" anchorCtr="0">
             <a:noAutofit/>
           </a:bodyPr>
           <a:lstStyle/>
           <a:p>
-            <a:pPr indent="0" lvl="0" marL="0" rtl="0" algn="l">
+            <a:pPr marL="0" lvl="0" indent="0" algn="l" rtl="0">
               <a:spcBef>
                 <a:spcPts val="0"/>
               </a:spcBef>
@@ -1179,9 +1222,6 @@
               </a:spcAft>
               <a:buNone/>
             </a:pPr>
-            <a:r>
-              <a:t/>
-            </a:r>
             <a:endParaRPr/>
           </a:p>
         </p:txBody>
@@ -1195,11 +1235,11 @@
 </file>
 
 <file path=ppt/notesSlides/notesSlide6.xml><?xml version="1.0" encoding="utf-8"?>
-<p:notes xmlns:a="http://schemas.openxmlformats.org/drawingml/2006/main" xmlns:r="http://schemas.openxmlformats.org/officeDocument/2006/relationships" xmlns:mc="http://schemas.openxmlformats.org/markup-compatibility/2006" xmlns:mv="urn:schemas-microsoft-com:mac:vml" xmlns:p="http://schemas.openxmlformats.org/presentationml/2006/main" xmlns:c="http://schemas.openxmlformats.org/drawingml/2006/chart" xmlns:dgm="http://schemas.openxmlformats.org/drawingml/2006/diagram" xmlns:o="urn:schemas-microsoft-com:office:office" xmlns:v="urn:schemas-microsoft-com:vml" xmlns:pvml="urn:schemas-microsoft-com:office:powerpoint" xmlns:com="http://schemas.openxmlformats.org/drawingml/2006/compatibility" xmlns:p14="http://schemas.microsoft.com/office/powerpoint/2010/main" xmlns:p15="http://schemas.microsoft.com/office/powerpoint/2012/main" xmlns:ahyp="http://schemas.microsoft.com/office/drawing/2018/hyperlinkcolor" showMasterPhAnim="0" showMasterSp="0">
+<p:notes xmlns:a="http://schemas.openxmlformats.org/drawingml/2006/main" xmlns:r="http://schemas.openxmlformats.org/officeDocument/2006/relationships" xmlns:p="http://schemas.openxmlformats.org/presentationml/2006/main" showMasterSp="0" showMasterPhAnim="0">
   <p:cSld>
     <p:spTree>
       <p:nvGrpSpPr>
-        <p:cNvPr id="81" name="Shape 81"/>
+        <p:cNvPr id="1" name="Shape 81"/>
         <p:cNvGrpSpPr/>
         <p:nvPr/>
       </p:nvGrpSpPr>
@@ -1214,20 +1254,26 @@
       <p:sp>
         <p:nvSpPr>
           <p:cNvPr id="82" name="Google Shape;82;g2203ca5f64b_0_12:notes"/>
-          <p:cNvSpPr/>
+          <p:cNvSpPr>
+            <a:spLocks noGrp="1" noRot="1" noChangeAspect="1"/>
+          </p:cNvSpPr>
           <p:nvPr>
-            <p:ph idx="2" type="sldImg"/>
+            <p:ph type="sldImg" idx="2"/>
           </p:nvPr>
         </p:nvSpPr>
         <p:spPr>
           <a:xfrm>
-            <a:off x="381300" y="685800"/>
+            <a:off x="381000" y="685800"/>
             <a:ext cx="6096000" cy="3429000"/>
           </a:xfrm>
           <a:custGeom>
-            <a:rect b="b" l="l" r="r" t="t"/>
+            <a:avLst/>
+            <a:gdLst/>
+            <a:ahLst/>
+            <a:cxnLst/>
+            <a:rect l="l" t="t" r="r" b="b"/>
             <a:pathLst>
-              <a:path extrusionOk="0" h="120000" w="120000">
+              <a:path w="120000" h="120000" extrusionOk="0">
                 <a:moveTo>
                   <a:pt x="0" y="0"/>
                 </a:moveTo>
@@ -1249,9 +1295,11 @@
       <p:sp>
         <p:nvSpPr>
           <p:cNvPr id="83" name="Google Shape;83;g2203ca5f64b_0_12:notes"/>
-          <p:cNvSpPr txBox="1"/>
+          <p:cNvSpPr txBox="1">
+            <a:spLocks noGrp="1"/>
+          </p:cNvSpPr>
           <p:nvPr>
-            <p:ph idx="1" type="body"/>
+            <p:ph type="body" idx="1"/>
           </p:nvPr>
         </p:nvSpPr>
         <p:spPr>
@@ -1264,12 +1312,12 @@
           </a:prstGeom>
         </p:spPr>
         <p:txBody>
-          <a:bodyPr anchorCtr="0" anchor="t" bIns="91425" lIns="91425" spcFirstLastPara="1" rIns="91425" wrap="square" tIns="91425">
+          <a:bodyPr spcFirstLastPara="1" wrap="square" lIns="91425" tIns="91425" rIns="91425" bIns="91425" anchor="t" anchorCtr="0">
             <a:noAutofit/>
           </a:bodyPr>
           <a:lstStyle/>
           <a:p>
-            <a:pPr indent="0" lvl="0" marL="0" rtl="0" algn="l">
+            <a:pPr marL="0" lvl="0" indent="0" algn="l" rtl="0">
               <a:spcBef>
                 <a:spcPts val="0"/>
               </a:spcBef>
@@ -1278,9 +1326,6 @@
               </a:spcAft>
               <a:buNone/>
             </a:pPr>
-            <a:r>
-              <a:t/>
-            </a:r>
             <a:endParaRPr/>
           </a:p>
         </p:txBody>
@@ -1294,11 +1339,11 @@
 </file>
 
 <file path=ppt/notesSlides/notesSlide7.xml><?xml version="1.0" encoding="utf-8"?>
-<p:notes xmlns:a="http://schemas.openxmlformats.org/drawingml/2006/main" xmlns:r="http://schemas.openxmlformats.org/officeDocument/2006/relationships" xmlns:mc="http://schemas.openxmlformats.org/markup-compatibility/2006" xmlns:mv="urn:schemas-microsoft-com:mac:vml" xmlns:p="http://schemas.openxmlformats.org/presentationml/2006/main" xmlns:c="http://schemas.openxmlformats.org/drawingml/2006/chart" xmlns:dgm="http://schemas.openxmlformats.org/drawingml/2006/diagram" xmlns:o="urn:schemas-microsoft-com:office:office" xmlns:v="urn:schemas-microsoft-com:vml" xmlns:pvml="urn:schemas-microsoft-com:office:powerpoint" xmlns:com="http://schemas.openxmlformats.org/drawingml/2006/compatibility" xmlns:p14="http://schemas.microsoft.com/office/powerpoint/2010/main" xmlns:p15="http://schemas.microsoft.com/office/powerpoint/2012/main" xmlns:ahyp="http://schemas.microsoft.com/office/drawing/2018/hyperlinkcolor" showMasterPhAnim="0" showMasterSp="0">
+<p:notes xmlns:a="http://schemas.openxmlformats.org/drawingml/2006/main" xmlns:r="http://schemas.openxmlformats.org/officeDocument/2006/relationships" xmlns:p="http://schemas.openxmlformats.org/presentationml/2006/main" showMasterSp="0" showMasterPhAnim="0">
   <p:cSld>
     <p:spTree>
       <p:nvGrpSpPr>
-        <p:cNvPr id="91" name="Shape 91"/>
+        <p:cNvPr id="1" name="Shape 91"/>
         <p:cNvGrpSpPr/>
         <p:nvPr/>
       </p:nvGrpSpPr>
@@ -1313,9 +1358,11 @@
       <p:sp>
         <p:nvSpPr>
           <p:cNvPr id="92" name="Google Shape;92;g2204020afc0_0_0:notes"/>
-          <p:cNvSpPr/>
+          <p:cNvSpPr>
+            <a:spLocks noGrp="1" noRot="1" noChangeAspect="1"/>
+          </p:cNvSpPr>
           <p:nvPr>
-            <p:ph idx="2" type="sldImg"/>
+            <p:ph type="sldImg" idx="2"/>
           </p:nvPr>
         </p:nvSpPr>
         <p:spPr>
@@ -1324,9 +1371,13 @@
             <a:ext cx="6096000" cy="3429000"/>
           </a:xfrm>
           <a:custGeom>
-            <a:rect b="b" l="l" r="r" t="t"/>
+            <a:avLst/>
+            <a:gdLst/>
+            <a:ahLst/>
+            <a:cxnLst/>
+            <a:rect l="l" t="t" r="r" b="b"/>
             <a:pathLst>
-              <a:path extrusionOk="0" h="120000" w="120000">
+              <a:path w="120000" h="120000" extrusionOk="0">
                 <a:moveTo>
                   <a:pt x="0" y="0"/>
                 </a:moveTo>
@@ -1348,9 +1399,11 @@
       <p:sp>
         <p:nvSpPr>
           <p:cNvPr id="93" name="Google Shape;93;g2204020afc0_0_0:notes"/>
-          <p:cNvSpPr txBox="1"/>
+          <p:cNvSpPr txBox="1">
+            <a:spLocks noGrp="1"/>
+          </p:cNvSpPr>
           <p:nvPr>
-            <p:ph idx="1" type="body"/>
+            <p:ph type="body" idx="1"/>
           </p:nvPr>
         </p:nvSpPr>
         <p:spPr>
@@ -1363,12 +1416,12 @@
           </a:prstGeom>
         </p:spPr>
         <p:txBody>
-          <a:bodyPr anchorCtr="0" anchor="t" bIns="91425" lIns="91425" spcFirstLastPara="1" rIns="91425" wrap="square" tIns="91425">
+          <a:bodyPr spcFirstLastPara="1" wrap="square" lIns="91425" tIns="91425" rIns="91425" bIns="91425" anchor="t" anchorCtr="0">
             <a:noAutofit/>
           </a:bodyPr>
           <a:lstStyle/>
           <a:p>
-            <a:pPr indent="0" lvl="0" marL="0" rtl="0" algn="l">
+            <a:pPr marL="0" lvl="0" indent="0" algn="l" rtl="0">
               <a:spcBef>
                 <a:spcPts val="0"/>
               </a:spcBef>
@@ -1377,9 +1430,6 @@
               </a:spcAft>
               <a:buNone/>
             </a:pPr>
-            <a:r>
-              <a:t/>
-            </a:r>
             <a:endParaRPr/>
           </a:p>
         </p:txBody>
@@ -1393,11 +1443,11 @@
 </file>
 
 <file path=ppt/slideLayouts/slideLayout1.xml><?xml version="1.0" encoding="utf-8"?>
-<p:sldLayout xmlns:a="http://schemas.openxmlformats.org/drawingml/2006/main" xmlns:r="http://schemas.openxmlformats.org/officeDocument/2006/relationships" xmlns:mc="http://schemas.openxmlformats.org/markup-compatibility/2006" xmlns:mv="urn:schemas-microsoft-com:mac:vml" xmlns:p="http://schemas.openxmlformats.org/presentationml/2006/main" xmlns:c="http://schemas.openxmlformats.org/drawingml/2006/chart" xmlns:dgm="http://schemas.openxmlformats.org/drawingml/2006/diagram" xmlns:o="urn:schemas-microsoft-com:office:office" xmlns:v="urn:schemas-microsoft-com:vml" xmlns:pvml="urn:schemas-microsoft-com:office:powerpoint" xmlns:com="http://schemas.openxmlformats.org/drawingml/2006/compatibility" xmlns:p14="http://schemas.microsoft.com/office/powerpoint/2010/main" xmlns:p15="http://schemas.microsoft.com/office/powerpoint/2012/main" xmlns:ahyp="http://schemas.microsoft.com/office/drawing/2018/hyperlinkcolor" matchingName="Title slide" type="title">
+<p:sldLayout xmlns:a="http://schemas.openxmlformats.org/drawingml/2006/main" xmlns:r="http://schemas.openxmlformats.org/officeDocument/2006/relationships" xmlns:p="http://schemas.openxmlformats.org/presentationml/2006/main" matchingName="Title slide" type="title">
   <p:cSld name="TITLE">
     <p:spTree>
       <p:nvGrpSpPr>
-        <p:cNvPr id="9" name="Shape 9"/>
+        <p:cNvPr id="1" name="Shape 9"/>
         <p:cNvGrpSpPr/>
         <p:nvPr/>
       </p:nvGrpSpPr>
@@ -1412,7 +1462,9 @@
       <p:sp>
         <p:nvSpPr>
           <p:cNvPr id="10" name="Google Shape;10;p2"/>
-          <p:cNvSpPr txBox="1"/>
+          <p:cNvSpPr txBox="1">
+            <a:spLocks noGrp="1"/>
+          </p:cNvSpPr>
           <p:nvPr>
             <p:ph type="ctrTitle"/>
           </p:nvPr>
@@ -1427,7 +1479,7 @@
           </a:prstGeom>
         </p:spPr>
         <p:txBody>
-          <a:bodyPr anchorCtr="0" anchor="b" bIns="91425" lIns="91425" spcFirstLastPara="1" rIns="91425" wrap="square" tIns="91425">
+          <a:bodyPr spcFirstLastPara="1" wrap="square" lIns="91425" tIns="91425" rIns="91425" bIns="91425" anchor="b" anchorCtr="0">
             <a:normAutofit/>
           </a:bodyPr>
           <a:lstStyle>
@@ -1531,15 +1583,19 @@
               <a:defRPr sz="5200"/>
             </a:lvl9pPr>
           </a:lstStyle>
-          <a:p/>
+          <a:p>
+            <a:endParaRPr/>
+          </a:p>
         </p:txBody>
       </p:sp>
       <p:sp>
         <p:nvSpPr>
           <p:cNvPr id="11" name="Google Shape;11;p2"/>
-          <p:cNvSpPr txBox="1"/>
+          <p:cNvSpPr txBox="1">
+            <a:spLocks noGrp="1"/>
+          </p:cNvSpPr>
           <p:nvPr>
-            <p:ph idx="1" type="subTitle"/>
+            <p:ph type="subTitle" idx="1"/>
           </p:nvPr>
         </p:nvSpPr>
         <p:spPr>
@@ -1552,7 +1608,7 @@
           </a:prstGeom>
         </p:spPr>
         <p:txBody>
-          <a:bodyPr anchorCtr="0" anchor="t" bIns="91425" lIns="91425" spcFirstLastPara="1" rIns="91425" wrap="square" tIns="91425">
+          <a:bodyPr spcFirstLastPara="1" wrap="square" lIns="91425" tIns="91425" rIns="91425" bIns="91425" anchor="t" anchorCtr="0">
             <a:normAutofit/>
           </a:bodyPr>
           <a:lstStyle>
@@ -1683,15 +1739,19 @@
               <a:defRPr sz="2800"/>
             </a:lvl9pPr>
           </a:lstStyle>
-          <a:p/>
+          <a:p>
+            <a:endParaRPr/>
+          </a:p>
         </p:txBody>
       </p:sp>
       <p:sp>
         <p:nvSpPr>
           <p:cNvPr id="12" name="Google Shape;12;p2"/>
-          <p:cNvSpPr txBox="1"/>
+          <p:cNvSpPr txBox="1">
+            <a:spLocks noGrp="1"/>
+          </p:cNvSpPr>
           <p:nvPr>
-            <p:ph idx="12" type="sldNum"/>
+            <p:ph type="sldNum" idx="12"/>
           </p:nvPr>
         </p:nvSpPr>
         <p:spPr>
@@ -1704,7 +1764,7 @@
           </a:prstGeom>
         </p:spPr>
         <p:txBody>
-          <a:bodyPr anchorCtr="0" anchor="ctr" bIns="91425" lIns="91425" spcFirstLastPara="1" rIns="91425" wrap="square" tIns="91425">
+          <a:bodyPr spcFirstLastPara="1" wrap="square" lIns="91425" tIns="91425" rIns="91425" bIns="91425" anchor="ctr" anchorCtr="0">
             <a:normAutofit/>
           </a:bodyPr>
           <a:lstStyle>
@@ -1746,7 +1806,7 @@
             </a:lvl9pPr>
           </a:lstStyle>
           <a:p>
-            <a:pPr indent="0" lvl="0" marL="0" rtl="0" algn="r">
+            <a:pPr marL="0" lvl="0" indent="0" algn="r" rtl="0">
               <a:spcBef>
                 <a:spcPts val="0"/>
               </a:spcBef>
@@ -1772,11 +1832,11 @@
 </file>
 
 <file path=ppt/slideLayouts/slideLayout10.xml><?xml version="1.0" encoding="utf-8"?>
-<p:sldLayout xmlns:a="http://schemas.openxmlformats.org/drawingml/2006/main" xmlns:r="http://schemas.openxmlformats.org/officeDocument/2006/relationships" xmlns:mc="http://schemas.openxmlformats.org/markup-compatibility/2006" xmlns:mv="urn:schemas-microsoft-com:mac:vml" xmlns:p="http://schemas.openxmlformats.org/presentationml/2006/main" xmlns:c="http://schemas.openxmlformats.org/drawingml/2006/chart" xmlns:dgm="http://schemas.openxmlformats.org/drawingml/2006/diagram" xmlns:o="urn:schemas-microsoft-com:office:office" xmlns:v="urn:schemas-microsoft-com:vml" xmlns:pvml="urn:schemas-microsoft-com:office:powerpoint" xmlns:com="http://schemas.openxmlformats.org/drawingml/2006/compatibility" xmlns:p14="http://schemas.microsoft.com/office/powerpoint/2010/main" xmlns:p15="http://schemas.microsoft.com/office/powerpoint/2012/main" xmlns:ahyp="http://schemas.microsoft.com/office/drawing/2018/hyperlinkcolor" matchingName="Big number">
+<p:sldLayout xmlns:a="http://schemas.openxmlformats.org/drawingml/2006/main" xmlns:r="http://schemas.openxmlformats.org/officeDocument/2006/relationships" xmlns:p="http://schemas.openxmlformats.org/presentationml/2006/main" matchingName="Big number">
   <p:cSld name="BIG_NUMBER">
     <p:spTree>
       <p:nvGrpSpPr>
-        <p:cNvPr id="44" name="Shape 44"/>
+        <p:cNvPr id="1" name="Shape 44"/>
         <p:cNvGrpSpPr/>
         <p:nvPr/>
       </p:nvGrpSpPr>
@@ -1791,9 +1851,11 @@
       <p:sp>
         <p:nvSpPr>
           <p:cNvPr id="45" name="Google Shape;45;p11"/>
-          <p:cNvSpPr txBox="1"/>
+          <p:cNvSpPr txBox="1">
+            <a:spLocks noGrp="1"/>
+          </p:cNvSpPr>
           <p:nvPr>
-            <p:ph hasCustomPrompt="1" type="title"/>
+            <p:ph type="title" hasCustomPrompt="1"/>
           </p:nvPr>
         </p:nvSpPr>
         <p:spPr>
@@ -1806,7 +1868,7 @@
           </a:prstGeom>
         </p:spPr>
         <p:txBody>
-          <a:bodyPr anchorCtr="0" anchor="b" bIns="91425" lIns="91425" spcFirstLastPara="1" rIns="91425" wrap="square" tIns="91425">
+          <a:bodyPr spcFirstLastPara="1" wrap="square" lIns="91425" tIns="91425" rIns="91425" bIns="91425" anchor="b" anchorCtr="0">
             <a:normAutofit/>
           </a:bodyPr>
           <a:lstStyle>
@@ -1920,9 +1982,11 @@
       <p:sp>
         <p:nvSpPr>
           <p:cNvPr id="46" name="Google Shape;46;p11"/>
-          <p:cNvSpPr txBox="1"/>
+          <p:cNvSpPr txBox="1">
+            <a:spLocks noGrp="1"/>
+          </p:cNvSpPr>
           <p:nvPr>
-            <p:ph idx="1" type="body"/>
+            <p:ph type="body" idx="1"/>
           </p:nvPr>
         </p:nvSpPr>
         <p:spPr>
@@ -1935,11 +1999,11 @@
           </a:prstGeom>
         </p:spPr>
         <p:txBody>
-          <a:bodyPr anchorCtr="0" anchor="t" bIns="91425" lIns="91425" spcFirstLastPara="1" rIns="91425" wrap="square" tIns="91425">
+          <a:bodyPr spcFirstLastPara="1" wrap="square" lIns="91425" tIns="91425" rIns="91425" bIns="91425" anchor="t" anchorCtr="0">
             <a:normAutofit/>
           </a:bodyPr>
           <a:lstStyle>
-            <a:lvl1pPr indent="-342900" lvl="0" marL="457200" algn="ctr">
+            <a:lvl1pPr marL="457200" lvl="0" indent="-342900" algn="ctr">
               <a:spcBef>
                 <a:spcPts val="0"/>
               </a:spcBef>
@@ -1950,7 +2014,7 @@
               <a:buChar char="●"/>
               <a:defRPr/>
             </a:lvl1pPr>
-            <a:lvl2pPr indent="-317500" lvl="1" marL="914400" algn="ctr">
+            <a:lvl2pPr marL="914400" lvl="1" indent="-317500" algn="ctr">
               <a:spcBef>
                 <a:spcPts val="0"/>
               </a:spcBef>
@@ -1961,7 +2025,7 @@
               <a:buChar char="○"/>
               <a:defRPr/>
             </a:lvl2pPr>
-            <a:lvl3pPr indent="-317500" lvl="2" marL="1371600" algn="ctr">
+            <a:lvl3pPr marL="1371600" lvl="2" indent="-317500" algn="ctr">
               <a:spcBef>
                 <a:spcPts val="0"/>
               </a:spcBef>
@@ -1972,7 +2036,7 @@
               <a:buChar char="■"/>
               <a:defRPr/>
             </a:lvl3pPr>
-            <a:lvl4pPr indent="-317500" lvl="3" marL="1828800" algn="ctr">
+            <a:lvl4pPr marL="1828800" lvl="3" indent="-317500" algn="ctr">
               <a:spcBef>
                 <a:spcPts val="0"/>
               </a:spcBef>
@@ -1983,7 +2047,7 @@
               <a:buChar char="●"/>
               <a:defRPr/>
             </a:lvl4pPr>
-            <a:lvl5pPr indent="-317500" lvl="4" marL="2286000" algn="ctr">
+            <a:lvl5pPr marL="2286000" lvl="4" indent="-317500" algn="ctr">
               <a:spcBef>
                 <a:spcPts val="0"/>
               </a:spcBef>
@@ -1994,7 +2058,7 @@
               <a:buChar char="○"/>
               <a:defRPr/>
             </a:lvl5pPr>
-            <a:lvl6pPr indent="-317500" lvl="5" marL="2743200" algn="ctr">
+            <a:lvl6pPr marL="2743200" lvl="5" indent="-317500" algn="ctr">
               <a:spcBef>
                 <a:spcPts val="0"/>
               </a:spcBef>
@@ -2005,7 +2069,7 @@
               <a:buChar char="■"/>
               <a:defRPr/>
             </a:lvl6pPr>
-            <a:lvl7pPr indent="-317500" lvl="6" marL="3200400" algn="ctr">
+            <a:lvl7pPr marL="3200400" lvl="6" indent="-317500" algn="ctr">
               <a:spcBef>
                 <a:spcPts val="0"/>
               </a:spcBef>
@@ -2016,7 +2080,7 @@
               <a:buChar char="●"/>
               <a:defRPr/>
             </a:lvl7pPr>
-            <a:lvl8pPr indent="-317500" lvl="7" marL="3657600" algn="ctr">
+            <a:lvl8pPr marL="3657600" lvl="7" indent="-317500" algn="ctr">
               <a:spcBef>
                 <a:spcPts val="0"/>
               </a:spcBef>
@@ -2027,7 +2091,7 @@
               <a:buChar char="○"/>
               <a:defRPr/>
             </a:lvl8pPr>
-            <a:lvl9pPr indent="-317500" lvl="8" marL="4114800" algn="ctr">
+            <a:lvl9pPr marL="4114800" lvl="8" indent="-317500" algn="ctr">
               <a:spcBef>
                 <a:spcPts val="0"/>
               </a:spcBef>
@@ -2039,15 +2103,19 @@
               <a:defRPr/>
             </a:lvl9pPr>
           </a:lstStyle>
-          <a:p/>
+          <a:p>
+            <a:endParaRPr/>
+          </a:p>
         </p:txBody>
       </p:sp>
       <p:sp>
         <p:nvSpPr>
           <p:cNvPr id="47" name="Google Shape;47;p11"/>
-          <p:cNvSpPr txBox="1"/>
+          <p:cNvSpPr txBox="1">
+            <a:spLocks noGrp="1"/>
+          </p:cNvSpPr>
           <p:nvPr>
-            <p:ph idx="12" type="sldNum"/>
+            <p:ph type="sldNum" idx="12"/>
           </p:nvPr>
         </p:nvSpPr>
         <p:spPr>
@@ -2060,7 +2128,7 @@
           </a:prstGeom>
         </p:spPr>
         <p:txBody>
-          <a:bodyPr anchorCtr="0" anchor="ctr" bIns="91425" lIns="91425" spcFirstLastPara="1" rIns="91425" wrap="square" tIns="91425">
+          <a:bodyPr spcFirstLastPara="1" wrap="square" lIns="91425" tIns="91425" rIns="91425" bIns="91425" anchor="ctr" anchorCtr="0">
             <a:normAutofit/>
           </a:bodyPr>
           <a:lstStyle>
@@ -2102,7 +2170,7 @@
             </a:lvl9pPr>
           </a:lstStyle>
           <a:p>
-            <a:pPr indent="0" lvl="0" marL="0" rtl="0" algn="r">
+            <a:pPr marL="0" lvl="0" indent="0" algn="r" rtl="0">
               <a:spcBef>
                 <a:spcPts val="0"/>
               </a:spcBef>
@@ -2128,11 +2196,11 @@
 </file>
 
 <file path=ppt/slideLayouts/slideLayout11.xml><?xml version="1.0" encoding="utf-8"?>
-<p:sldLayout xmlns:a="http://schemas.openxmlformats.org/drawingml/2006/main" xmlns:r="http://schemas.openxmlformats.org/officeDocument/2006/relationships" xmlns:mc="http://schemas.openxmlformats.org/markup-compatibility/2006" xmlns:mv="urn:schemas-microsoft-com:mac:vml" xmlns:p="http://schemas.openxmlformats.org/presentationml/2006/main" xmlns:c="http://schemas.openxmlformats.org/drawingml/2006/chart" xmlns:dgm="http://schemas.openxmlformats.org/drawingml/2006/diagram" xmlns:o="urn:schemas-microsoft-com:office:office" xmlns:v="urn:schemas-microsoft-com:vml" xmlns:pvml="urn:schemas-microsoft-com:office:powerpoint" xmlns:com="http://schemas.openxmlformats.org/drawingml/2006/compatibility" xmlns:p14="http://schemas.microsoft.com/office/powerpoint/2010/main" xmlns:p15="http://schemas.microsoft.com/office/powerpoint/2012/main" xmlns:ahyp="http://schemas.microsoft.com/office/drawing/2018/hyperlinkcolor" matchingName="Blank" type="blank">
+<p:sldLayout xmlns:a="http://schemas.openxmlformats.org/drawingml/2006/main" xmlns:r="http://schemas.openxmlformats.org/officeDocument/2006/relationships" xmlns:p="http://schemas.openxmlformats.org/presentationml/2006/main" matchingName="Blank" type="blank">
   <p:cSld name="BLANK">
     <p:spTree>
       <p:nvGrpSpPr>
-        <p:cNvPr id="48" name="Shape 48"/>
+        <p:cNvPr id="1" name="Shape 48"/>
         <p:cNvGrpSpPr/>
         <p:nvPr/>
       </p:nvGrpSpPr>
@@ -2147,9 +2215,11 @@
       <p:sp>
         <p:nvSpPr>
           <p:cNvPr id="49" name="Google Shape;49;p12"/>
-          <p:cNvSpPr txBox="1"/>
+          <p:cNvSpPr txBox="1">
+            <a:spLocks noGrp="1"/>
+          </p:cNvSpPr>
           <p:nvPr>
-            <p:ph idx="12" type="sldNum"/>
+            <p:ph type="sldNum" idx="12"/>
           </p:nvPr>
         </p:nvSpPr>
         <p:spPr>
@@ -2162,7 +2232,7 @@
           </a:prstGeom>
         </p:spPr>
         <p:txBody>
-          <a:bodyPr anchorCtr="0" anchor="ctr" bIns="91425" lIns="91425" spcFirstLastPara="1" rIns="91425" wrap="square" tIns="91425">
+          <a:bodyPr spcFirstLastPara="1" wrap="square" lIns="91425" tIns="91425" rIns="91425" bIns="91425" anchor="ctr" anchorCtr="0">
             <a:normAutofit/>
           </a:bodyPr>
           <a:lstStyle>
@@ -2204,7 +2274,7 @@
             </a:lvl9pPr>
           </a:lstStyle>
           <a:p>
-            <a:pPr indent="0" lvl="0" marL="0" rtl="0" algn="r">
+            <a:pPr marL="0" lvl="0" indent="0" algn="r" rtl="0">
               <a:spcBef>
                 <a:spcPts val="0"/>
               </a:spcBef>
@@ -2230,11 +2300,11 @@
 </file>
 
 <file path=ppt/slideLayouts/slideLayout2.xml><?xml version="1.0" encoding="utf-8"?>
-<p:sldLayout xmlns:a="http://schemas.openxmlformats.org/drawingml/2006/main" xmlns:r="http://schemas.openxmlformats.org/officeDocument/2006/relationships" xmlns:mc="http://schemas.openxmlformats.org/markup-compatibility/2006" xmlns:mv="urn:schemas-microsoft-com:mac:vml" xmlns:p="http://schemas.openxmlformats.org/presentationml/2006/main" xmlns:c="http://schemas.openxmlformats.org/drawingml/2006/chart" xmlns:dgm="http://schemas.openxmlformats.org/drawingml/2006/diagram" xmlns:o="urn:schemas-microsoft-com:office:office" xmlns:v="urn:schemas-microsoft-com:vml" xmlns:pvml="urn:schemas-microsoft-com:office:powerpoint" xmlns:com="http://schemas.openxmlformats.org/drawingml/2006/compatibility" xmlns:p14="http://schemas.microsoft.com/office/powerpoint/2010/main" xmlns:p15="http://schemas.microsoft.com/office/powerpoint/2012/main" xmlns:ahyp="http://schemas.microsoft.com/office/drawing/2018/hyperlinkcolor" matchingName="Section header" type="secHead">
+<p:sldLayout xmlns:a="http://schemas.openxmlformats.org/drawingml/2006/main" xmlns:r="http://schemas.openxmlformats.org/officeDocument/2006/relationships" xmlns:p="http://schemas.openxmlformats.org/presentationml/2006/main" matchingName="Section header" type="secHead">
   <p:cSld name="SECTION_HEADER">
     <p:spTree>
       <p:nvGrpSpPr>
-        <p:cNvPr id="13" name="Shape 13"/>
+        <p:cNvPr id="1" name="Shape 13"/>
         <p:cNvGrpSpPr/>
         <p:nvPr/>
       </p:nvGrpSpPr>
@@ -2249,7 +2319,9 @@
       <p:sp>
         <p:nvSpPr>
           <p:cNvPr id="14" name="Google Shape;14;p3"/>
-          <p:cNvSpPr txBox="1"/>
+          <p:cNvSpPr txBox="1">
+            <a:spLocks noGrp="1"/>
+          </p:cNvSpPr>
           <p:nvPr>
             <p:ph type="title"/>
           </p:nvPr>
@@ -2264,7 +2336,7 @@
           </a:prstGeom>
         </p:spPr>
         <p:txBody>
-          <a:bodyPr anchorCtr="0" anchor="ctr" bIns="91425" lIns="91425" spcFirstLastPara="1" rIns="91425" wrap="square" tIns="91425">
+          <a:bodyPr spcFirstLastPara="1" wrap="square" lIns="91425" tIns="91425" rIns="91425" bIns="91425" anchor="ctr" anchorCtr="0">
             <a:normAutofit/>
           </a:bodyPr>
           <a:lstStyle>
@@ -2368,15 +2440,19 @@
               <a:defRPr sz="3600"/>
             </a:lvl9pPr>
           </a:lstStyle>
-          <a:p/>
+          <a:p>
+            <a:endParaRPr/>
+          </a:p>
         </p:txBody>
       </p:sp>
       <p:sp>
         <p:nvSpPr>
           <p:cNvPr id="15" name="Google Shape;15;p3"/>
-          <p:cNvSpPr txBox="1"/>
+          <p:cNvSpPr txBox="1">
+            <a:spLocks noGrp="1"/>
+          </p:cNvSpPr>
           <p:nvPr>
-            <p:ph idx="12" type="sldNum"/>
+            <p:ph type="sldNum" idx="12"/>
           </p:nvPr>
         </p:nvSpPr>
         <p:spPr>
@@ -2389,7 +2465,7 @@
           </a:prstGeom>
         </p:spPr>
         <p:txBody>
-          <a:bodyPr anchorCtr="0" anchor="ctr" bIns="91425" lIns="91425" spcFirstLastPara="1" rIns="91425" wrap="square" tIns="91425">
+          <a:bodyPr spcFirstLastPara="1" wrap="square" lIns="91425" tIns="91425" rIns="91425" bIns="91425" anchor="ctr" anchorCtr="0">
             <a:normAutofit/>
           </a:bodyPr>
           <a:lstStyle>
@@ -2431,7 +2507,7 @@
             </a:lvl9pPr>
           </a:lstStyle>
           <a:p>
-            <a:pPr indent="0" lvl="0" marL="0" rtl="0" algn="r">
+            <a:pPr marL="0" lvl="0" indent="0" algn="r" rtl="0">
               <a:spcBef>
                 <a:spcPts val="0"/>
               </a:spcBef>
@@ -2457,11 +2533,11 @@
 </file>
 
 <file path=ppt/slideLayouts/slideLayout3.xml><?xml version="1.0" encoding="utf-8"?>
-<p:sldLayout xmlns:a="http://schemas.openxmlformats.org/drawingml/2006/main" xmlns:r="http://schemas.openxmlformats.org/officeDocument/2006/relationships" xmlns:mc="http://schemas.openxmlformats.org/markup-compatibility/2006" xmlns:mv="urn:schemas-microsoft-com:mac:vml" xmlns:p="http://schemas.openxmlformats.org/presentationml/2006/main" xmlns:c="http://schemas.openxmlformats.org/drawingml/2006/chart" xmlns:dgm="http://schemas.openxmlformats.org/drawingml/2006/diagram" xmlns:o="urn:schemas-microsoft-com:office:office" xmlns:v="urn:schemas-microsoft-com:vml" xmlns:pvml="urn:schemas-microsoft-com:office:powerpoint" xmlns:com="http://schemas.openxmlformats.org/drawingml/2006/compatibility" xmlns:p14="http://schemas.microsoft.com/office/powerpoint/2010/main" xmlns:p15="http://schemas.microsoft.com/office/powerpoint/2012/main" xmlns:ahyp="http://schemas.microsoft.com/office/drawing/2018/hyperlinkcolor" matchingName="Title and body" type="tx">
+<p:sldLayout xmlns:a="http://schemas.openxmlformats.org/drawingml/2006/main" xmlns:r="http://schemas.openxmlformats.org/officeDocument/2006/relationships" xmlns:p="http://schemas.openxmlformats.org/presentationml/2006/main" matchingName="Title and body" type="tx">
   <p:cSld name="TITLE_AND_BODY">
     <p:spTree>
       <p:nvGrpSpPr>
-        <p:cNvPr id="16" name="Shape 16"/>
+        <p:cNvPr id="1" name="Shape 16"/>
         <p:cNvGrpSpPr/>
         <p:nvPr/>
       </p:nvGrpSpPr>
@@ -2476,7 +2552,9 @@
       <p:sp>
         <p:nvSpPr>
           <p:cNvPr id="17" name="Google Shape;17;p4"/>
-          <p:cNvSpPr txBox="1"/>
+          <p:cNvSpPr txBox="1">
+            <a:spLocks noGrp="1"/>
+          </p:cNvSpPr>
           <p:nvPr>
             <p:ph type="title"/>
           </p:nvPr>
@@ -2491,7 +2569,7 @@
           </a:prstGeom>
         </p:spPr>
         <p:txBody>
-          <a:bodyPr anchorCtr="0" anchor="t" bIns="91425" lIns="91425" spcFirstLastPara="1" rIns="91425" wrap="square" tIns="91425">
+          <a:bodyPr spcFirstLastPara="1" wrap="square" lIns="91425" tIns="91425" rIns="91425" bIns="91425" anchor="t" anchorCtr="0">
             <a:normAutofit/>
           </a:bodyPr>
           <a:lstStyle>
@@ -2595,15 +2673,19 @@
               <a:defRPr/>
             </a:lvl9pPr>
           </a:lstStyle>
-          <a:p/>
+          <a:p>
+            <a:endParaRPr/>
+          </a:p>
         </p:txBody>
       </p:sp>
       <p:sp>
         <p:nvSpPr>
           <p:cNvPr id="18" name="Google Shape;18;p4"/>
-          <p:cNvSpPr txBox="1"/>
+          <p:cNvSpPr txBox="1">
+            <a:spLocks noGrp="1"/>
+          </p:cNvSpPr>
           <p:nvPr>
-            <p:ph idx="1" type="body"/>
+            <p:ph type="body" idx="1"/>
           </p:nvPr>
         </p:nvSpPr>
         <p:spPr>
@@ -2616,11 +2698,11 @@
           </a:prstGeom>
         </p:spPr>
         <p:txBody>
-          <a:bodyPr anchorCtr="0" anchor="t" bIns="91425" lIns="91425" spcFirstLastPara="1" rIns="91425" wrap="square" tIns="91425">
+          <a:bodyPr spcFirstLastPara="1" wrap="square" lIns="91425" tIns="91425" rIns="91425" bIns="91425" anchor="t" anchorCtr="0">
             <a:normAutofit/>
           </a:bodyPr>
           <a:lstStyle>
-            <a:lvl1pPr indent="-342900" lvl="0" marL="457200">
+            <a:lvl1pPr marL="457200" lvl="0" indent="-342900">
               <a:spcBef>
                 <a:spcPts val="0"/>
               </a:spcBef>
@@ -2631,7 +2713,7 @@
               <a:buChar char="●"/>
               <a:defRPr/>
             </a:lvl1pPr>
-            <a:lvl2pPr indent="-317500" lvl="1" marL="914400">
+            <a:lvl2pPr marL="914400" lvl="1" indent="-317500">
               <a:spcBef>
                 <a:spcPts val="0"/>
               </a:spcBef>
@@ -2642,7 +2724,7 @@
               <a:buChar char="○"/>
               <a:defRPr/>
             </a:lvl2pPr>
-            <a:lvl3pPr indent="-317500" lvl="2" marL="1371600">
+            <a:lvl3pPr marL="1371600" lvl="2" indent="-317500">
               <a:spcBef>
                 <a:spcPts val="0"/>
               </a:spcBef>
@@ -2653,7 +2735,7 @@
               <a:buChar char="■"/>
               <a:defRPr/>
             </a:lvl3pPr>
-            <a:lvl4pPr indent="-317500" lvl="3" marL="1828800">
+            <a:lvl4pPr marL="1828800" lvl="3" indent="-317500">
               <a:spcBef>
                 <a:spcPts val="0"/>
               </a:spcBef>
@@ -2664,7 +2746,7 @@
               <a:buChar char="●"/>
               <a:defRPr/>
             </a:lvl4pPr>
-            <a:lvl5pPr indent="-317500" lvl="4" marL="2286000">
+            <a:lvl5pPr marL="2286000" lvl="4" indent="-317500">
               <a:spcBef>
                 <a:spcPts val="0"/>
               </a:spcBef>
@@ -2675,7 +2757,7 @@
               <a:buChar char="○"/>
               <a:defRPr/>
             </a:lvl5pPr>
-            <a:lvl6pPr indent="-317500" lvl="5" marL="2743200">
+            <a:lvl6pPr marL="2743200" lvl="5" indent="-317500">
               <a:spcBef>
                 <a:spcPts val="0"/>
               </a:spcBef>
@@ -2686,7 +2768,7 @@
               <a:buChar char="■"/>
               <a:defRPr/>
             </a:lvl6pPr>
-            <a:lvl7pPr indent="-317500" lvl="6" marL="3200400">
+            <a:lvl7pPr marL="3200400" lvl="6" indent="-317500">
               <a:spcBef>
                 <a:spcPts val="0"/>
               </a:spcBef>
@@ -2697,7 +2779,7 @@
               <a:buChar char="●"/>
               <a:defRPr/>
             </a:lvl7pPr>
-            <a:lvl8pPr indent="-317500" lvl="7" marL="3657600">
+            <a:lvl8pPr marL="3657600" lvl="7" indent="-317500">
               <a:spcBef>
                 <a:spcPts val="0"/>
               </a:spcBef>
@@ -2708,7 +2790,7 @@
               <a:buChar char="○"/>
               <a:defRPr/>
             </a:lvl8pPr>
-            <a:lvl9pPr indent="-317500" lvl="8" marL="4114800">
+            <a:lvl9pPr marL="4114800" lvl="8" indent="-317500">
               <a:spcBef>
                 <a:spcPts val="0"/>
               </a:spcBef>
@@ -2720,15 +2802,19 @@
               <a:defRPr/>
             </a:lvl9pPr>
           </a:lstStyle>
-          <a:p/>
+          <a:p>
+            <a:endParaRPr/>
+          </a:p>
         </p:txBody>
       </p:sp>
       <p:sp>
         <p:nvSpPr>
           <p:cNvPr id="19" name="Google Shape;19;p4"/>
-          <p:cNvSpPr txBox="1"/>
+          <p:cNvSpPr txBox="1">
+            <a:spLocks noGrp="1"/>
+          </p:cNvSpPr>
           <p:nvPr>
-            <p:ph idx="12" type="sldNum"/>
+            <p:ph type="sldNum" idx="12"/>
           </p:nvPr>
         </p:nvSpPr>
         <p:spPr>
@@ -2741,7 +2827,7 @@
           </a:prstGeom>
         </p:spPr>
         <p:txBody>
-          <a:bodyPr anchorCtr="0" anchor="ctr" bIns="91425" lIns="91425" spcFirstLastPara="1" rIns="91425" wrap="square" tIns="91425">
+          <a:bodyPr spcFirstLastPara="1" wrap="square" lIns="91425" tIns="91425" rIns="91425" bIns="91425" anchor="ctr" anchorCtr="0">
             <a:normAutofit/>
           </a:bodyPr>
           <a:lstStyle>
@@ -2783,7 +2869,7 @@
             </a:lvl9pPr>
           </a:lstStyle>
           <a:p>
-            <a:pPr indent="0" lvl="0" marL="0" rtl="0" algn="r">
+            <a:pPr marL="0" lvl="0" indent="0" algn="r" rtl="0">
               <a:spcBef>
                 <a:spcPts val="0"/>
               </a:spcBef>
@@ -2809,11 +2895,11 @@
 </file>
 
 <file path=ppt/slideLayouts/slideLayout4.xml><?xml version="1.0" encoding="utf-8"?>
-<p:sldLayout xmlns:a="http://schemas.openxmlformats.org/drawingml/2006/main" xmlns:r="http://schemas.openxmlformats.org/officeDocument/2006/relationships" xmlns:mc="http://schemas.openxmlformats.org/markup-compatibility/2006" xmlns:mv="urn:schemas-microsoft-com:mac:vml" xmlns:p="http://schemas.openxmlformats.org/presentationml/2006/main" xmlns:c="http://schemas.openxmlformats.org/drawingml/2006/chart" xmlns:dgm="http://schemas.openxmlformats.org/drawingml/2006/diagram" xmlns:o="urn:schemas-microsoft-com:office:office" xmlns:v="urn:schemas-microsoft-com:vml" xmlns:pvml="urn:schemas-microsoft-com:office:powerpoint" xmlns:com="http://schemas.openxmlformats.org/drawingml/2006/compatibility" xmlns:p14="http://schemas.microsoft.com/office/powerpoint/2010/main" xmlns:p15="http://schemas.microsoft.com/office/powerpoint/2012/main" xmlns:ahyp="http://schemas.microsoft.com/office/drawing/2018/hyperlinkcolor" matchingName="Title and two columns" type="twoColTx">
+<p:sldLayout xmlns:a="http://schemas.openxmlformats.org/drawingml/2006/main" xmlns:r="http://schemas.openxmlformats.org/officeDocument/2006/relationships" xmlns:p="http://schemas.openxmlformats.org/presentationml/2006/main" matchingName="Title and two columns" type="twoColTx">
   <p:cSld name="TITLE_AND_TWO_COLUMNS">
     <p:spTree>
       <p:nvGrpSpPr>
-        <p:cNvPr id="20" name="Shape 20"/>
+        <p:cNvPr id="1" name="Shape 20"/>
         <p:cNvGrpSpPr/>
         <p:nvPr/>
       </p:nvGrpSpPr>
@@ -2828,7 +2914,9 @@
       <p:sp>
         <p:nvSpPr>
           <p:cNvPr id="21" name="Google Shape;21;p5"/>
-          <p:cNvSpPr txBox="1"/>
+          <p:cNvSpPr txBox="1">
+            <a:spLocks noGrp="1"/>
+          </p:cNvSpPr>
           <p:nvPr>
             <p:ph type="title"/>
           </p:nvPr>
@@ -2843,7 +2931,7 @@
           </a:prstGeom>
         </p:spPr>
         <p:txBody>
-          <a:bodyPr anchorCtr="0" anchor="t" bIns="91425" lIns="91425" spcFirstLastPara="1" rIns="91425" wrap="square" tIns="91425">
+          <a:bodyPr spcFirstLastPara="1" wrap="square" lIns="91425" tIns="91425" rIns="91425" bIns="91425" anchor="t" anchorCtr="0">
             <a:normAutofit/>
           </a:bodyPr>
           <a:lstStyle>
@@ -2947,15 +3035,19 @@
               <a:defRPr/>
             </a:lvl9pPr>
           </a:lstStyle>
-          <a:p/>
+          <a:p>
+            <a:endParaRPr/>
+          </a:p>
         </p:txBody>
       </p:sp>
       <p:sp>
         <p:nvSpPr>
           <p:cNvPr id="22" name="Google Shape;22;p5"/>
-          <p:cNvSpPr txBox="1"/>
+          <p:cNvSpPr txBox="1">
+            <a:spLocks noGrp="1"/>
+          </p:cNvSpPr>
           <p:nvPr>
-            <p:ph idx="1" type="body"/>
+            <p:ph type="body" idx="1"/>
           </p:nvPr>
         </p:nvSpPr>
         <p:spPr>
@@ -2968,11 +3060,11 @@
           </a:prstGeom>
         </p:spPr>
         <p:txBody>
-          <a:bodyPr anchorCtr="0" anchor="t" bIns="91425" lIns="91425" spcFirstLastPara="1" rIns="91425" wrap="square" tIns="91425">
+          <a:bodyPr spcFirstLastPara="1" wrap="square" lIns="91425" tIns="91425" rIns="91425" bIns="91425" anchor="t" anchorCtr="0">
             <a:normAutofit/>
           </a:bodyPr>
           <a:lstStyle>
-            <a:lvl1pPr indent="-317500" lvl="0" marL="457200">
+            <a:lvl1pPr marL="457200" lvl="0" indent="-317500">
               <a:spcBef>
                 <a:spcPts val="0"/>
               </a:spcBef>
@@ -2983,7 +3075,7 @@
               <a:buChar char="●"/>
               <a:defRPr sz="1400"/>
             </a:lvl1pPr>
-            <a:lvl2pPr indent="-304800" lvl="1" marL="914400">
+            <a:lvl2pPr marL="914400" lvl="1" indent="-304800">
               <a:spcBef>
                 <a:spcPts val="0"/>
               </a:spcBef>
@@ -2994,7 +3086,7 @@
               <a:buChar char="○"/>
               <a:defRPr sz="1200"/>
             </a:lvl2pPr>
-            <a:lvl3pPr indent="-304800" lvl="2" marL="1371600">
+            <a:lvl3pPr marL="1371600" lvl="2" indent="-304800">
               <a:spcBef>
                 <a:spcPts val="0"/>
               </a:spcBef>
@@ -3005,7 +3097,7 @@
               <a:buChar char="■"/>
               <a:defRPr sz="1200"/>
             </a:lvl3pPr>
-            <a:lvl4pPr indent="-304800" lvl="3" marL="1828800">
+            <a:lvl4pPr marL="1828800" lvl="3" indent="-304800">
               <a:spcBef>
                 <a:spcPts val="0"/>
               </a:spcBef>
@@ -3016,7 +3108,7 @@
               <a:buChar char="●"/>
               <a:defRPr sz="1200"/>
             </a:lvl4pPr>
-            <a:lvl5pPr indent="-304800" lvl="4" marL="2286000">
+            <a:lvl5pPr marL="2286000" lvl="4" indent="-304800">
               <a:spcBef>
                 <a:spcPts val="0"/>
               </a:spcBef>
@@ -3027,7 +3119,7 @@
               <a:buChar char="○"/>
               <a:defRPr sz="1200"/>
             </a:lvl5pPr>
-            <a:lvl6pPr indent="-304800" lvl="5" marL="2743200">
+            <a:lvl6pPr marL="2743200" lvl="5" indent="-304800">
               <a:spcBef>
                 <a:spcPts val="0"/>
               </a:spcBef>
@@ -3038,7 +3130,7 @@
               <a:buChar char="■"/>
               <a:defRPr sz="1200"/>
             </a:lvl6pPr>
-            <a:lvl7pPr indent="-304800" lvl="6" marL="3200400">
+            <a:lvl7pPr marL="3200400" lvl="6" indent="-304800">
               <a:spcBef>
                 <a:spcPts val="0"/>
               </a:spcBef>
@@ -3049,7 +3141,7 @@
               <a:buChar char="●"/>
               <a:defRPr sz="1200"/>
             </a:lvl7pPr>
-            <a:lvl8pPr indent="-304800" lvl="7" marL="3657600">
+            <a:lvl8pPr marL="3657600" lvl="7" indent="-304800">
               <a:spcBef>
                 <a:spcPts val="0"/>
               </a:spcBef>
@@ -3060,7 +3152,7 @@
               <a:buChar char="○"/>
               <a:defRPr sz="1200"/>
             </a:lvl8pPr>
-            <a:lvl9pPr indent="-304800" lvl="8" marL="4114800">
+            <a:lvl9pPr marL="4114800" lvl="8" indent="-304800">
               <a:spcBef>
                 <a:spcPts val="0"/>
               </a:spcBef>
@@ -3072,15 +3164,19 @@
               <a:defRPr sz="1200"/>
             </a:lvl9pPr>
           </a:lstStyle>
-          <a:p/>
+          <a:p>
+            <a:endParaRPr/>
+          </a:p>
         </p:txBody>
       </p:sp>
       <p:sp>
         <p:nvSpPr>
           <p:cNvPr id="23" name="Google Shape;23;p5"/>
-          <p:cNvSpPr txBox="1"/>
+          <p:cNvSpPr txBox="1">
+            <a:spLocks noGrp="1"/>
+          </p:cNvSpPr>
           <p:nvPr>
-            <p:ph idx="2" type="body"/>
+            <p:ph type="body" idx="2"/>
           </p:nvPr>
         </p:nvSpPr>
         <p:spPr>
@@ -3093,11 +3189,11 @@
           </a:prstGeom>
         </p:spPr>
         <p:txBody>
-          <a:bodyPr anchorCtr="0" anchor="t" bIns="91425" lIns="91425" spcFirstLastPara="1" rIns="91425" wrap="square" tIns="91425">
+          <a:bodyPr spcFirstLastPara="1" wrap="square" lIns="91425" tIns="91425" rIns="91425" bIns="91425" anchor="t" anchorCtr="0">
             <a:normAutofit/>
           </a:bodyPr>
           <a:lstStyle>
-            <a:lvl1pPr indent="-317500" lvl="0" marL="457200">
+            <a:lvl1pPr marL="457200" lvl="0" indent="-317500">
               <a:spcBef>
                 <a:spcPts val="0"/>
               </a:spcBef>
@@ -3108,7 +3204,7 @@
               <a:buChar char="●"/>
               <a:defRPr sz="1400"/>
             </a:lvl1pPr>
-            <a:lvl2pPr indent="-304800" lvl="1" marL="914400">
+            <a:lvl2pPr marL="914400" lvl="1" indent="-304800">
               <a:spcBef>
                 <a:spcPts val="0"/>
               </a:spcBef>
@@ -3119,7 +3215,7 @@
               <a:buChar char="○"/>
               <a:defRPr sz="1200"/>
             </a:lvl2pPr>
-            <a:lvl3pPr indent="-304800" lvl="2" marL="1371600">
+            <a:lvl3pPr marL="1371600" lvl="2" indent="-304800">
               <a:spcBef>
                 <a:spcPts val="0"/>
               </a:spcBef>
@@ -3130,7 +3226,7 @@
               <a:buChar char="■"/>
               <a:defRPr sz="1200"/>
             </a:lvl3pPr>
-            <a:lvl4pPr indent="-304800" lvl="3" marL="1828800">
+            <a:lvl4pPr marL="1828800" lvl="3" indent="-304800">
               <a:spcBef>
                 <a:spcPts val="0"/>
               </a:spcBef>
@@ -3141,7 +3237,7 @@
               <a:buChar char="●"/>
               <a:defRPr sz="1200"/>
             </a:lvl4pPr>
-            <a:lvl5pPr indent="-304800" lvl="4" marL="2286000">
+            <a:lvl5pPr marL="2286000" lvl="4" indent="-304800">
               <a:spcBef>
                 <a:spcPts val="0"/>
               </a:spcBef>
@@ -3152,7 +3248,7 @@
               <a:buChar char="○"/>
               <a:defRPr sz="1200"/>
             </a:lvl5pPr>
-            <a:lvl6pPr indent="-304800" lvl="5" marL="2743200">
+            <a:lvl6pPr marL="2743200" lvl="5" indent="-304800">
               <a:spcBef>
                 <a:spcPts val="0"/>
               </a:spcBef>
@@ -3163,7 +3259,7 @@
               <a:buChar char="■"/>
               <a:defRPr sz="1200"/>
             </a:lvl6pPr>
-            <a:lvl7pPr indent="-304800" lvl="6" marL="3200400">
+            <a:lvl7pPr marL="3200400" lvl="6" indent="-304800">
               <a:spcBef>
                 <a:spcPts val="0"/>
               </a:spcBef>
@@ -3174,7 +3270,7 @@
               <a:buChar char="●"/>
               <a:defRPr sz="1200"/>
             </a:lvl7pPr>
-            <a:lvl8pPr indent="-304800" lvl="7" marL="3657600">
+            <a:lvl8pPr marL="3657600" lvl="7" indent="-304800">
               <a:spcBef>
                 <a:spcPts val="0"/>
               </a:spcBef>
@@ -3185,7 +3281,7 @@
               <a:buChar char="○"/>
               <a:defRPr sz="1200"/>
             </a:lvl8pPr>
-            <a:lvl9pPr indent="-304800" lvl="8" marL="4114800">
+            <a:lvl9pPr marL="4114800" lvl="8" indent="-304800">
               <a:spcBef>
                 <a:spcPts val="0"/>
               </a:spcBef>
@@ -3197,15 +3293,19 @@
               <a:defRPr sz="1200"/>
             </a:lvl9pPr>
           </a:lstStyle>
-          <a:p/>
+          <a:p>
+            <a:endParaRPr/>
+          </a:p>
         </p:txBody>
       </p:sp>
       <p:sp>
         <p:nvSpPr>
           <p:cNvPr id="24" name="Google Shape;24;p5"/>
-          <p:cNvSpPr txBox="1"/>
+          <p:cNvSpPr txBox="1">
+            <a:spLocks noGrp="1"/>
+          </p:cNvSpPr>
           <p:nvPr>
-            <p:ph idx="12" type="sldNum"/>
+            <p:ph type="sldNum" idx="12"/>
           </p:nvPr>
         </p:nvSpPr>
         <p:spPr>
@@ -3218,7 +3318,7 @@
           </a:prstGeom>
         </p:spPr>
         <p:txBody>
-          <a:bodyPr anchorCtr="0" anchor="ctr" bIns="91425" lIns="91425" spcFirstLastPara="1" rIns="91425" wrap="square" tIns="91425">
+          <a:bodyPr spcFirstLastPara="1" wrap="square" lIns="91425" tIns="91425" rIns="91425" bIns="91425" anchor="ctr" anchorCtr="0">
             <a:normAutofit/>
           </a:bodyPr>
           <a:lstStyle>
@@ -3260,7 +3360,7 @@
             </a:lvl9pPr>
           </a:lstStyle>
           <a:p>
-            <a:pPr indent="0" lvl="0" marL="0" rtl="0" algn="r">
+            <a:pPr marL="0" lvl="0" indent="0" algn="r" rtl="0">
               <a:spcBef>
                 <a:spcPts val="0"/>
               </a:spcBef>
@@ -3286,11 +3386,11 @@
 </file>
 
 <file path=ppt/slideLayouts/slideLayout5.xml><?xml version="1.0" encoding="utf-8"?>
-<p:sldLayout xmlns:a="http://schemas.openxmlformats.org/drawingml/2006/main" xmlns:r="http://schemas.openxmlformats.org/officeDocument/2006/relationships" xmlns:mc="http://schemas.openxmlformats.org/markup-compatibility/2006" xmlns:mv="urn:schemas-microsoft-com:mac:vml" xmlns:p="http://schemas.openxmlformats.org/presentationml/2006/main" xmlns:c="http://schemas.openxmlformats.org/drawingml/2006/chart" xmlns:dgm="http://schemas.openxmlformats.org/drawingml/2006/diagram" xmlns:o="urn:schemas-microsoft-com:office:office" xmlns:v="urn:schemas-microsoft-com:vml" xmlns:pvml="urn:schemas-microsoft-com:office:powerpoint" xmlns:com="http://schemas.openxmlformats.org/drawingml/2006/compatibility" xmlns:p14="http://schemas.microsoft.com/office/powerpoint/2010/main" xmlns:p15="http://schemas.microsoft.com/office/powerpoint/2012/main" xmlns:ahyp="http://schemas.microsoft.com/office/drawing/2018/hyperlinkcolor" matchingName="Title only" type="titleOnly">
+<p:sldLayout xmlns:a="http://schemas.openxmlformats.org/drawingml/2006/main" xmlns:r="http://schemas.openxmlformats.org/officeDocument/2006/relationships" xmlns:p="http://schemas.openxmlformats.org/presentationml/2006/main" matchingName="Title only" type="titleOnly">
   <p:cSld name="TITLE_ONLY">
     <p:spTree>
       <p:nvGrpSpPr>
-        <p:cNvPr id="25" name="Shape 25"/>
+        <p:cNvPr id="1" name="Shape 25"/>
         <p:cNvGrpSpPr/>
         <p:nvPr/>
       </p:nvGrpSpPr>
@@ -3305,7 +3405,9 @@
       <p:sp>
         <p:nvSpPr>
           <p:cNvPr id="26" name="Google Shape;26;p6"/>
-          <p:cNvSpPr txBox="1"/>
+          <p:cNvSpPr txBox="1">
+            <a:spLocks noGrp="1"/>
+          </p:cNvSpPr>
           <p:nvPr>
             <p:ph type="title"/>
           </p:nvPr>
@@ -3320,7 +3422,7 @@
           </a:prstGeom>
         </p:spPr>
         <p:txBody>
-          <a:bodyPr anchorCtr="0" anchor="t" bIns="91425" lIns="91425" spcFirstLastPara="1" rIns="91425" wrap="square" tIns="91425">
+          <a:bodyPr spcFirstLastPara="1" wrap="square" lIns="91425" tIns="91425" rIns="91425" bIns="91425" anchor="t" anchorCtr="0">
             <a:normAutofit/>
           </a:bodyPr>
           <a:lstStyle>
@@ -3424,15 +3526,19 @@
               <a:defRPr/>
             </a:lvl9pPr>
           </a:lstStyle>
-          <a:p/>
+          <a:p>
+            <a:endParaRPr/>
+          </a:p>
         </p:txBody>
       </p:sp>
       <p:sp>
         <p:nvSpPr>
           <p:cNvPr id="27" name="Google Shape;27;p6"/>
-          <p:cNvSpPr txBox="1"/>
+          <p:cNvSpPr txBox="1">
+            <a:spLocks noGrp="1"/>
+          </p:cNvSpPr>
           <p:nvPr>
-            <p:ph idx="12" type="sldNum"/>
+            <p:ph type="sldNum" idx="12"/>
           </p:nvPr>
         </p:nvSpPr>
         <p:spPr>
@@ -3445,7 +3551,7 @@
           </a:prstGeom>
         </p:spPr>
         <p:txBody>
-          <a:bodyPr anchorCtr="0" anchor="ctr" bIns="91425" lIns="91425" spcFirstLastPara="1" rIns="91425" wrap="square" tIns="91425">
+          <a:bodyPr spcFirstLastPara="1" wrap="square" lIns="91425" tIns="91425" rIns="91425" bIns="91425" anchor="ctr" anchorCtr="0">
             <a:normAutofit/>
           </a:bodyPr>
           <a:lstStyle>
@@ -3487,7 +3593,7 @@
             </a:lvl9pPr>
           </a:lstStyle>
           <a:p>
-            <a:pPr indent="0" lvl="0" marL="0" rtl="0" algn="r">
+            <a:pPr marL="0" lvl="0" indent="0" algn="r" rtl="0">
               <a:spcBef>
                 <a:spcPts val="0"/>
               </a:spcBef>
@@ -3513,11 +3619,11 @@
 </file>
 
 <file path=ppt/slideLayouts/slideLayout6.xml><?xml version="1.0" encoding="utf-8"?>
-<p:sldLayout xmlns:a="http://schemas.openxmlformats.org/drawingml/2006/main" xmlns:r="http://schemas.openxmlformats.org/officeDocument/2006/relationships" xmlns:mc="http://schemas.openxmlformats.org/markup-compatibility/2006" xmlns:mv="urn:schemas-microsoft-com:mac:vml" xmlns:p="http://schemas.openxmlformats.org/presentationml/2006/main" xmlns:c="http://schemas.openxmlformats.org/drawingml/2006/chart" xmlns:dgm="http://schemas.openxmlformats.org/drawingml/2006/diagram" xmlns:o="urn:schemas-microsoft-com:office:office" xmlns:v="urn:schemas-microsoft-com:vml" xmlns:pvml="urn:schemas-microsoft-com:office:powerpoint" xmlns:com="http://schemas.openxmlformats.org/drawingml/2006/compatibility" xmlns:p14="http://schemas.microsoft.com/office/powerpoint/2010/main" xmlns:p15="http://schemas.microsoft.com/office/powerpoint/2012/main" xmlns:ahyp="http://schemas.microsoft.com/office/drawing/2018/hyperlinkcolor" matchingName="One column text">
+<p:sldLayout xmlns:a="http://schemas.openxmlformats.org/drawingml/2006/main" xmlns:r="http://schemas.openxmlformats.org/officeDocument/2006/relationships" xmlns:p="http://schemas.openxmlformats.org/presentationml/2006/main" matchingName="One column text">
   <p:cSld name="ONE_COLUMN_TEXT">
     <p:spTree>
       <p:nvGrpSpPr>
-        <p:cNvPr id="28" name="Shape 28"/>
+        <p:cNvPr id="1" name="Shape 28"/>
         <p:cNvGrpSpPr/>
         <p:nvPr/>
       </p:nvGrpSpPr>
@@ -3532,7 +3638,9 @@
       <p:sp>
         <p:nvSpPr>
           <p:cNvPr id="29" name="Google Shape;29;p7"/>
-          <p:cNvSpPr txBox="1"/>
+          <p:cNvSpPr txBox="1">
+            <a:spLocks noGrp="1"/>
+          </p:cNvSpPr>
           <p:nvPr>
             <p:ph type="title"/>
           </p:nvPr>
@@ -3547,7 +3655,7 @@
           </a:prstGeom>
         </p:spPr>
         <p:txBody>
-          <a:bodyPr anchorCtr="0" anchor="b" bIns="91425" lIns="91425" spcFirstLastPara="1" rIns="91425" wrap="square" tIns="91425">
+          <a:bodyPr spcFirstLastPara="1" wrap="square" lIns="91425" tIns="91425" rIns="91425" bIns="91425" anchor="b" anchorCtr="0">
             <a:normAutofit/>
           </a:bodyPr>
           <a:lstStyle>
@@ -3651,15 +3759,19 @@
               <a:defRPr sz="2400"/>
             </a:lvl9pPr>
           </a:lstStyle>
-          <a:p/>
+          <a:p>
+            <a:endParaRPr/>
+          </a:p>
         </p:txBody>
       </p:sp>
       <p:sp>
         <p:nvSpPr>
           <p:cNvPr id="30" name="Google Shape;30;p7"/>
-          <p:cNvSpPr txBox="1"/>
+          <p:cNvSpPr txBox="1">
+            <a:spLocks noGrp="1"/>
+          </p:cNvSpPr>
           <p:nvPr>
-            <p:ph idx="1" type="body"/>
+            <p:ph type="body" idx="1"/>
           </p:nvPr>
         </p:nvSpPr>
         <p:spPr>
@@ -3672,11 +3784,11 @@
           </a:prstGeom>
         </p:spPr>
         <p:txBody>
-          <a:bodyPr anchorCtr="0" anchor="t" bIns="91425" lIns="91425" spcFirstLastPara="1" rIns="91425" wrap="square" tIns="91425">
+          <a:bodyPr spcFirstLastPara="1" wrap="square" lIns="91425" tIns="91425" rIns="91425" bIns="91425" anchor="t" anchorCtr="0">
             <a:normAutofit/>
           </a:bodyPr>
           <a:lstStyle>
-            <a:lvl1pPr indent="-304800" lvl="0" marL="457200">
+            <a:lvl1pPr marL="457200" lvl="0" indent="-304800">
               <a:spcBef>
                 <a:spcPts val="0"/>
               </a:spcBef>
@@ -3687,7 +3799,7 @@
               <a:buChar char="●"/>
               <a:defRPr sz="1200"/>
             </a:lvl1pPr>
-            <a:lvl2pPr indent="-304800" lvl="1" marL="914400">
+            <a:lvl2pPr marL="914400" lvl="1" indent="-304800">
               <a:spcBef>
                 <a:spcPts val="0"/>
               </a:spcBef>
@@ -3698,7 +3810,7 @@
               <a:buChar char="○"/>
               <a:defRPr sz="1200"/>
             </a:lvl2pPr>
-            <a:lvl3pPr indent="-304800" lvl="2" marL="1371600">
+            <a:lvl3pPr marL="1371600" lvl="2" indent="-304800">
               <a:spcBef>
                 <a:spcPts val="0"/>
               </a:spcBef>
@@ -3709,7 +3821,7 @@
               <a:buChar char="■"/>
               <a:defRPr sz="1200"/>
             </a:lvl3pPr>
-            <a:lvl4pPr indent="-304800" lvl="3" marL="1828800">
+            <a:lvl4pPr marL="1828800" lvl="3" indent="-304800">
               <a:spcBef>
                 <a:spcPts val="0"/>
               </a:spcBef>
@@ -3720,7 +3832,7 @@
               <a:buChar char="●"/>
               <a:defRPr sz="1200"/>
             </a:lvl4pPr>
-            <a:lvl5pPr indent="-304800" lvl="4" marL="2286000">
+            <a:lvl5pPr marL="2286000" lvl="4" indent="-304800">
               <a:spcBef>
                 <a:spcPts val="0"/>
               </a:spcBef>
@@ -3731,7 +3843,7 @@
               <a:buChar char="○"/>
               <a:defRPr sz="1200"/>
             </a:lvl5pPr>
-            <a:lvl6pPr indent="-304800" lvl="5" marL="2743200">
+            <a:lvl6pPr marL="2743200" lvl="5" indent="-304800">
               <a:spcBef>
                 <a:spcPts val="0"/>
               </a:spcBef>
@@ -3742,7 +3854,7 @@
               <a:buChar char="■"/>
               <a:defRPr sz="1200"/>
             </a:lvl6pPr>
-            <a:lvl7pPr indent="-304800" lvl="6" marL="3200400">
+            <a:lvl7pPr marL="3200400" lvl="6" indent="-304800">
               <a:spcBef>
                 <a:spcPts val="0"/>
               </a:spcBef>
@@ -3753,7 +3865,7 @@
               <a:buChar char="●"/>
               <a:defRPr sz="1200"/>
             </a:lvl7pPr>
-            <a:lvl8pPr indent="-304800" lvl="7" marL="3657600">
+            <a:lvl8pPr marL="3657600" lvl="7" indent="-304800">
               <a:spcBef>
                 <a:spcPts val="0"/>
               </a:spcBef>
@@ -3764,7 +3876,7 @@
               <a:buChar char="○"/>
               <a:defRPr sz="1200"/>
             </a:lvl8pPr>
-            <a:lvl9pPr indent="-304800" lvl="8" marL="4114800">
+            <a:lvl9pPr marL="4114800" lvl="8" indent="-304800">
               <a:spcBef>
                 <a:spcPts val="0"/>
               </a:spcBef>
@@ -3776,15 +3888,19 @@
               <a:defRPr sz="1200"/>
             </a:lvl9pPr>
           </a:lstStyle>
-          <a:p/>
+          <a:p>
+            <a:endParaRPr/>
+          </a:p>
         </p:txBody>
       </p:sp>
       <p:sp>
         <p:nvSpPr>
           <p:cNvPr id="31" name="Google Shape;31;p7"/>
-          <p:cNvSpPr txBox="1"/>
+          <p:cNvSpPr txBox="1">
+            <a:spLocks noGrp="1"/>
+          </p:cNvSpPr>
           <p:nvPr>
-            <p:ph idx="12" type="sldNum"/>
+            <p:ph type="sldNum" idx="12"/>
           </p:nvPr>
         </p:nvSpPr>
         <p:spPr>
@@ -3797,7 +3913,7 @@
           </a:prstGeom>
         </p:spPr>
         <p:txBody>
-          <a:bodyPr anchorCtr="0" anchor="ctr" bIns="91425" lIns="91425" spcFirstLastPara="1" rIns="91425" wrap="square" tIns="91425">
+          <a:bodyPr spcFirstLastPara="1" wrap="square" lIns="91425" tIns="91425" rIns="91425" bIns="91425" anchor="ctr" anchorCtr="0">
             <a:normAutofit/>
           </a:bodyPr>
           <a:lstStyle>
@@ -3839,7 +3955,7 @@
             </a:lvl9pPr>
           </a:lstStyle>
           <a:p>
-            <a:pPr indent="0" lvl="0" marL="0" rtl="0" algn="r">
+            <a:pPr marL="0" lvl="0" indent="0" algn="r" rtl="0">
               <a:spcBef>
                 <a:spcPts val="0"/>
               </a:spcBef>
@@ -3865,11 +3981,11 @@
 </file>
 
 <file path=ppt/slideLayouts/slideLayout7.xml><?xml version="1.0" encoding="utf-8"?>
-<p:sldLayout xmlns:a="http://schemas.openxmlformats.org/drawingml/2006/main" xmlns:r="http://schemas.openxmlformats.org/officeDocument/2006/relationships" xmlns:mc="http://schemas.openxmlformats.org/markup-compatibility/2006" xmlns:mv="urn:schemas-microsoft-com:mac:vml" xmlns:p="http://schemas.openxmlformats.org/presentationml/2006/main" xmlns:c="http://schemas.openxmlformats.org/drawingml/2006/chart" xmlns:dgm="http://schemas.openxmlformats.org/drawingml/2006/diagram" xmlns:o="urn:schemas-microsoft-com:office:office" xmlns:v="urn:schemas-microsoft-com:vml" xmlns:pvml="urn:schemas-microsoft-com:office:powerpoint" xmlns:com="http://schemas.openxmlformats.org/drawingml/2006/compatibility" xmlns:p14="http://schemas.microsoft.com/office/powerpoint/2010/main" xmlns:p15="http://schemas.microsoft.com/office/powerpoint/2012/main" xmlns:ahyp="http://schemas.microsoft.com/office/drawing/2018/hyperlinkcolor" matchingName="Main point">
+<p:sldLayout xmlns:a="http://schemas.openxmlformats.org/drawingml/2006/main" xmlns:r="http://schemas.openxmlformats.org/officeDocument/2006/relationships" xmlns:p="http://schemas.openxmlformats.org/presentationml/2006/main" matchingName="Main point">
   <p:cSld name="MAIN_POINT">
     <p:spTree>
       <p:nvGrpSpPr>
-        <p:cNvPr id="32" name="Shape 32"/>
+        <p:cNvPr id="1" name="Shape 32"/>
         <p:cNvGrpSpPr/>
         <p:nvPr/>
       </p:nvGrpSpPr>
@@ -3884,7 +4000,9 @@
       <p:sp>
         <p:nvSpPr>
           <p:cNvPr id="33" name="Google Shape;33;p8"/>
-          <p:cNvSpPr txBox="1"/>
+          <p:cNvSpPr txBox="1">
+            <a:spLocks noGrp="1"/>
+          </p:cNvSpPr>
           <p:nvPr>
             <p:ph type="title"/>
           </p:nvPr>
@@ -3899,7 +4017,7 @@
           </a:prstGeom>
         </p:spPr>
         <p:txBody>
-          <a:bodyPr anchorCtr="0" anchor="ctr" bIns="91425" lIns="91425" spcFirstLastPara="1" rIns="91425" wrap="square" tIns="91425">
+          <a:bodyPr spcFirstLastPara="1" wrap="square" lIns="91425" tIns="91425" rIns="91425" bIns="91425" anchor="ctr" anchorCtr="0">
             <a:normAutofit/>
           </a:bodyPr>
           <a:lstStyle>
@@ -4003,15 +4121,19 @@
               <a:defRPr sz="4800"/>
             </a:lvl9pPr>
           </a:lstStyle>
-          <a:p/>
+          <a:p>
+            <a:endParaRPr/>
+          </a:p>
         </p:txBody>
       </p:sp>
       <p:sp>
         <p:nvSpPr>
           <p:cNvPr id="34" name="Google Shape;34;p8"/>
-          <p:cNvSpPr txBox="1"/>
+          <p:cNvSpPr txBox="1">
+            <a:spLocks noGrp="1"/>
+          </p:cNvSpPr>
           <p:nvPr>
-            <p:ph idx="12" type="sldNum"/>
+            <p:ph type="sldNum" idx="12"/>
           </p:nvPr>
         </p:nvSpPr>
         <p:spPr>
@@ -4024,7 +4146,7 @@
           </a:prstGeom>
         </p:spPr>
         <p:txBody>
-          <a:bodyPr anchorCtr="0" anchor="ctr" bIns="91425" lIns="91425" spcFirstLastPara="1" rIns="91425" wrap="square" tIns="91425">
+          <a:bodyPr spcFirstLastPara="1" wrap="square" lIns="91425" tIns="91425" rIns="91425" bIns="91425" anchor="ctr" anchorCtr="0">
             <a:normAutofit/>
           </a:bodyPr>
           <a:lstStyle>
@@ -4066,7 +4188,7 @@
             </a:lvl9pPr>
           </a:lstStyle>
           <a:p>
-            <a:pPr indent="0" lvl="0" marL="0" rtl="0" algn="r">
+            <a:pPr marL="0" lvl="0" indent="0" algn="r" rtl="0">
               <a:spcBef>
                 <a:spcPts val="0"/>
               </a:spcBef>
@@ -4092,11 +4214,11 @@
 </file>
 
 <file path=ppt/slideLayouts/slideLayout8.xml><?xml version="1.0" encoding="utf-8"?>
-<p:sldLayout xmlns:a="http://schemas.openxmlformats.org/drawingml/2006/main" xmlns:r="http://schemas.openxmlformats.org/officeDocument/2006/relationships" xmlns:mc="http://schemas.openxmlformats.org/markup-compatibility/2006" xmlns:mv="urn:schemas-microsoft-com:mac:vml" xmlns:p="http://schemas.openxmlformats.org/presentationml/2006/main" xmlns:c="http://schemas.openxmlformats.org/drawingml/2006/chart" xmlns:dgm="http://schemas.openxmlformats.org/drawingml/2006/diagram" xmlns:o="urn:schemas-microsoft-com:office:office" xmlns:v="urn:schemas-microsoft-com:vml" xmlns:pvml="urn:schemas-microsoft-com:office:powerpoint" xmlns:com="http://schemas.openxmlformats.org/drawingml/2006/compatibility" xmlns:p14="http://schemas.microsoft.com/office/powerpoint/2010/main" xmlns:p15="http://schemas.microsoft.com/office/powerpoint/2012/main" xmlns:ahyp="http://schemas.microsoft.com/office/drawing/2018/hyperlinkcolor" matchingName="Section title and description">
+<p:sldLayout xmlns:a="http://schemas.openxmlformats.org/drawingml/2006/main" xmlns:r="http://schemas.openxmlformats.org/officeDocument/2006/relationships" xmlns:p="http://schemas.openxmlformats.org/presentationml/2006/main" matchingName="Section title and description">
   <p:cSld name="SECTION_TITLE_AND_DESCRIPTION">
     <p:spTree>
       <p:nvGrpSpPr>
-        <p:cNvPr id="35" name="Shape 35"/>
+        <p:cNvPr id="1" name="Shape 35"/>
         <p:cNvGrpSpPr/>
         <p:nvPr/>
       </p:nvGrpSpPr>
@@ -4130,12 +4252,12 @@
           </a:ln>
         </p:spPr>
         <p:txBody>
-          <a:bodyPr anchorCtr="0" anchor="ctr" bIns="91425" lIns="91425" spcFirstLastPara="1" rIns="91425" wrap="square" tIns="91425">
+          <a:bodyPr spcFirstLastPara="1" wrap="square" lIns="91425" tIns="91425" rIns="91425" bIns="91425" anchor="ctr" anchorCtr="0">
             <a:noAutofit/>
           </a:bodyPr>
           <a:lstStyle/>
           <a:p>
-            <a:pPr indent="0" lvl="0" marL="0" rtl="0" algn="l">
+            <a:pPr marL="0" lvl="0" indent="0" algn="l" rtl="0">
               <a:spcBef>
                 <a:spcPts val="0"/>
               </a:spcBef>
@@ -4144,9 +4266,6 @@
               </a:spcAft>
               <a:buNone/>
             </a:pPr>
-            <a:r>
-              <a:t/>
-            </a:r>
             <a:endParaRPr/>
           </a:p>
         </p:txBody>
@@ -4154,7 +4273,9 @@
       <p:sp>
         <p:nvSpPr>
           <p:cNvPr id="37" name="Google Shape;37;p9"/>
-          <p:cNvSpPr txBox="1"/>
+          <p:cNvSpPr txBox="1">
+            <a:spLocks noGrp="1"/>
+          </p:cNvSpPr>
           <p:nvPr>
             <p:ph type="title"/>
           </p:nvPr>
@@ -4169,7 +4290,7 @@
           </a:prstGeom>
         </p:spPr>
         <p:txBody>
-          <a:bodyPr anchorCtr="0" anchor="b" bIns="91425" lIns="91425" spcFirstLastPara="1" rIns="91425" wrap="square" tIns="91425">
+          <a:bodyPr spcFirstLastPara="1" wrap="square" lIns="91425" tIns="91425" rIns="91425" bIns="91425" anchor="b" anchorCtr="0">
             <a:normAutofit/>
           </a:bodyPr>
           <a:lstStyle>
@@ -4273,15 +4394,19 @@
               <a:defRPr sz="4200"/>
             </a:lvl9pPr>
           </a:lstStyle>
-          <a:p/>
+          <a:p>
+            <a:endParaRPr/>
+          </a:p>
         </p:txBody>
       </p:sp>
       <p:sp>
         <p:nvSpPr>
           <p:cNvPr id="38" name="Google Shape;38;p9"/>
-          <p:cNvSpPr txBox="1"/>
+          <p:cNvSpPr txBox="1">
+            <a:spLocks noGrp="1"/>
+          </p:cNvSpPr>
           <p:nvPr>
-            <p:ph idx="1" type="subTitle"/>
+            <p:ph type="subTitle" idx="1"/>
           </p:nvPr>
         </p:nvSpPr>
         <p:spPr>
@@ -4294,7 +4419,7 @@
           </a:prstGeom>
         </p:spPr>
         <p:txBody>
-          <a:bodyPr anchorCtr="0" anchor="t" bIns="91425" lIns="91425" spcFirstLastPara="1" rIns="91425" wrap="square" tIns="91425">
+          <a:bodyPr spcFirstLastPara="1" wrap="square" lIns="91425" tIns="91425" rIns="91425" bIns="91425" anchor="t" anchorCtr="0">
             <a:normAutofit/>
           </a:bodyPr>
           <a:lstStyle>
@@ -4425,15 +4550,19 @@
               <a:defRPr sz="2100"/>
             </a:lvl9pPr>
           </a:lstStyle>
-          <a:p/>
+          <a:p>
+            <a:endParaRPr/>
+          </a:p>
         </p:txBody>
       </p:sp>
       <p:sp>
         <p:nvSpPr>
           <p:cNvPr id="39" name="Google Shape;39;p9"/>
-          <p:cNvSpPr txBox="1"/>
+          <p:cNvSpPr txBox="1">
+            <a:spLocks noGrp="1"/>
+          </p:cNvSpPr>
           <p:nvPr>
-            <p:ph idx="2" type="body"/>
+            <p:ph type="body" idx="2"/>
           </p:nvPr>
         </p:nvSpPr>
         <p:spPr>
@@ -4446,11 +4575,11 @@
           </a:prstGeom>
         </p:spPr>
         <p:txBody>
-          <a:bodyPr anchorCtr="0" anchor="ctr" bIns="91425" lIns="91425" spcFirstLastPara="1" rIns="91425" wrap="square" tIns="91425">
+          <a:bodyPr spcFirstLastPara="1" wrap="square" lIns="91425" tIns="91425" rIns="91425" bIns="91425" anchor="ctr" anchorCtr="0">
             <a:normAutofit/>
           </a:bodyPr>
           <a:lstStyle>
-            <a:lvl1pPr indent="-342900" lvl="0" marL="457200">
+            <a:lvl1pPr marL="457200" lvl="0" indent="-342900">
               <a:spcBef>
                 <a:spcPts val="0"/>
               </a:spcBef>
@@ -4461,7 +4590,7 @@
               <a:buChar char="●"/>
               <a:defRPr/>
             </a:lvl1pPr>
-            <a:lvl2pPr indent="-317500" lvl="1" marL="914400">
+            <a:lvl2pPr marL="914400" lvl="1" indent="-317500">
               <a:spcBef>
                 <a:spcPts val="0"/>
               </a:spcBef>
@@ -4472,7 +4601,7 @@
               <a:buChar char="○"/>
               <a:defRPr/>
             </a:lvl2pPr>
-            <a:lvl3pPr indent="-317500" lvl="2" marL="1371600">
+            <a:lvl3pPr marL="1371600" lvl="2" indent="-317500">
               <a:spcBef>
                 <a:spcPts val="0"/>
               </a:spcBef>
@@ -4483,7 +4612,7 @@
               <a:buChar char="■"/>
               <a:defRPr/>
             </a:lvl3pPr>
-            <a:lvl4pPr indent="-317500" lvl="3" marL="1828800">
+            <a:lvl4pPr marL="1828800" lvl="3" indent="-317500">
               <a:spcBef>
                 <a:spcPts val="0"/>
               </a:spcBef>
@@ -4494,7 +4623,7 @@
               <a:buChar char="●"/>
               <a:defRPr/>
             </a:lvl4pPr>
-            <a:lvl5pPr indent="-317500" lvl="4" marL="2286000">
+            <a:lvl5pPr marL="2286000" lvl="4" indent="-317500">
               <a:spcBef>
                 <a:spcPts val="0"/>
               </a:spcBef>
@@ -4505,7 +4634,7 @@
               <a:buChar char="○"/>
               <a:defRPr/>
             </a:lvl5pPr>
-            <a:lvl6pPr indent="-317500" lvl="5" marL="2743200">
+            <a:lvl6pPr marL="2743200" lvl="5" indent="-317500">
               <a:spcBef>
                 <a:spcPts val="0"/>
               </a:spcBef>
@@ -4516,7 +4645,7 @@
               <a:buChar char="■"/>
               <a:defRPr/>
             </a:lvl6pPr>
-            <a:lvl7pPr indent="-317500" lvl="6" marL="3200400">
+            <a:lvl7pPr marL="3200400" lvl="6" indent="-317500">
               <a:spcBef>
                 <a:spcPts val="0"/>
               </a:spcBef>
@@ -4527,7 +4656,7 @@
               <a:buChar char="●"/>
               <a:defRPr/>
             </a:lvl7pPr>
-            <a:lvl8pPr indent="-317500" lvl="7" marL="3657600">
+            <a:lvl8pPr marL="3657600" lvl="7" indent="-317500">
               <a:spcBef>
                 <a:spcPts val="0"/>
               </a:spcBef>
@@ -4538,7 +4667,7 @@
               <a:buChar char="○"/>
               <a:defRPr/>
             </a:lvl8pPr>
-            <a:lvl9pPr indent="-317500" lvl="8" marL="4114800">
+            <a:lvl9pPr marL="4114800" lvl="8" indent="-317500">
               <a:spcBef>
                 <a:spcPts val="0"/>
               </a:spcBef>
@@ -4550,15 +4679,19 @@
               <a:defRPr/>
             </a:lvl9pPr>
           </a:lstStyle>
-          <a:p/>
+          <a:p>
+            <a:endParaRPr/>
+          </a:p>
         </p:txBody>
       </p:sp>
       <p:sp>
         <p:nvSpPr>
           <p:cNvPr id="40" name="Google Shape;40;p9"/>
-          <p:cNvSpPr txBox="1"/>
+          <p:cNvSpPr txBox="1">
+            <a:spLocks noGrp="1"/>
+          </p:cNvSpPr>
           <p:nvPr>
-            <p:ph idx="12" type="sldNum"/>
+            <p:ph type="sldNum" idx="12"/>
           </p:nvPr>
         </p:nvSpPr>
         <p:spPr>
@@ -4571,7 +4704,7 @@
           </a:prstGeom>
         </p:spPr>
         <p:txBody>
-          <a:bodyPr anchorCtr="0" anchor="ctr" bIns="91425" lIns="91425" spcFirstLastPara="1" rIns="91425" wrap="square" tIns="91425">
+          <a:bodyPr spcFirstLastPara="1" wrap="square" lIns="91425" tIns="91425" rIns="91425" bIns="91425" anchor="ctr" anchorCtr="0">
             <a:normAutofit/>
           </a:bodyPr>
           <a:lstStyle>
@@ -4613,7 +4746,7 @@
             </a:lvl9pPr>
           </a:lstStyle>
           <a:p>
-            <a:pPr indent="0" lvl="0" marL="0" rtl="0" algn="r">
+            <a:pPr marL="0" lvl="0" indent="0" algn="r" rtl="0">
               <a:spcBef>
                 <a:spcPts val="0"/>
               </a:spcBef>
@@ -4639,11 +4772,11 @@
 </file>
 
 <file path=ppt/slideLayouts/slideLayout9.xml><?xml version="1.0" encoding="utf-8"?>
-<p:sldLayout xmlns:a="http://schemas.openxmlformats.org/drawingml/2006/main" xmlns:r="http://schemas.openxmlformats.org/officeDocument/2006/relationships" xmlns:mc="http://schemas.openxmlformats.org/markup-compatibility/2006" xmlns:mv="urn:schemas-microsoft-com:mac:vml" xmlns:p="http://schemas.openxmlformats.org/presentationml/2006/main" xmlns:c="http://schemas.openxmlformats.org/drawingml/2006/chart" xmlns:dgm="http://schemas.openxmlformats.org/drawingml/2006/diagram" xmlns:o="urn:schemas-microsoft-com:office:office" xmlns:v="urn:schemas-microsoft-com:vml" xmlns:pvml="urn:schemas-microsoft-com:office:powerpoint" xmlns:com="http://schemas.openxmlformats.org/drawingml/2006/compatibility" xmlns:p14="http://schemas.microsoft.com/office/powerpoint/2010/main" xmlns:p15="http://schemas.microsoft.com/office/powerpoint/2012/main" xmlns:ahyp="http://schemas.microsoft.com/office/drawing/2018/hyperlinkcolor" matchingName="Caption">
+<p:sldLayout xmlns:a="http://schemas.openxmlformats.org/drawingml/2006/main" xmlns:r="http://schemas.openxmlformats.org/officeDocument/2006/relationships" xmlns:p="http://schemas.openxmlformats.org/presentationml/2006/main" matchingName="Caption">
   <p:cSld name="CAPTION_ONLY">
     <p:spTree>
       <p:nvGrpSpPr>
-        <p:cNvPr id="41" name="Shape 41"/>
+        <p:cNvPr id="1" name="Shape 41"/>
         <p:cNvGrpSpPr/>
         <p:nvPr/>
       </p:nvGrpSpPr>
@@ -4658,9 +4791,11 @@
       <p:sp>
         <p:nvSpPr>
           <p:cNvPr id="42" name="Google Shape;42;p10"/>
-          <p:cNvSpPr txBox="1"/>
+          <p:cNvSpPr txBox="1">
+            <a:spLocks noGrp="1"/>
+          </p:cNvSpPr>
           <p:nvPr>
-            <p:ph idx="1" type="body"/>
+            <p:ph type="body" idx="1"/>
           </p:nvPr>
         </p:nvSpPr>
         <p:spPr>
@@ -4673,11 +4808,11 @@
           </a:prstGeom>
         </p:spPr>
         <p:txBody>
-          <a:bodyPr anchorCtr="0" anchor="ctr" bIns="91425" lIns="91425" spcFirstLastPara="1" rIns="91425" wrap="square" tIns="91425">
+          <a:bodyPr spcFirstLastPara="1" wrap="square" lIns="91425" tIns="91425" rIns="91425" bIns="91425" anchor="ctr" anchorCtr="0">
             <a:normAutofit/>
           </a:bodyPr>
           <a:lstStyle>
-            <a:lvl1pPr indent="-228600" lvl="0" marL="457200">
+            <a:lvl1pPr marL="457200" lvl="0" indent="-228600">
               <a:lnSpc>
                 <a:spcPct val="100000"/>
               </a:lnSpc>
@@ -4692,15 +4827,19 @@
               <a:defRPr/>
             </a:lvl1pPr>
           </a:lstStyle>
-          <a:p/>
+          <a:p>
+            <a:endParaRPr/>
+          </a:p>
         </p:txBody>
       </p:sp>
       <p:sp>
         <p:nvSpPr>
           <p:cNvPr id="43" name="Google Shape;43;p10"/>
-          <p:cNvSpPr txBox="1"/>
+          <p:cNvSpPr txBox="1">
+            <a:spLocks noGrp="1"/>
+          </p:cNvSpPr>
           <p:nvPr>
-            <p:ph idx="12" type="sldNum"/>
+            <p:ph type="sldNum" idx="12"/>
           </p:nvPr>
         </p:nvSpPr>
         <p:spPr>
@@ -4713,7 +4852,7 @@
           </a:prstGeom>
         </p:spPr>
         <p:txBody>
-          <a:bodyPr anchorCtr="0" anchor="ctr" bIns="91425" lIns="91425" spcFirstLastPara="1" rIns="91425" wrap="square" tIns="91425">
+          <a:bodyPr spcFirstLastPara="1" wrap="square" lIns="91425" tIns="91425" rIns="91425" bIns="91425" anchor="ctr" anchorCtr="0">
             <a:normAutofit/>
           </a:bodyPr>
           <a:lstStyle>
@@ -4755,7 +4894,7 @@
             </a:lvl9pPr>
           </a:lstStyle>
           <a:p>
-            <a:pPr indent="0" lvl="0" marL="0" rtl="0" algn="r">
+            <a:pPr marL="0" lvl="0" indent="0" algn="r" rtl="0">
               <a:spcBef>
                 <a:spcPts val="0"/>
               </a:spcBef>
@@ -4781,18 +4920,19 @@
 </file>
 
 <file path=ppt/slideMasters/slideMaster1.xml><?xml version="1.0" encoding="utf-8"?>
-<p:sldMaster xmlns:a="http://schemas.openxmlformats.org/drawingml/2006/main" xmlns:r="http://schemas.openxmlformats.org/officeDocument/2006/relationships" xmlns:mc="http://schemas.openxmlformats.org/markup-compatibility/2006" xmlns:mv="urn:schemas-microsoft-com:mac:vml" xmlns:p="http://schemas.openxmlformats.org/presentationml/2006/main" xmlns:c="http://schemas.openxmlformats.org/drawingml/2006/chart" xmlns:dgm="http://schemas.openxmlformats.org/drawingml/2006/diagram" xmlns:o="urn:schemas-microsoft-com:office:office" xmlns:v="urn:schemas-microsoft-com:vml" xmlns:pvml="urn:schemas-microsoft-com:office:powerpoint" xmlns:com="http://schemas.openxmlformats.org/drawingml/2006/compatibility" xmlns:p14="http://schemas.microsoft.com/office/powerpoint/2010/main" xmlns:p15="http://schemas.microsoft.com/office/powerpoint/2012/main" xmlns:ahyp="http://schemas.microsoft.com/office/drawing/2018/hyperlinkcolor">
+<p:sldMaster xmlns:a="http://schemas.openxmlformats.org/drawingml/2006/main" xmlns:r="http://schemas.openxmlformats.org/officeDocument/2006/relationships" xmlns:p="http://schemas.openxmlformats.org/presentationml/2006/main">
   <p:cSld name="simple-light-2">
     <p:bg>
       <p:bgPr>
         <a:solidFill>
           <a:schemeClr val="lt1"/>
         </a:solidFill>
+        <a:effectLst/>
       </p:bgPr>
     </p:bg>
     <p:spTree>
       <p:nvGrpSpPr>
-        <p:cNvPr id="5" name="Shape 5"/>
+        <p:cNvPr id="1" name="Shape 5"/>
         <p:cNvGrpSpPr/>
         <p:nvPr/>
       </p:nvGrpSpPr>
@@ -4807,7 +4947,9 @@
       <p:sp>
         <p:nvSpPr>
           <p:cNvPr id="6" name="Google Shape;6;p1"/>
-          <p:cNvSpPr txBox="1"/>
+          <p:cNvSpPr txBox="1">
+            <a:spLocks noGrp="1"/>
+          </p:cNvSpPr>
           <p:nvPr>
             <p:ph type="title"/>
           </p:nvPr>
@@ -4826,7 +4968,7 @@
           </a:ln>
         </p:spPr>
         <p:txBody>
-          <a:bodyPr anchorCtr="0" anchor="t" bIns="91425" lIns="91425" spcFirstLastPara="1" rIns="91425" wrap="square" tIns="91425">
+          <a:bodyPr spcFirstLastPara="1" wrap="square" lIns="91425" tIns="91425" rIns="91425" bIns="91425" anchor="t" anchorCtr="0">
             <a:normAutofit/>
           </a:bodyPr>
           <a:lstStyle>
@@ -4993,15 +5135,19 @@
               </a:defRPr>
             </a:lvl9pPr>
           </a:lstStyle>
-          <a:p/>
+          <a:p>
+            <a:endParaRPr/>
+          </a:p>
         </p:txBody>
       </p:sp>
       <p:sp>
         <p:nvSpPr>
           <p:cNvPr id="7" name="Google Shape;7;p1"/>
-          <p:cNvSpPr txBox="1"/>
+          <p:cNvSpPr txBox="1">
+            <a:spLocks noGrp="1"/>
+          </p:cNvSpPr>
           <p:nvPr>
-            <p:ph idx="1" type="body"/>
+            <p:ph type="body" idx="1"/>
           </p:nvPr>
         </p:nvSpPr>
         <p:spPr>
@@ -5018,11 +5164,11 @@
           </a:ln>
         </p:spPr>
         <p:txBody>
-          <a:bodyPr anchorCtr="0" anchor="t" bIns="91425" lIns="91425" spcFirstLastPara="1" rIns="91425" wrap="square" tIns="91425">
+          <a:bodyPr spcFirstLastPara="1" wrap="square" lIns="91425" tIns="91425" rIns="91425" bIns="91425" anchor="t" anchorCtr="0">
             <a:normAutofit/>
           </a:bodyPr>
           <a:lstStyle>
-            <a:lvl1pPr indent="-342900" lvl="0" marL="457200">
+            <a:lvl1pPr marL="457200" lvl="0" indent="-342900">
               <a:lnSpc>
                 <a:spcPct val="115000"/>
               </a:lnSpc>
@@ -5043,7 +5189,7 @@
                 </a:solidFill>
               </a:defRPr>
             </a:lvl1pPr>
-            <a:lvl2pPr indent="-317500" lvl="1" marL="914400">
+            <a:lvl2pPr marL="914400" lvl="1" indent="-317500">
               <a:lnSpc>
                 <a:spcPct val="115000"/>
               </a:lnSpc>
@@ -5064,7 +5210,7 @@
                 </a:solidFill>
               </a:defRPr>
             </a:lvl2pPr>
-            <a:lvl3pPr indent="-317500" lvl="2" marL="1371600">
+            <a:lvl3pPr marL="1371600" lvl="2" indent="-317500">
               <a:lnSpc>
                 <a:spcPct val="115000"/>
               </a:lnSpc>
@@ -5085,7 +5231,7 @@
                 </a:solidFill>
               </a:defRPr>
             </a:lvl3pPr>
-            <a:lvl4pPr indent="-317500" lvl="3" marL="1828800">
+            <a:lvl4pPr marL="1828800" lvl="3" indent="-317500">
               <a:lnSpc>
                 <a:spcPct val="115000"/>
               </a:lnSpc>
@@ -5106,7 +5252,7 @@
                 </a:solidFill>
               </a:defRPr>
             </a:lvl4pPr>
-            <a:lvl5pPr indent="-317500" lvl="4" marL="2286000">
+            <a:lvl5pPr marL="2286000" lvl="4" indent="-317500">
               <a:lnSpc>
                 <a:spcPct val="115000"/>
               </a:lnSpc>
@@ -5127,7 +5273,7 @@
                 </a:solidFill>
               </a:defRPr>
             </a:lvl5pPr>
-            <a:lvl6pPr indent="-317500" lvl="5" marL="2743200">
+            <a:lvl6pPr marL="2743200" lvl="5" indent="-317500">
               <a:lnSpc>
                 <a:spcPct val="115000"/>
               </a:lnSpc>
@@ -5148,7 +5294,7 @@
                 </a:solidFill>
               </a:defRPr>
             </a:lvl6pPr>
-            <a:lvl7pPr indent="-317500" lvl="6" marL="3200400">
+            <a:lvl7pPr marL="3200400" lvl="6" indent="-317500">
               <a:lnSpc>
                 <a:spcPct val="115000"/>
               </a:lnSpc>
@@ -5169,7 +5315,7 @@
                 </a:solidFill>
               </a:defRPr>
             </a:lvl7pPr>
-            <a:lvl8pPr indent="-317500" lvl="7" marL="3657600">
+            <a:lvl8pPr marL="3657600" lvl="7" indent="-317500">
               <a:lnSpc>
                 <a:spcPct val="115000"/>
               </a:lnSpc>
@@ -5190,7 +5336,7 @@
                 </a:solidFill>
               </a:defRPr>
             </a:lvl8pPr>
-            <a:lvl9pPr indent="-317500" lvl="8" marL="4114800">
+            <a:lvl9pPr marL="4114800" lvl="8" indent="-317500">
               <a:lnSpc>
                 <a:spcPct val="115000"/>
               </a:lnSpc>
@@ -5212,15 +5358,19 @@
               </a:defRPr>
             </a:lvl9pPr>
           </a:lstStyle>
-          <a:p/>
+          <a:p>
+            <a:endParaRPr/>
+          </a:p>
         </p:txBody>
       </p:sp>
       <p:sp>
         <p:nvSpPr>
           <p:cNvPr id="8" name="Google Shape;8;p1"/>
-          <p:cNvSpPr txBox="1"/>
+          <p:cNvSpPr txBox="1">
+            <a:spLocks noGrp="1"/>
+          </p:cNvSpPr>
           <p:nvPr>
-            <p:ph idx="12" type="sldNum"/>
+            <p:ph type="sldNum" idx="12"/>
           </p:nvPr>
         </p:nvSpPr>
         <p:spPr>
@@ -5237,7 +5387,7 @@
           </a:ln>
         </p:spPr>
         <p:txBody>
-          <a:bodyPr anchorCtr="0" anchor="ctr" bIns="91425" lIns="91425" spcFirstLastPara="1" rIns="91425" wrap="square" tIns="91425">
+          <a:bodyPr spcFirstLastPara="1" wrap="square" lIns="91425" tIns="91425" rIns="91425" bIns="91425" anchor="ctr" anchorCtr="0">
             <a:normAutofit/>
           </a:bodyPr>
           <a:lstStyle>
@@ -5315,7 +5465,7 @@
             </a:lvl9pPr>
           </a:lstStyle>
           <a:p>
-            <a:pPr indent="0" lvl="0" marL="0" rtl="0" algn="r">
+            <a:pPr marL="0" lvl="0" indent="0" algn="r" rtl="0">
               <a:spcBef>
                 <a:spcPts val="0"/>
               </a:spcBef>
@@ -5334,7 +5484,7 @@
       </p:sp>
     </p:spTree>
   </p:cSld>
-  <p:clrMap accent1="accent1" accent2="accent2" accent3="accent3" accent4="accent4" accent5="accent5" accent6="accent6" bg1="lt1" bg2="dk2" tx1="dk1" tx2="lt2" folHlink="folHlink" hlink="hlink"/>
+  <p:clrMap bg1="lt1" tx1="dk1" bg2="dk2" tx2="lt2" accent1="accent1" accent2="accent2" accent3="accent3" accent4="accent4" accent5="accent5" accent6="accent6" hlink="hlink" folHlink="folHlink"/>
   <p:sldLayoutIdLst>
     <p:sldLayoutId id="2147483648" r:id="rId1"/>
     <p:sldLayoutId id="2147483649" r:id="rId2"/>
@@ -5348,10 +5498,10 @@
     <p:sldLayoutId id="2147483657" r:id="rId10"/>
     <p:sldLayoutId id="2147483658" r:id="rId11"/>
   </p:sldLayoutIdLst>
-  <p:hf dt="0" ftr="0" hdr="0" sldNum="0"/>
+  <p:hf sldNum="0" hdr="0" ftr="0" dt="0"/>
   <p:txStyles>
     <p:titleStyle>
-      <a:defPPr lvl="0" marR="0" rtl="0" algn="l">
+      <a:defPPr marR="0" lvl="0" algn="l" rtl="0">
         <a:lnSpc>
           <a:spcPct val="100000"/>
         </a:lnSpc>
@@ -5362,7 +5512,7 @@
           <a:spcPts val="0"/>
         </a:spcAft>
       </a:defPPr>
-      <a:lvl1pPr lvl="0" marR="0" rtl="0" algn="l">
+      <a:lvl1pPr marR="0" lvl="0" algn="l" rtl="0">
         <a:lnSpc>
           <a:spcPct val="100000"/>
         </a:lnSpc>
@@ -5376,7 +5526,7 @@
           <a:srgbClr val="000000"/>
         </a:buClr>
         <a:buFont typeface="Arial"/>
-        <a:defRPr b="0" i="0" spc="0" sz="1400" u="none" cap="none" strike="noStrike">
+        <a:defRPr sz="1400" b="0" i="0" u="none" strike="noStrike" cap="none" spc="0">
           <a:solidFill>
             <a:srgbClr val="000000"/>
           </a:solidFill>
@@ -5386,7 +5536,7 @@
           <a:sym typeface="Arial"/>
         </a:defRPr>
       </a:lvl1pPr>
-      <a:lvl2pPr lvl="1" marR="0" rtl="0" algn="l">
+      <a:lvl2pPr marR="0" lvl="1" algn="l" rtl="0">
         <a:lnSpc>
           <a:spcPct val="100000"/>
         </a:lnSpc>
@@ -5400,7 +5550,7 @@
           <a:srgbClr val="000000"/>
         </a:buClr>
         <a:buFont typeface="Arial"/>
-        <a:defRPr b="0" i="0" spc="0" sz="1400" u="none" cap="none" strike="noStrike">
+        <a:defRPr sz="1400" b="0" i="0" u="none" strike="noStrike" cap="none" spc="0">
           <a:solidFill>
             <a:srgbClr val="000000"/>
           </a:solidFill>
@@ -5410,7 +5560,7 @@
           <a:sym typeface="Arial"/>
         </a:defRPr>
       </a:lvl2pPr>
-      <a:lvl3pPr lvl="2" marR="0" rtl="0" algn="l">
+      <a:lvl3pPr marR="0" lvl="2" algn="l" rtl="0">
         <a:lnSpc>
           <a:spcPct val="100000"/>
         </a:lnSpc>
@@ -5424,7 +5574,7 @@
           <a:srgbClr val="000000"/>
         </a:buClr>
         <a:buFont typeface="Arial"/>
-        <a:defRPr b="0" i="0" spc="0" sz="1400" u="none" cap="none" strike="noStrike">
+        <a:defRPr sz="1400" b="0" i="0" u="none" strike="noStrike" cap="none" spc="0">
           <a:solidFill>
             <a:srgbClr val="000000"/>
           </a:solidFill>
@@ -5434,7 +5584,7 @@
           <a:sym typeface="Arial"/>
         </a:defRPr>
       </a:lvl3pPr>
-      <a:lvl4pPr lvl="3" marR="0" rtl="0" algn="l">
+      <a:lvl4pPr marR="0" lvl="3" algn="l" rtl="0">
         <a:lnSpc>
           <a:spcPct val="100000"/>
         </a:lnSpc>
@@ -5448,7 +5598,7 @@
           <a:srgbClr val="000000"/>
         </a:buClr>
         <a:buFont typeface="Arial"/>
-        <a:defRPr b="0" i="0" spc="0" sz="1400" u="none" cap="none" strike="noStrike">
+        <a:defRPr sz="1400" b="0" i="0" u="none" strike="noStrike" cap="none" spc="0">
           <a:solidFill>
             <a:srgbClr val="000000"/>
           </a:solidFill>
@@ -5458,7 +5608,7 @@
           <a:sym typeface="Arial"/>
         </a:defRPr>
       </a:lvl4pPr>
-      <a:lvl5pPr lvl="4" marR="0" rtl="0" algn="l">
+      <a:lvl5pPr marR="0" lvl="4" algn="l" rtl="0">
         <a:lnSpc>
           <a:spcPct val="100000"/>
         </a:lnSpc>
@@ -5472,7 +5622,7 @@
           <a:srgbClr val="000000"/>
         </a:buClr>
         <a:buFont typeface="Arial"/>
-        <a:defRPr b="0" i="0" spc="0" sz="1400" u="none" cap="none" strike="noStrike">
+        <a:defRPr sz="1400" b="0" i="0" u="none" strike="noStrike" cap="none" spc="0">
           <a:solidFill>
             <a:srgbClr val="000000"/>
           </a:solidFill>
@@ -5482,7 +5632,7 @@
           <a:sym typeface="Arial"/>
         </a:defRPr>
       </a:lvl5pPr>
-      <a:lvl6pPr lvl="5" marR="0" rtl="0" algn="l">
+      <a:lvl6pPr marR="0" lvl="5" algn="l" rtl="0">
         <a:lnSpc>
           <a:spcPct val="100000"/>
         </a:lnSpc>
@@ -5496,7 +5646,7 @@
           <a:srgbClr val="000000"/>
         </a:buClr>
         <a:buFont typeface="Arial"/>
-        <a:defRPr b="0" i="0" spc="0" sz="1400" u="none" cap="none" strike="noStrike">
+        <a:defRPr sz="1400" b="0" i="0" u="none" strike="noStrike" cap="none" spc="0">
           <a:solidFill>
             <a:srgbClr val="000000"/>
           </a:solidFill>
@@ -5506,7 +5656,7 @@
           <a:sym typeface="Arial"/>
         </a:defRPr>
       </a:lvl6pPr>
-      <a:lvl7pPr lvl="6" marR="0" rtl="0" algn="l">
+      <a:lvl7pPr marR="0" lvl="6" algn="l" rtl="0">
         <a:lnSpc>
           <a:spcPct val="100000"/>
         </a:lnSpc>
@@ -5520,7 +5670,7 @@
           <a:srgbClr val="000000"/>
         </a:buClr>
         <a:buFont typeface="Arial"/>
-        <a:defRPr b="0" i="0" spc="0" sz="1400" u="none" cap="none" strike="noStrike">
+        <a:defRPr sz="1400" b="0" i="0" u="none" strike="noStrike" cap="none" spc="0">
           <a:solidFill>
             <a:srgbClr val="000000"/>
           </a:solidFill>
@@ -5530,7 +5680,7 @@
           <a:sym typeface="Arial"/>
         </a:defRPr>
       </a:lvl7pPr>
-      <a:lvl8pPr lvl="7" marR="0" rtl="0" algn="l">
+      <a:lvl8pPr marR="0" lvl="7" algn="l" rtl="0">
         <a:lnSpc>
           <a:spcPct val="100000"/>
         </a:lnSpc>
@@ -5544,7 +5694,7 @@
           <a:srgbClr val="000000"/>
         </a:buClr>
         <a:buFont typeface="Arial"/>
-        <a:defRPr b="0" i="0" spc="0" sz="1400" u="none" cap="none" strike="noStrike">
+        <a:defRPr sz="1400" b="0" i="0" u="none" strike="noStrike" cap="none" spc="0">
           <a:solidFill>
             <a:srgbClr val="000000"/>
           </a:solidFill>
@@ -5554,7 +5704,7 @@
           <a:sym typeface="Arial"/>
         </a:defRPr>
       </a:lvl8pPr>
-      <a:lvl9pPr lvl="8" marR="0" rtl="0" algn="l">
+      <a:lvl9pPr marR="0" lvl="8" algn="l" rtl="0">
         <a:lnSpc>
           <a:spcPct val="100000"/>
         </a:lnSpc>
@@ -5568,7 +5718,7 @@
           <a:srgbClr val="000000"/>
         </a:buClr>
         <a:buFont typeface="Arial"/>
-        <a:defRPr b="0" i="0" spc="0" sz="1400" u="none" cap="none" strike="noStrike">
+        <a:defRPr sz="1400" b="0" i="0" u="none" strike="noStrike" cap="none" spc="0">
           <a:solidFill>
             <a:srgbClr val="000000"/>
           </a:solidFill>
@@ -5580,7 +5730,7 @@
       </a:lvl9pPr>
     </p:titleStyle>
     <p:bodyStyle>
-      <a:defPPr lvl="0" marR="0" rtl="0" algn="l">
+      <a:defPPr marR="0" lvl="0" algn="l" rtl="0">
         <a:lnSpc>
           <a:spcPct val="100000"/>
         </a:lnSpc>
@@ -5591,7 +5741,7 @@
           <a:spcPts val="0"/>
         </a:spcAft>
       </a:defPPr>
-      <a:lvl1pPr lvl="0" marR="0" rtl="0" algn="l">
+      <a:lvl1pPr marR="0" lvl="0" algn="l" rtl="0">
         <a:lnSpc>
           <a:spcPct val="100000"/>
         </a:lnSpc>
@@ -5605,7 +5755,7 @@
           <a:srgbClr val="000000"/>
         </a:buClr>
         <a:buFont typeface="Arial"/>
-        <a:defRPr b="0" i="0" spc="0" sz="1400" u="none" cap="none" strike="noStrike">
+        <a:defRPr sz="1400" b="0" i="0" u="none" strike="noStrike" cap="none" spc="0">
           <a:solidFill>
             <a:srgbClr val="000000"/>
           </a:solidFill>
@@ -5615,7 +5765,7 @@
           <a:sym typeface="Arial"/>
         </a:defRPr>
       </a:lvl1pPr>
-      <a:lvl2pPr lvl="1" marR="0" rtl="0" algn="l">
+      <a:lvl2pPr marR="0" lvl="1" algn="l" rtl="0">
         <a:lnSpc>
           <a:spcPct val="100000"/>
         </a:lnSpc>
@@ -5629,7 +5779,7 @@
           <a:srgbClr val="000000"/>
         </a:buClr>
         <a:buFont typeface="Arial"/>
-        <a:defRPr b="0" i="0" spc="0" sz="1400" u="none" cap="none" strike="noStrike">
+        <a:defRPr sz="1400" b="0" i="0" u="none" strike="noStrike" cap="none" spc="0">
           <a:solidFill>
             <a:srgbClr val="000000"/>
           </a:solidFill>
@@ -5639,7 +5789,7 @@
           <a:sym typeface="Arial"/>
         </a:defRPr>
       </a:lvl2pPr>
-      <a:lvl3pPr lvl="2" marR="0" rtl="0" algn="l">
+      <a:lvl3pPr marR="0" lvl="2" algn="l" rtl="0">
         <a:lnSpc>
           <a:spcPct val="100000"/>
         </a:lnSpc>
@@ -5653,7 +5803,7 @@
           <a:srgbClr val="000000"/>
         </a:buClr>
         <a:buFont typeface="Arial"/>
-        <a:defRPr b="0" i="0" spc="0" sz="1400" u="none" cap="none" strike="noStrike">
+        <a:defRPr sz="1400" b="0" i="0" u="none" strike="noStrike" cap="none" spc="0">
           <a:solidFill>
             <a:srgbClr val="000000"/>
           </a:solidFill>
@@ -5663,7 +5813,7 @@
           <a:sym typeface="Arial"/>
         </a:defRPr>
       </a:lvl3pPr>
-      <a:lvl4pPr lvl="3" marR="0" rtl="0" algn="l">
+      <a:lvl4pPr marR="0" lvl="3" algn="l" rtl="0">
         <a:lnSpc>
           <a:spcPct val="100000"/>
         </a:lnSpc>
@@ -5677,7 +5827,7 @@
           <a:srgbClr val="000000"/>
         </a:buClr>
         <a:buFont typeface="Arial"/>
-        <a:defRPr b="0" i="0" spc="0" sz="1400" u="none" cap="none" strike="noStrike">
+        <a:defRPr sz="1400" b="0" i="0" u="none" strike="noStrike" cap="none" spc="0">
           <a:solidFill>
             <a:srgbClr val="000000"/>
           </a:solidFill>
@@ -5687,7 +5837,7 @@
           <a:sym typeface="Arial"/>
         </a:defRPr>
       </a:lvl4pPr>
-      <a:lvl5pPr lvl="4" marR="0" rtl="0" algn="l">
+      <a:lvl5pPr marR="0" lvl="4" algn="l" rtl="0">
         <a:lnSpc>
           <a:spcPct val="100000"/>
         </a:lnSpc>
@@ -5701,7 +5851,7 @@
           <a:srgbClr val="000000"/>
         </a:buClr>
         <a:buFont typeface="Arial"/>
-        <a:defRPr b="0" i="0" spc="0" sz="1400" u="none" cap="none" strike="noStrike">
+        <a:defRPr sz="1400" b="0" i="0" u="none" strike="noStrike" cap="none" spc="0">
           <a:solidFill>
             <a:srgbClr val="000000"/>
           </a:solidFill>
@@ -5711,7 +5861,7 @@
           <a:sym typeface="Arial"/>
         </a:defRPr>
       </a:lvl5pPr>
-      <a:lvl6pPr lvl="5" marR="0" rtl="0" algn="l">
+      <a:lvl6pPr marR="0" lvl="5" algn="l" rtl="0">
         <a:lnSpc>
           <a:spcPct val="100000"/>
         </a:lnSpc>
@@ -5725,7 +5875,7 @@
           <a:srgbClr val="000000"/>
         </a:buClr>
         <a:buFont typeface="Arial"/>
-        <a:defRPr b="0" i="0" spc="0" sz="1400" u="none" cap="none" strike="noStrike">
+        <a:defRPr sz="1400" b="0" i="0" u="none" strike="noStrike" cap="none" spc="0">
           <a:solidFill>
             <a:srgbClr val="000000"/>
           </a:solidFill>
@@ -5735,7 +5885,7 @@
           <a:sym typeface="Arial"/>
         </a:defRPr>
       </a:lvl6pPr>
-      <a:lvl7pPr lvl="6" marR="0" rtl="0" algn="l">
+      <a:lvl7pPr marR="0" lvl="6" algn="l" rtl="0">
         <a:lnSpc>
           <a:spcPct val="100000"/>
         </a:lnSpc>
@@ -5749,7 +5899,7 @@
           <a:srgbClr val="000000"/>
         </a:buClr>
         <a:buFont typeface="Arial"/>
-        <a:defRPr b="0" i="0" spc="0" sz="1400" u="none" cap="none" strike="noStrike">
+        <a:defRPr sz="1400" b="0" i="0" u="none" strike="noStrike" cap="none" spc="0">
           <a:solidFill>
             <a:srgbClr val="000000"/>
           </a:solidFill>
@@ -5759,7 +5909,7 @@
           <a:sym typeface="Arial"/>
         </a:defRPr>
       </a:lvl7pPr>
-      <a:lvl8pPr lvl="7" marR="0" rtl="0" algn="l">
+      <a:lvl8pPr marR="0" lvl="7" algn="l" rtl="0">
         <a:lnSpc>
           <a:spcPct val="100000"/>
         </a:lnSpc>
@@ -5773,7 +5923,7 @@
           <a:srgbClr val="000000"/>
         </a:buClr>
         <a:buFont typeface="Arial"/>
-        <a:defRPr b="0" i="0" spc="0" sz="1400" u="none" cap="none" strike="noStrike">
+        <a:defRPr sz="1400" b="0" i="0" u="none" strike="noStrike" cap="none" spc="0">
           <a:solidFill>
             <a:srgbClr val="000000"/>
           </a:solidFill>
@@ -5783,7 +5933,7 @@
           <a:sym typeface="Arial"/>
         </a:defRPr>
       </a:lvl8pPr>
-      <a:lvl9pPr lvl="8" marR="0" rtl="0" algn="l">
+      <a:lvl9pPr marR="0" lvl="8" algn="l" rtl="0">
         <a:lnSpc>
           <a:spcPct val="100000"/>
         </a:lnSpc>
@@ -5797,7 +5947,7 @@
           <a:srgbClr val="000000"/>
         </a:buClr>
         <a:buFont typeface="Arial"/>
-        <a:defRPr b="0" i="0" spc="0" sz="1400" u="none" cap="none" strike="noStrike">
+        <a:defRPr sz="1400" b="0" i="0" u="none" strike="noStrike" cap="none" spc="0">
           <a:solidFill>
             <a:srgbClr val="000000"/>
           </a:solidFill>
@@ -5809,7 +5959,7 @@
       </a:lvl9pPr>
     </p:bodyStyle>
     <p:otherStyle>
-      <a:defPPr lvl="0" marR="0" rtl="0" algn="l">
+      <a:defPPr marR="0" lvl="0" algn="l" rtl="0">
         <a:lnSpc>
           <a:spcPct val="100000"/>
         </a:lnSpc>
@@ -5820,7 +5970,7 @@
           <a:spcPts val="0"/>
         </a:spcAft>
       </a:defPPr>
-      <a:lvl1pPr lvl="0" marR="0" rtl="0" algn="l">
+      <a:lvl1pPr marR="0" lvl="0" algn="l" rtl="0">
         <a:lnSpc>
           <a:spcPct val="100000"/>
         </a:lnSpc>
@@ -5834,7 +5984,7 @@
           <a:srgbClr val="000000"/>
         </a:buClr>
         <a:buFont typeface="Arial"/>
-        <a:defRPr b="0" i="0" spc="0" sz="1400" u="none" cap="none" strike="noStrike">
+        <a:defRPr sz="1400" b="0" i="0" u="none" strike="noStrike" cap="none" spc="0">
           <a:solidFill>
             <a:srgbClr val="000000"/>
           </a:solidFill>
@@ -5844,7 +5994,7 @@
           <a:sym typeface="Arial"/>
         </a:defRPr>
       </a:lvl1pPr>
-      <a:lvl2pPr lvl="1" marR="0" rtl="0" algn="l">
+      <a:lvl2pPr marR="0" lvl="1" algn="l" rtl="0">
         <a:lnSpc>
           <a:spcPct val="100000"/>
         </a:lnSpc>
@@ -5858,7 +6008,7 @@
           <a:srgbClr val="000000"/>
         </a:buClr>
         <a:buFont typeface="Arial"/>
-        <a:defRPr b="0" i="0" spc="0" sz="1400" u="none" cap="none" strike="noStrike">
+        <a:defRPr sz="1400" b="0" i="0" u="none" strike="noStrike" cap="none" spc="0">
           <a:solidFill>
             <a:srgbClr val="000000"/>
           </a:solidFill>
@@ -5868,7 +6018,7 @@
           <a:sym typeface="Arial"/>
         </a:defRPr>
       </a:lvl2pPr>
-      <a:lvl3pPr lvl="2" marR="0" rtl="0" algn="l">
+      <a:lvl3pPr marR="0" lvl="2" algn="l" rtl="0">
         <a:lnSpc>
           <a:spcPct val="100000"/>
         </a:lnSpc>
@@ -5882,7 +6032,7 @@
           <a:srgbClr val="000000"/>
         </a:buClr>
         <a:buFont typeface="Arial"/>
-        <a:defRPr b="0" i="0" spc="0" sz="1400" u="none" cap="none" strike="noStrike">
+        <a:defRPr sz="1400" b="0" i="0" u="none" strike="noStrike" cap="none" spc="0">
           <a:solidFill>
             <a:srgbClr val="000000"/>
           </a:solidFill>
@@ -5892,7 +6042,7 @@
           <a:sym typeface="Arial"/>
         </a:defRPr>
       </a:lvl3pPr>
-      <a:lvl4pPr lvl="3" marR="0" rtl="0" algn="l">
+      <a:lvl4pPr marR="0" lvl="3" algn="l" rtl="0">
         <a:lnSpc>
           <a:spcPct val="100000"/>
         </a:lnSpc>
@@ -5906,7 +6056,7 @@
           <a:srgbClr val="000000"/>
         </a:buClr>
         <a:buFont typeface="Arial"/>
-        <a:defRPr b="0" i="0" spc="0" sz="1400" u="none" cap="none" strike="noStrike">
+        <a:defRPr sz="1400" b="0" i="0" u="none" strike="noStrike" cap="none" spc="0">
           <a:solidFill>
             <a:srgbClr val="000000"/>
           </a:solidFill>
@@ -5916,7 +6066,7 @@
           <a:sym typeface="Arial"/>
         </a:defRPr>
       </a:lvl4pPr>
-      <a:lvl5pPr lvl="4" marR="0" rtl="0" algn="l">
+      <a:lvl5pPr marR="0" lvl="4" algn="l" rtl="0">
         <a:lnSpc>
           <a:spcPct val="100000"/>
         </a:lnSpc>
@@ -5930,7 +6080,7 @@
           <a:srgbClr val="000000"/>
         </a:buClr>
         <a:buFont typeface="Arial"/>
-        <a:defRPr b="0" i="0" spc="0" sz="1400" u="none" cap="none" strike="noStrike">
+        <a:defRPr sz="1400" b="0" i="0" u="none" strike="noStrike" cap="none" spc="0">
           <a:solidFill>
             <a:srgbClr val="000000"/>
           </a:solidFill>
@@ -5940,7 +6090,7 @@
           <a:sym typeface="Arial"/>
         </a:defRPr>
       </a:lvl5pPr>
-      <a:lvl6pPr lvl="5" marR="0" rtl="0" algn="l">
+      <a:lvl6pPr marR="0" lvl="5" algn="l" rtl="0">
         <a:lnSpc>
           <a:spcPct val="100000"/>
         </a:lnSpc>
@@ -5954,7 +6104,7 @@
           <a:srgbClr val="000000"/>
         </a:buClr>
         <a:buFont typeface="Arial"/>
-        <a:defRPr b="0" i="0" spc="0" sz="1400" u="none" cap="none" strike="noStrike">
+        <a:defRPr sz="1400" b="0" i="0" u="none" strike="noStrike" cap="none" spc="0">
           <a:solidFill>
             <a:srgbClr val="000000"/>
           </a:solidFill>
@@ -5964,7 +6114,7 @@
           <a:sym typeface="Arial"/>
         </a:defRPr>
       </a:lvl6pPr>
-      <a:lvl7pPr lvl="6" marR="0" rtl="0" algn="l">
+      <a:lvl7pPr marR="0" lvl="6" algn="l" rtl="0">
         <a:lnSpc>
           <a:spcPct val="100000"/>
         </a:lnSpc>
@@ -5978,7 +6128,7 @@
           <a:srgbClr val="000000"/>
         </a:buClr>
         <a:buFont typeface="Arial"/>
-        <a:defRPr b="0" i="0" spc="0" sz="1400" u="none" cap="none" strike="noStrike">
+        <a:defRPr sz="1400" b="0" i="0" u="none" strike="noStrike" cap="none" spc="0">
           <a:solidFill>
             <a:srgbClr val="000000"/>
           </a:solidFill>
@@ -5988,7 +6138,7 @@
           <a:sym typeface="Arial"/>
         </a:defRPr>
       </a:lvl7pPr>
-      <a:lvl8pPr lvl="7" marR="0" rtl="0" algn="l">
+      <a:lvl8pPr marR="0" lvl="7" algn="l" rtl="0">
         <a:lnSpc>
           <a:spcPct val="100000"/>
         </a:lnSpc>
@@ -6002,7 +6152,7 @@
           <a:srgbClr val="000000"/>
         </a:buClr>
         <a:buFont typeface="Arial"/>
-        <a:defRPr b="0" i="0" spc="0" sz="1400" u="none" cap="none" strike="noStrike">
+        <a:defRPr sz="1400" b="0" i="0" u="none" strike="noStrike" cap="none" spc="0">
           <a:solidFill>
             <a:srgbClr val="000000"/>
           </a:solidFill>
@@ -6012,7 +6162,7 @@
           <a:sym typeface="Arial"/>
         </a:defRPr>
       </a:lvl8pPr>
-      <a:lvl9pPr lvl="8" marR="0" rtl="0" algn="l">
+      <a:lvl9pPr marR="0" lvl="8" algn="l" rtl="0">
         <a:lnSpc>
           <a:spcPct val="100000"/>
         </a:lnSpc>
@@ -6026,7 +6176,7 @@
           <a:srgbClr val="000000"/>
         </a:buClr>
         <a:buFont typeface="Arial"/>
-        <a:defRPr b="0" i="0" spc="0" sz="1400" u="none" cap="none" strike="noStrike">
+        <a:defRPr sz="1400" b="0" i="0" u="none" strike="noStrike" cap="none" spc="0">
           <a:solidFill>
             <a:srgbClr val="000000"/>
           </a:solidFill>
@@ -6042,7 +6192,7 @@
 </file>
 
 <file path=ppt/slides/slide1.xml><?xml version="1.0" encoding="utf-8"?>
-<p:sld xmlns:a="http://schemas.openxmlformats.org/drawingml/2006/main" xmlns:r="http://schemas.openxmlformats.org/officeDocument/2006/relationships" xmlns:mc="http://schemas.openxmlformats.org/markup-compatibility/2006" xmlns:mv="urn:schemas-microsoft-com:mac:vml" xmlns:p="http://schemas.openxmlformats.org/presentationml/2006/main" xmlns:c="http://schemas.openxmlformats.org/drawingml/2006/chart" xmlns:dgm="http://schemas.openxmlformats.org/drawingml/2006/diagram" xmlns:o="urn:schemas-microsoft-com:office:office" xmlns:v="urn:schemas-microsoft-com:vml" xmlns:pvml="urn:schemas-microsoft-com:office:powerpoint" xmlns:com="http://schemas.openxmlformats.org/drawingml/2006/compatibility" xmlns:p14="http://schemas.microsoft.com/office/powerpoint/2010/main" xmlns:p15="http://schemas.microsoft.com/office/powerpoint/2012/main" xmlns:ahyp="http://schemas.microsoft.com/office/drawing/2018/hyperlinkcolor">
+<p:sld xmlns:a="http://schemas.openxmlformats.org/drawingml/2006/main" xmlns:r="http://schemas.openxmlformats.org/officeDocument/2006/relationships" xmlns:p="http://schemas.openxmlformats.org/presentationml/2006/main">
   <p:cSld>
     <p:bg>
       <p:bgPr>
@@ -6054,11 +6204,12 @@
             <a:fillRect/>
           </a:stretch>
         </a:blipFill>
+        <a:effectLst/>
       </p:bgPr>
     </p:bg>
     <p:spTree>
       <p:nvGrpSpPr>
-        <p:cNvPr id="53" name="Shape 53"/>
+        <p:cNvPr id="1" name="Shape 53"/>
         <p:cNvGrpSpPr/>
         <p:nvPr/>
       </p:nvGrpSpPr>
@@ -6090,12 +6241,12 @@
           </a:ln>
         </p:spPr>
         <p:txBody>
-          <a:bodyPr anchorCtr="0" anchor="t" bIns="91425" lIns="91425" spcFirstLastPara="1" rIns="91425" wrap="square" tIns="91425">
+          <a:bodyPr spcFirstLastPara="1" wrap="square" lIns="91425" tIns="91425" rIns="91425" bIns="91425" anchor="t" anchorCtr="0">
             <a:noAutofit/>
           </a:bodyPr>
           <a:lstStyle/>
           <a:p>
-            <a:pPr indent="0" lvl="0" marL="0" rtl="0" algn="l">
+            <a:pPr marL="0" lvl="0" indent="0" algn="l" rtl="0">
               <a:spcBef>
                 <a:spcPts val="0"/>
               </a:spcBef>
@@ -6105,7 +6256,7 @@
               <a:buNone/>
             </a:pPr>
             <a:r>
-              <a:rPr lang="en" sz="1800">
+              <a:rPr lang="en" sz="1800" dirty="0">
                 <a:solidFill>
                   <a:srgbClr val="FAF9FA"/>
                 </a:solidFill>
@@ -6114,9 +6265,9 @@
                 <a:cs typeface="Archivo SemiBold"/>
                 <a:sym typeface="Archivo SemiBold"/>
               </a:rPr>
-              <a:t>&lt;&lt;NOMBRE COMPLETO&gt;&gt;</a:t>
+              <a:t>&lt;&lt;Nombre y Apellido&gt;&gt;</a:t>
             </a:r>
-            <a:endParaRPr sz="1800">
+            <a:endParaRPr sz="1800" dirty="0">
               <a:solidFill>
                 <a:srgbClr val="FAF9FA"/>
               </a:solidFill>
@@ -6137,7 +6288,7 @@
 </file>
 
 <file path=ppt/slides/slide2.xml><?xml version="1.0" encoding="utf-8"?>
-<p:sld xmlns:a="http://schemas.openxmlformats.org/drawingml/2006/main" xmlns:r="http://schemas.openxmlformats.org/officeDocument/2006/relationships" xmlns:mc="http://schemas.openxmlformats.org/markup-compatibility/2006" xmlns:mv="urn:schemas-microsoft-com:mac:vml" xmlns:p="http://schemas.openxmlformats.org/presentationml/2006/main" xmlns:c="http://schemas.openxmlformats.org/drawingml/2006/chart" xmlns:dgm="http://schemas.openxmlformats.org/drawingml/2006/diagram" xmlns:o="urn:schemas-microsoft-com:office:office" xmlns:v="urn:schemas-microsoft-com:vml" xmlns:pvml="urn:schemas-microsoft-com:office:powerpoint" xmlns:com="http://schemas.openxmlformats.org/drawingml/2006/compatibility" xmlns:p14="http://schemas.microsoft.com/office/powerpoint/2010/main" xmlns:p15="http://schemas.microsoft.com/office/powerpoint/2012/main" xmlns:ahyp="http://schemas.microsoft.com/office/drawing/2018/hyperlinkcolor">
+<p:sld xmlns:a="http://schemas.openxmlformats.org/drawingml/2006/main" xmlns:r="http://schemas.openxmlformats.org/officeDocument/2006/relationships" xmlns:p="http://schemas.openxmlformats.org/presentationml/2006/main">
   <p:cSld>
     <p:bg>
       <p:bgPr>
@@ -6149,11 +6300,12 @@
             <a:fillRect/>
           </a:stretch>
         </a:blipFill>
+        <a:effectLst/>
       </p:bgPr>
     </p:bg>
     <p:spTree>
       <p:nvGrpSpPr>
-        <p:cNvPr id="58" name="Shape 58"/>
+        <p:cNvPr id="1" name="Shape 58"/>
         <p:cNvGrpSpPr/>
         <p:nvPr/>
       </p:nvGrpSpPr>
@@ -6174,7 +6326,7 @@
 </file>
 
 <file path=ppt/slides/slide3.xml><?xml version="1.0" encoding="utf-8"?>
-<p:sld xmlns:a="http://schemas.openxmlformats.org/drawingml/2006/main" xmlns:r="http://schemas.openxmlformats.org/officeDocument/2006/relationships" xmlns:mc="http://schemas.openxmlformats.org/markup-compatibility/2006" xmlns:mv="urn:schemas-microsoft-com:mac:vml" xmlns:p="http://schemas.openxmlformats.org/presentationml/2006/main" xmlns:c="http://schemas.openxmlformats.org/drawingml/2006/chart" xmlns:dgm="http://schemas.openxmlformats.org/drawingml/2006/diagram" xmlns:o="urn:schemas-microsoft-com:office:office" xmlns:v="urn:schemas-microsoft-com:vml" xmlns:pvml="urn:schemas-microsoft-com:office:powerpoint" xmlns:com="http://schemas.openxmlformats.org/drawingml/2006/compatibility" xmlns:p14="http://schemas.microsoft.com/office/powerpoint/2010/main" xmlns:p15="http://schemas.microsoft.com/office/powerpoint/2012/main" xmlns:ahyp="http://schemas.microsoft.com/office/drawing/2018/hyperlinkcolor">
+<p:sld xmlns:a="http://schemas.openxmlformats.org/drawingml/2006/main" xmlns:r="http://schemas.openxmlformats.org/officeDocument/2006/relationships" xmlns:p="http://schemas.openxmlformats.org/presentationml/2006/main">
   <p:cSld>
     <p:bg>
       <p:bgPr>
@@ -6186,11 +6338,12 @@
             <a:fillRect/>
           </a:stretch>
         </a:blipFill>
+        <a:effectLst/>
       </p:bgPr>
     </p:bg>
     <p:spTree>
       <p:nvGrpSpPr>
-        <p:cNvPr id="62" name="Shape 62"/>
+        <p:cNvPr id="1" name="Shape 62"/>
         <p:cNvGrpSpPr/>
         <p:nvPr/>
       </p:nvGrpSpPr>
@@ -6222,12 +6375,12 @@
           </a:ln>
         </p:spPr>
         <p:txBody>
-          <a:bodyPr anchorCtr="0" anchor="ctr" bIns="91425" lIns="91425" spcFirstLastPara="1" rIns="91425" wrap="square" tIns="91425">
+          <a:bodyPr spcFirstLastPara="1" wrap="square" lIns="91425" tIns="91425" rIns="91425" bIns="91425" anchor="ctr" anchorCtr="0">
             <a:noAutofit/>
           </a:bodyPr>
           <a:lstStyle/>
           <a:p>
-            <a:pPr indent="0" lvl="0" marL="0" rtl="0" algn="ctr">
+            <a:pPr marL="0" lvl="0" indent="0" algn="ctr" rtl="0">
               <a:spcBef>
                 <a:spcPts val="0"/>
               </a:spcBef>
@@ -6237,7 +6390,7 @@
               <a:buNone/>
             </a:pPr>
             <a:r>
-              <a:rPr b="1" lang="en" sz="1800">
+              <a:rPr lang="en" sz="1800" b="1" dirty="0">
                 <a:solidFill>
                   <a:schemeClr val="lt1"/>
                 </a:solidFill>
@@ -6246,9 +6399,9 @@
                 <a:cs typeface="Archivo"/>
                 <a:sym typeface="Archivo"/>
               </a:rPr>
-              <a:t>&lt;&lt;Nombre de Isla 1&gt;&gt;</a:t>
+              <a:t>&lt;&lt;nom_1&gt;&gt;</a:t>
             </a:r>
-            <a:endParaRPr b="1" sz="1800">
+            <a:endParaRPr sz="1800" b="1" dirty="0">
               <a:solidFill>
                 <a:schemeClr val="lt1"/>
               </a:solidFill>
@@ -6280,12 +6433,12 @@
           </a:ln>
         </p:spPr>
         <p:txBody>
-          <a:bodyPr anchorCtr="0" anchor="ctr" bIns="91425" lIns="91425" spcFirstLastPara="1" rIns="91425" wrap="square" tIns="91425">
+          <a:bodyPr spcFirstLastPara="1" wrap="square" lIns="91425" tIns="91425" rIns="91425" bIns="91425" anchor="ctr" anchorCtr="0">
             <a:noAutofit/>
           </a:bodyPr>
           <a:lstStyle/>
           <a:p>
-            <a:pPr indent="0" lvl="0" marL="0" rtl="0" algn="r">
+            <a:pPr marL="0" lvl="0" indent="0" algn="r" rtl="0">
               <a:spcBef>
                 <a:spcPts val="0"/>
               </a:spcBef>
@@ -6295,7 +6448,7 @@
               <a:buNone/>
             </a:pPr>
             <a:r>
-              <a:rPr lang="en">
+              <a:rPr lang="en" dirty="0">
                 <a:solidFill>
                   <a:schemeClr val="lt1"/>
                 </a:solidFill>
@@ -6304,33 +6457,9 @@
                 <a:cs typeface="Archivo Medium"/>
                 <a:sym typeface="Archivo Medium"/>
               </a:rPr>
-              <a:t>&lt;&lt;</a:t>
+              <a:t>&lt;&lt;desc_1&gt;&gt;</a:t>
             </a:r>
-            <a:r>
-              <a:rPr lang="en">
-                <a:solidFill>
-                  <a:schemeClr val="lt1"/>
-                </a:solidFill>
-                <a:latin typeface="Archivo Medium"/>
-                <a:ea typeface="Archivo Medium"/>
-                <a:cs typeface="Archivo Medium"/>
-                <a:sym typeface="Archivo Medium"/>
-              </a:rPr>
-              <a:t>Descripción Isla 1</a:t>
-            </a:r>
-            <a:r>
-              <a:rPr lang="en">
-                <a:solidFill>
-                  <a:schemeClr val="lt1"/>
-                </a:solidFill>
-                <a:latin typeface="Archivo Medium"/>
-                <a:ea typeface="Archivo Medium"/>
-                <a:cs typeface="Archivo Medium"/>
-                <a:sym typeface="Archivo Medium"/>
-              </a:rPr>
-              <a:t>&gt;&gt;</a:t>
-            </a:r>
-            <a:endParaRPr>
+            <a:endParaRPr dirty="0">
               <a:solidFill>
                 <a:schemeClr val="lt1"/>
               </a:solidFill>
@@ -6351,7 +6480,7 @@
 </file>
 
 <file path=ppt/slides/slide4.xml><?xml version="1.0" encoding="utf-8"?>
-<p:sld xmlns:a="http://schemas.openxmlformats.org/drawingml/2006/main" xmlns:r="http://schemas.openxmlformats.org/officeDocument/2006/relationships" xmlns:mc="http://schemas.openxmlformats.org/markup-compatibility/2006" xmlns:mv="urn:schemas-microsoft-com:mac:vml" xmlns:p="http://schemas.openxmlformats.org/presentationml/2006/main" xmlns:c="http://schemas.openxmlformats.org/drawingml/2006/chart" xmlns:dgm="http://schemas.openxmlformats.org/drawingml/2006/diagram" xmlns:o="urn:schemas-microsoft-com:office:office" xmlns:v="urn:schemas-microsoft-com:vml" xmlns:pvml="urn:schemas-microsoft-com:office:powerpoint" xmlns:com="http://schemas.openxmlformats.org/drawingml/2006/compatibility" xmlns:p14="http://schemas.microsoft.com/office/powerpoint/2010/main" xmlns:p15="http://schemas.microsoft.com/office/powerpoint/2012/main" xmlns:ahyp="http://schemas.microsoft.com/office/drawing/2018/hyperlinkcolor">
+<p:sld xmlns:a="http://schemas.openxmlformats.org/drawingml/2006/main" xmlns:r="http://schemas.openxmlformats.org/officeDocument/2006/relationships" xmlns:p="http://schemas.openxmlformats.org/presentationml/2006/main">
   <p:cSld>
     <p:bg>
       <p:bgPr>
@@ -6363,11 +6492,12 @@
             <a:fillRect/>
           </a:stretch>
         </a:blipFill>
+        <a:effectLst/>
       </p:bgPr>
     </p:bg>
     <p:spTree>
       <p:nvGrpSpPr>
-        <p:cNvPr id="68" name="Shape 68"/>
+        <p:cNvPr id="1" name="Shape 68"/>
         <p:cNvGrpSpPr/>
         <p:nvPr/>
       </p:nvGrpSpPr>
@@ -6399,12 +6529,12 @@
           </a:ln>
         </p:spPr>
         <p:txBody>
-          <a:bodyPr anchorCtr="0" anchor="t" bIns="91425" lIns="91425" spcFirstLastPara="1" rIns="91425" wrap="square" tIns="91425">
+          <a:bodyPr spcFirstLastPara="1" wrap="square" lIns="91425" tIns="91425" rIns="91425" bIns="91425" anchor="t" anchorCtr="0">
             <a:noAutofit/>
           </a:bodyPr>
           <a:lstStyle/>
           <a:p>
-            <a:pPr indent="0" lvl="0" marL="0" rtl="0" algn="just">
+            <a:pPr marL="0" lvl="0" indent="0" algn="just" rtl="0">
               <a:spcBef>
                 <a:spcPts val="0"/>
               </a:spcBef>
@@ -6419,7 +6549,7 @@
               <a:buNone/>
             </a:pPr>
             <a:r>
-              <a:rPr lang="en" sz="1200">
+              <a:rPr lang="en" sz="1200" dirty="0">
                 <a:solidFill>
                   <a:srgbClr val="FAF9FA"/>
                 </a:solidFill>
@@ -6428,21 +6558,9 @@
                 <a:cs typeface="Archivo Medium"/>
                 <a:sym typeface="Archivo Medium"/>
               </a:rPr>
-              <a:t>&lt;&lt;HABILIDAD 1.1&gt;&gt;</a:t>
+              <a:t>&lt;&lt;1_desc_hab_1&gt;&gt; </a:t>
             </a:r>
-            <a:r>
-              <a:rPr lang="en" sz="1200">
-                <a:solidFill>
-                  <a:srgbClr val="FAF9FA"/>
-                </a:solidFill>
-                <a:latin typeface="Archivo Medium"/>
-                <a:ea typeface="Archivo Medium"/>
-                <a:cs typeface="Archivo Medium"/>
-                <a:sym typeface="Archivo Medium"/>
-              </a:rPr>
-              <a:t> </a:t>
-            </a:r>
-            <a:endParaRPr sz="1200">
+            <a:endParaRPr sz="1200" dirty="0">
               <a:solidFill>
                 <a:srgbClr val="595959"/>
               </a:solidFill>
@@ -6474,12 +6592,12 @@
           </a:ln>
         </p:spPr>
         <p:txBody>
-          <a:bodyPr anchorCtr="0" anchor="t" bIns="91425" lIns="91425" spcFirstLastPara="1" rIns="91425" wrap="square" tIns="91425">
+          <a:bodyPr spcFirstLastPara="1" wrap="square" lIns="91425" tIns="91425" rIns="91425" bIns="91425" anchor="t" anchorCtr="0">
             <a:noAutofit/>
           </a:bodyPr>
           <a:lstStyle/>
           <a:p>
-            <a:pPr indent="0" lvl="0" marL="0" rtl="0" algn="just">
+            <a:pPr marL="0" lvl="0" indent="0" algn="just" rtl="0">
               <a:spcBef>
                 <a:spcPts val="0"/>
               </a:spcBef>
@@ -6489,7 +6607,7 @@
               <a:buNone/>
             </a:pPr>
             <a:r>
-              <a:rPr lang="en" sz="1200">
+              <a:rPr lang="en" sz="1200" dirty="0">
                 <a:solidFill>
                   <a:srgbClr val="FAF9FA"/>
                 </a:solidFill>
@@ -6498,9 +6616,9 @@
                 <a:cs typeface="Archivo Medium"/>
                 <a:sym typeface="Archivo Medium"/>
               </a:rPr>
-              <a:t>&lt;&lt;HABILIDAD 1.3&gt;&gt;</a:t>
+              <a:t>&lt;&lt;1_desc_hab_3&gt;&gt;</a:t>
             </a:r>
-            <a:endParaRPr sz="1200">
+            <a:endParaRPr sz="1200" dirty="0">
               <a:solidFill>
                 <a:srgbClr val="595959"/>
               </a:solidFill>
@@ -6532,12 +6650,12 @@
           </a:ln>
         </p:spPr>
         <p:txBody>
-          <a:bodyPr anchorCtr="0" anchor="t" bIns="91425" lIns="91425" spcFirstLastPara="1" rIns="91425" wrap="square" tIns="91425">
+          <a:bodyPr spcFirstLastPara="1" wrap="square" lIns="91425" tIns="91425" rIns="91425" bIns="91425" anchor="t" anchorCtr="0">
             <a:noAutofit/>
           </a:bodyPr>
           <a:lstStyle/>
           <a:p>
-            <a:pPr indent="0" lvl="0" marL="0" rtl="0" algn="l">
+            <a:pPr marL="0" lvl="0" indent="0" algn="l" rtl="0">
               <a:spcBef>
                 <a:spcPts val="0"/>
               </a:spcBef>
@@ -6547,7 +6665,7 @@
               <a:buNone/>
             </a:pPr>
             <a:r>
-              <a:rPr b="1" lang="en" sz="1700">
+              <a:rPr lang="en" sz="1700" b="1" dirty="0">
                 <a:solidFill>
                   <a:srgbClr val="FF6C4C"/>
                 </a:solidFill>
@@ -6556,33 +6674,9 @@
                 <a:cs typeface="Archivo"/>
                 <a:sym typeface="Archivo"/>
               </a:rPr>
-              <a:t>&lt;&lt;</a:t>
+              <a:t>&lt;&lt;1_hab_1&gt;&gt;</a:t>
             </a:r>
-            <a:r>
-              <a:rPr b="1" lang="en" sz="1700">
-                <a:solidFill>
-                  <a:srgbClr val="FF6C4C"/>
-                </a:solidFill>
-                <a:latin typeface="Archivo"/>
-                <a:ea typeface="Archivo"/>
-                <a:cs typeface="Archivo"/>
-                <a:sym typeface="Archivo"/>
-              </a:rPr>
-              <a:t>TÍTULO</a:t>
-            </a:r>
-            <a:r>
-              <a:rPr b="1" lang="en" sz="1700">
-                <a:solidFill>
-                  <a:srgbClr val="FF6C4C"/>
-                </a:solidFill>
-                <a:latin typeface="Archivo"/>
-                <a:ea typeface="Archivo"/>
-                <a:cs typeface="Archivo"/>
-                <a:sym typeface="Archivo"/>
-              </a:rPr>
-              <a:t> HABILIDAD 1.1&gt;&gt;</a:t>
-            </a:r>
-            <a:endParaRPr b="1" sz="1700">
+            <a:endParaRPr sz="1700" b="1" dirty="0">
               <a:solidFill>
                 <a:srgbClr val="FF6C4C"/>
               </a:solidFill>
@@ -6614,12 +6708,12 @@
           </a:ln>
         </p:spPr>
         <p:txBody>
-          <a:bodyPr anchorCtr="0" anchor="t" bIns="91425" lIns="91425" spcFirstLastPara="1" rIns="91425" wrap="square" tIns="91425">
+          <a:bodyPr spcFirstLastPara="1" wrap="square" lIns="91425" tIns="91425" rIns="91425" bIns="91425" anchor="t" anchorCtr="0">
             <a:noAutofit/>
           </a:bodyPr>
           <a:lstStyle/>
           <a:p>
-            <a:pPr indent="0" lvl="0" marL="0" rtl="0" algn="l">
+            <a:pPr marL="0" lvl="0" indent="0" algn="l" rtl="0">
               <a:spcBef>
                 <a:spcPts val="0"/>
               </a:spcBef>
@@ -6629,7 +6723,7 @@
               <a:buNone/>
             </a:pPr>
             <a:r>
-              <a:rPr b="1" lang="en" sz="1700">
+              <a:rPr lang="en" sz="1700" b="1" dirty="0">
                 <a:solidFill>
                   <a:srgbClr val="FF6C4C"/>
                 </a:solidFill>
@@ -6638,9 +6732,9 @@
                 <a:cs typeface="Archivo"/>
                 <a:sym typeface="Archivo"/>
               </a:rPr>
-              <a:t>&lt;&lt;TÍTULO HABILIDAD 1.3&gt;&gt;</a:t>
+              <a:t>&lt;&lt;1_hab_3&gt;&gt;</a:t>
             </a:r>
-            <a:endParaRPr b="1" sz="1700">
+            <a:endParaRPr sz="1700" b="1" dirty="0">
               <a:solidFill>
                 <a:srgbClr val="FF6C4C"/>
               </a:solidFill>
@@ -6672,12 +6766,12 @@
           </a:ln>
         </p:spPr>
         <p:txBody>
-          <a:bodyPr anchorCtr="0" anchor="t" bIns="91425" lIns="91425" spcFirstLastPara="1" rIns="91425" wrap="square" tIns="91425">
+          <a:bodyPr spcFirstLastPara="1" wrap="square" lIns="91425" tIns="91425" rIns="91425" bIns="91425" anchor="t" anchorCtr="0">
             <a:noAutofit/>
           </a:bodyPr>
           <a:lstStyle/>
           <a:p>
-            <a:pPr indent="0" lvl="0" marL="0" rtl="0" algn="just">
+            <a:pPr marL="0" lvl="0" indent="0" algn="just" rtl="0">
               <a:spcBef>
                 <a:spcPts val="0"/>
               </a:spcBef>
@@ -6692,7 +6786,7 @@
               <a:buNone/>
             </a:pPr>
             <a:r>
-              <a:rPr lang="en" sz="1200">
+              <a:rPr lang="en" sz="1200" dirty="0">
                 <a:solidFill>
                   <a:srgbClr val="FAF9FA"/>
                 </a:solidFill>
@@ -6701,21 +6795,9 @@
                 <a:cs typeface="Archivo Medium"/>
                 <a:sym typeface="Archivo Medium"/>
               </a:rPr>
-              <a:t>&lt;&lt;HABILIDAD 1.2&gt;&gt;</a:t>
+              <a:t>&lt;&lt;1_desc_hab_2&gt;&gt; </a:t>
             </a:r>
-            <a:r>
-              <a:rPr lang="en" sz="1200">
-                <a:solidFill>
-                  <a:srgbClr val="FAF9FA"/>
-                </a:solidFill>
-                <a:latin typeface="Archivo Medium"/>
-                <a:ea typeface="Archivo Medium"/>
-                <a:cs typeface="Archivo Medium"/>
-                <a:sym typeface="Archivo Medium"/>
-              </a:rPr>
-              <a:t> </a:t>
-            </a:r>
-            <a:endParaRPr sz="1200">
+            <a:endParaRPr sz="1200" dirty="0">
               <a:solidFill>
                 <a:srgbClr val="595959"/>
               </a:solidFill>
@@ -6747,12 +6829,12 @@
           </a:ln>
         </p:spPr>
         <p:txBody>
-          <a:bodyPr anchorCtr="0" anchor="t" bIns="91425" lIns="91425" spcFirstLastPara="1" rIns="91425" wrap="square" tIns="91425">
+          <a:bodyPr spcFirstLastPara="1" wrap="square" lIns="91425" tIns="91425" rIns="91425" bIns="91425" anchor="t" anchorCtr="0">
             <a:noAutofit/>
           </a:bodyPr>
           <a:lstStyle/>
           <a:p>
-            <a:pPr indent="0" lvl="0" marL="0" rtl="0" algn="l">
+            <a:pPr marL="0" lvl="0" indent="0" algn="l" rtl="0">
               <a:spcBef>
                 <a:spcPts val="0"/>
               </a:spcBef>
@@ -6762,7 +6844,7 @@
               <a:buNone/>
             </a:pPr>
             <a:r>
-              <a:rPr b="1" lang="en" sz="1700">
+              <a:rPr lang="en" sz="1700" b="1" dirty="0">
                 <a:solidFill>
                   <a:srgbClr val="FF6C4C"/>
                 </a:solidFill>
@@ -6771,9 +6853,9 @@
                 <a:cs typeface="Archivo"/>
                 <a:sym typeface="Archivo"/>
               </a:rPr>
-              <a:t>&lt;&lt;TÍTULO HABILIDAD 1.2&gt;&gt;</a:t>
+              <a:t>&lt;&lt;1_hab_2&gt;&gt;</a:t>
             </a:r>
-            <a:endParaRPr b="1" sz="1700">
+            <a:endParaRPr sz="1700" b="1" dirty="0">
               <a:solidFill>
                 <a:srgbClr val="FF6C4C"/>
               </a:solidFill>
@@ -6794,7 +6876,7 @@
 </file>
 
 <file path=ppt/slides/slide5.xml><?xml version="1.0" encoding="utf-8"?>
-<p:sld xmlns:a="http://schemas.openxmlformats.org/drawingml/2006/main" xmlns:r="http://schemas.openxmlformats.org/officeDocument/2006/relationships" xmlns:mc="http://schemas.openxmlformats.org/markup-compatibility/2006" xmlns:mv="urn:schemas-microsoft-com:mac:vml" xmlns:p="http://schemas.openxmlformats.org/presentationml/2006/main" xmlns:c="http://schemas.openxmlformats.org/drawingml/2006/chart" xmlns:dgm="http://schemas.openxmlformats.org/drawingml/2006/diagram" xmlns:o="urn:schemas-microsoft-com:office:office" xmlns:v="urn:schemas-microsoft-com:vml" xmlns:pvml="urn:schemas-microsoft-com:office:powerpoint" xmlns:com="http://schemas.openxmlformats.org/drawingml/2006/compatibility" xmlns:p14="http://schemas.microsoft.com/office/powerpoint/2010/main" xmlns:p15="http://schemas.microsoft.com/office/powerpoint/2012/main" xmlns:ahyp="http://schemas.microsoft.com/office/drawing/2018/hyperlinkcolor">
+<p:sld xmlns:a="http://schemas.openxmlformats.org/drawingml/2006/main" xmlns:r="http://schemas.openxmlformats.org/officeDocument/2006/relationships" xmlns:p="http://schemas.openxmlformats.org/presentationml/2006/main">
   <p:cSld>
     <p:bg>
       <p:bgPr>
@@ -6806,11 +6888,12 @@
             <a:fillRect/>
           </a:stretch>
         </a:blipFill>
+        <a:effectLst/>
       </p:bgPr>
     </p:bg>
     <p:spTree>
       <p:nvGrpSpPr>
-        <p:cNvPr id="78" name="Shape 78"/>
+        <p:cNvPr id="1" name="Shape 78"/>
         <p:cNvGrpSpPr/>
         <p:nvPr/>
       </p:nvGrpSpPr>
@@ -6824,14 +6907,20 @@
       </p:grpSpPr>
       <p:sp>
         <p:nvSpPr>
-          <p:cNvPr id="79" name="Google Shape;79;p17"/>
+          <p:cNvPr id="3" name="Google Shape;63;p15">
+            <a:extLst>
+              <a:ext uri="{FF2B5EF4-FFF2-40B4-BE49-F238E27FC236}">
+                <a16:creationId xmlns:a16="http://schemas.microsoft.com/office/drawing/2014/main" id="{D43A4A85-F95B-C2D5-15AB-2FFCF07FD527}"/>
+              </a:ext>
+            </a:extLst>
+          </p:cNvPr>
           <p:cNvSpPr txBox="1"/>
           <p:nvPr/>
         </p:nvSpPr>
         <p:spPr>
           <a:xfrm>
-            <a:off x="1768875" y="1794500"/>
-            <a:ext cx="2197200" cy="1508700"/>
+            <a:off x="1798850" y="1794500"/>
+            <a:ext cx="2147400" cy="1508700"/>
           </a:xfrm>
           <a:prstGeom prst="rect">
             <a:avLst/>
@@ -6842,12 +6931,12 @@
           </a:ln>
         </p:spPr>
         <p:txBody>
-          <a:bodyPr anchorCtr="0" anchor="ctr" bIns="91425" lIns="91425" spcFirstLastPara="1" rIns="91425" wrap="square" tIns="91425">
+          <a:bodyPr spcFirstLastPara="1" wrap="square" lIns="91425" tIns="91425" rIns="91425" bIns="91425" anchor="ctr" anchorCtr="0">
             <a:noAutofit/>
           </a:bodyPr>
           <a:lstStyle/>
           <a:p>
-            <a:pPr indent="0" lvl="0" marL="0" rtl="0" algn="ctr">
+            <a:pPr marL="0" lvl="0" indent="0" algn="ctr" rtl="0">
               <a:spcBef>
                 <a:spcPts val="0"/>
               </a:spcBef>
@@ -6857,7 +6946,7 @@
               <a:buNone/>
             </a:pPr>
             <a:r>
-              <a:rPr b="1" lang="en" sz="1800">
+              <a:rPr lang="en" sz="1800" b="1" dirty="0">
                 <a:solidFill>
                   <a:schemeClr val="lt1"/>
                 </a:solidFill>
@@ -6866,9 +6955,9 @@
                 <a:cs typeface="Archivo"/>
                 <a:sym typeface="Archivo"/>
               </a:rPr>
-              <a:t>&lt;&lt;Nombre de Isla 2&gt;&gt;</a:t>
+              <a:t>&lt;&lt;nom_2&gt;&gt;</a:t>
             </a:r>
-            <a:endParaRPr b="1" sz="1800">
+            <a:endParaRPr sz="1800" b="1" dirty="0">
               <a:solidFill>
                 <a:schemeClr val="lt1"/>
               </a:solidFill>
@@ -6882,13 +6971,19 @@
       </p:sp>
       <p:sp>
         <p:nvSpPr>
-          <p:cNvPr id="80" name="Google Shape;80;p17"/>
+          <p:cNvPr id="5" name="Google Shape;64;p15">
+            <a:extLst>
+              <a:ext uri="{FF2B5EF4-FFF2-40B4-BE49-F238E27FC236}">
+                <a16:creationId xmlns:a16="http://schemas.microsoft.com/office/drawing/2014/main" id="{6F808232-BC30-A837-79B8-3ABEB2D50470}"/>
+              </a:ext>
+            </a:extLst>
+          </p:cNvPr>
           <p:cNvSpPr txBox="1"/>
           <p:nvPr/>
         </p:nvSpPr>
         <p:spPr>
           <a:xfrm>
-            <a:off x="4741925" y="2024200"/>
+            <a:off x="4652025" y="1575450"/>
             <a:ext cx="4011900" cy="2091600"/>
           </a:xfrm>
           <a:prstGeom prst="rect">
@@ -6900,12 +6995,12 @@
           </a:ln>
         </p:spPr>
         <p:txBody>
-          <a:bodyPr anchorCtr="0" anchor="ctr" bIns="91425" lIns="91425" spcFirstLastPara="1" rIns="91425" wrap="square" tIns="91425">
+          <a:bodyPr spcFirstLastPara="1" wrap="square" lIns="91425" tIns="91425" rIns="91425" bIns="91425" anchor="ctr" anchorCtr="0">
             <a:noAutofit/>
           </a:bodyPr>
           <a:lstStyle/>
           <a:p>
-            <a:pPr indent="0" lvl="0" marL="0" rtl="0" algn="r">
+            <a:pPr marL="0" lvl="0" indent="0" algn="r" rtl="0">
               <a:spcBef>
                 <a:spcPts val="0"/>
               </a:spcBef>
@@ -6915,7 +7010,7 @@
               <a:buNone/>
             </a:pPr>
             <a:r>
-              <a:rPr lang="en">
+              <a:rPr lang="en" dirty="0">
                 <a:solidFill>
                   <a:schemeClr val="lt1"/>
                 </a:solidFill>
@@ -6924,9 +7019,9 @@
                 <a:cs typeface="Archivo Medium"/>
                 <a:sym typeface="Archivo Medium"/>
               </a:rPr>
-              <a:t>&lt;&lt;Descripción Isla 2&gt;&gt;</a:t>
+              <a:t>&lt;&lt;desc_2&gt;&gt;</a:t>
             </a:r>
-            <a:endParaRPr>
+            <a:endParaRPr dirty="0">
               <a:solidFill>
                 <a:schemeClr val="lt1"/>
               </a:solidFill>
@@ -6947,7 +7042,7 @@
 </file>
 
 <file path=ppt/slides/slide6.xml><?xml version="1.0" encoding="utf-8"?>
-<p:sld xmlns:a="http://schemas.openxmlformats.org/drawingml/2006/main" xmlns:r="http://schemas.openxmlformats.org/officeDocument/2006/relationships" xmlns:mc="http://schemas.openxmlformats.org/markup-compatibility/2006" xmlns:mv="urn:schemas-microsoft-com:mac:vml" xmlns:p="http://schemas.openxmlformats.org/presentationml/2006/main" xmlns:c="http://schemas.openxmlformats.org/drawingml/2006/chart" xmlns:dgm="http://schemas.openxmlformats.org/drawingml/2006/diagram" xmlns:o="urn:schemas-microsoft-com:office:office" xmlns:v="urn:schemas-microsoft-com:vml" xmlns:pvml="urn:schemas-microsoft-com:office:powerpoint" xmlns:com="http://schemas.openxmlformats.org/drawingml/2006/compatibility" xmlns:p14="http://schemas.microsoft.com/office/powerpoint/2010/main" xmlns:p15="http://schemas.microsoft.com/office/powerpoint/2012/main" xmlns:ahyp="http://schemas.microsoft.com/office/drawing/2018/hyperlinkcolor">
+<p:sld xmlns:a="http://schemas.openxmlformats.org/drawingml/2006/main" xmlns:r="http://schemas.openxmlformats.org/officeDocument/2006/relationships" xmlns:p="http://schemas.openxmlformats.org/presentationml/2006/main">
   <p:cSld>
     <p:bg>
       <p:bgPr>
@@ -6959,11 +7054,12 @@
             <a:fillRect/>
           </a:stretch>
         </a:blipFill>
+        <a:effectLst/>
       </p:bgPr>
     </p:bg>
     <p:spTree>
       <p:nvGrpSpPr>
-        <p:cNvPr id="84" name="Shape 84"/>
+        <p:cNvPr id="1" name="Shape 84"/>
         <p:cNvGrpSpPr/>
         <p:nvPr/>
       </p:nvGrpSpPr>
@@ -6977,7 +7073,13 @@
       </p:grpSpPr>
       <p:sp>
         <p:nvSpPr>
-          <p:cNvPr id="85" name="Google Shape;85;p18"/>
+          <p:cNvPr id="13" name="Google Shape;69;p16">
+            <a:extLst>
+              <a:ext uri="{FF2B5EF4-FFF2-40B4-BE49-F238E27FC236}">
+                <a16:creationId xmlns:a16="http://schemas.microsoft.com/office/drawing/2014/main" id="{BF0294A4-2F75-01A6-12BA-D76E06B4DB85}"/>
+              </a:ext>
+            </a:extLst>
+          </p:cNvPr>
           <p:cNvSpPr txBox="1"/>
           <p:nvPr/>
         </p:nvSpPr>
@@ -6995,12 +7097,12 @@
           </a:ln>
         </p:spPr>
         <p:txBody>
-          <a:bodyPr anchorCtr="0" anchor="t" bIns="91425" lIns="91425" spcFirstLastPara="1" rIns="91425" wrap="square" tIns="91425">
+          <a:bodyPr spcFirstLastPara="1" wrap="square" lIns="91425" tIns="91425" rIns="91425" bIns="91425" anchor="t" anchorCtr="0">
             <a:noAutofit/>
           </a:bodyPr>
           <a:lstStyle/>
           <a:p>
-            <a:pPr indent="0" lvl="0" marL="0" rtl="0" algn="just">
+            <a:pPr marL="0" lvl="0" indent="0" algn="just" rtl="0">
               <a:spcBef>
                 <a:spcPts val="0"/>
               </a:spcBef>
@@ -7015,7 +7117,7 @@
               <a:buNone/>
             </a:pPr>
             <a:r>
-              <a:rPr lang="en" sz="1200">
+              <a:rPr lang="en" sz="1200" dirty="0">
                 <a:solidFill>
                   <a:srgbClr val="FAF9FA"/>
                 </a:solidFill>
@@ -7024,21 +7126,9 @@
                 <a:cs typeface="Archivo Medium"/>
                 <a:sym typeface="Archivo Medium"/>
               </a:rPr>
-              <a:t>&lt;&lt;HABILIDAD 2.1&gt;&gt;</a:t>
+              <a:t>&lt;&lt;2_desc_hab_1&gt;&gt; </a:t>
             </a:r>
-            <a:r>
-              <a:rPr lang="en" sz="1200">
-                <a:solidFill>
-                  <a:srgbClr val="FAF9FA"/>
-                </a:solidFill>
-                <a:latin typeface="Archivo Medium"/>
-                <a:ea typeface="Archivo Medium"/>
-                <a:cs typeface="Archivo Medium"/>
-                <a:sym typeface="Archivo Medium"/>
-              </a:rPr>
-              <a:t> </a:t>
-            </a:r>
-            <a:endParaRPr sz="1200">
+            <a:endParaRPr sz="1200" dirty="0">
               <a:solidFill>
                 <a:srgbClr val="595959"/>
               </a:solidFill>
@@ -7052,7 +7142,13 @@
       </p:sp>
       <p:sp>
         <p:nvSpPr>
-          <p:cNvPr id="86" name="Google Shape;86;p18"/>
+          <p:cNvPr id="15" name="Google Shape;70;p16">
+            <a:extLst>
+              <a:ext uri="{FF2B5EF4-FFF2-40B4-BE49-F238E27FC236}">
+                <a16:creationId xmlns:a16="http://schemas.microsoft.com/office/drawing/2014/main" id="{354883C8-C25C-058F-F355-D7AC992F346A}"/>
+              </a:ext>
+            </a:extLst>
+          </p:cNvPr>
           <p:cNvSpPr txBox="1"/>
           <p:nvPr/>
         </p:nvSpPr>
@@ -7070,12 +7166,12 @@
           </a:ln>
         </p:spPr>
         <p:txBody>
-          <a:bodyPr anchorCtr="0" anchor="t" bIns="91425" lIns="91425" spcFirstLastPara="1" rIns="91425" wrap="square" tIns="91425">
+          <a:bodyPr spcFirstLastPara="1" wrap="square" lIns="91425" tIns="91425" rIns="91425" bIns="91425" anchor="t" anchorCtr="0">
             <a:noAutofit/>
           </a:bodyPr>
           <a:lstStyle/>
           <a:p>
-            <a:pPr indent="0" lvl="0" marL="0" rtl="0" algn="just">
+            <a:pPr marL="0" lvl="0" indent="0" algn="just" rtl="0">
               <a:spcBef>
                 <a:spcPts val="0"/>
               </a:spcBef>
@@ -7085,7 +7181,7 @@
               <a:buNone/>
             </a:pPr>
             <a:r>
-              <a:rPr lang="en" sz="1200">
+              <a:rPr lang="en" sz="1200" dirty="0">
                 <a:solidFill>
                   <a:srgbClr val="FAF9FA"/>
                 </a:solidFill>
@@ -7094,9 +7190,9 @@
                 <a:cs typeface="Archivo Medium"/>
                 <a:sym typeface="Archivo Medium"/>
               </a:rPr>
-              <a:t>&lt;&lt;HABILIDAD 2.3&gt;&gt;</a:t>
+              <a:t>&lt;&lt;2_desc_hab_3&gt;&gt;</a:t>
             </a:r>
-            <a:endParaRPr sz="1200">
+            <a:endParaRPr sz="1200" dirty="0">
               <a:solidFill>
                 <a:srgbClr val="595959"/>
               </a:solidFill>
@@ -7110,7 +7206,13 @@
       </p:sp>
       <p:sp>
         <p:nvSpPr>
-          <p:cNvPr id="87" name="Google Shape;87;p18"/>
+          <p:cNvPr id="17" name="Google Shape;71;p16">
+            <a:extLst>
+              <a:ext uri="{FF2B5EF4-FFF2-40B4-BE49-F238E27FC236}">
+                <a16:creationId xmlns:a16="http://schemas.microsoft.com/office/drawing/2014/main" id="{46653221-E3A0-E579-7074-7D290AC10E96}"/>
+              </a:ext>
+            </a:extLst>
+          </p:cNvPr>
           <p:cNvSpPr txBox="1"/>
           <p:nvPr/>
         </p:nvSpPr>
@@ -7128,12 +7230,12 @@
           </a:ln>
         </p:spPr>
         <p:txBody>
-          <a:bodyPr anchorCtr="0" anchor="t" bIns="91425" lIns="91425" spcFirstLastPara="1" rIns="91425" wrap="square" tIns="91425">
+          <a:bodyPr spcFirstLastPara="1" wrap="square" lIns="91425" tIns="91425" rIns="91425" bIns="91425" anchor="t" anchorCtr="0">
             <a:noAutofit/>
           </a:bodyPr>
           <a:lstStyle/>
           <a:p>
-            <a:pPr indent="0" lvl="0" marL="0" rtl="0" algn="l">
+            <a:pPr marL="0" lvl="0" indent="0" algn="l" rtl="0">
               <a:spcBef>
                 <a:spcPts val="0"/>
               </a:spcBef>
@@ -7143,7 +7245,7 @@
               <a:buNone/>
             </a:pPr>
             <a:r>
-              <a:rPr b="1" lang="en" sz="1700">
+              <a:rPr lang="en" sz="1700" b="1" dirty="0">
                 <a:solidFill>
                   <a:srgbClr val="FF6C4C"/>
                 </a:solidFill>
@@ -7152,9 +7254,9 @@
                 <a:cs typeface="Archivo"/>
                 <a:sym typeface="Archivo"/>
               </a:rPr>
-              <a:t>&lt;&lt;TÍTULO HABILIDAD 2.1&gt;&gt;</a:t>
+              <a:t>&lt;&lt;2_hab_1&gt;&gt;</a:t>
             </a:r>
-            <a:endParaRPr b="1" sz="1700">
+            <a:endParaRPr sz="1700" b="1" dirty="0">
               <a:solidFill>
                 <a:srgbClr val="FF6C4C"/>
               </a:solidFill>
@@ -7168,7 +7270,13 @@
       </p:sp>
       <p:sp>
         <p:nvSpPr>
-          <p:cNvPr id="88" name="Google Shape;88;p18"/>
+          <p:cNvPr id="19" name="Google Shape;72;p16">
+            <a:extLst>
+              <a:ext uri="{FF2B5EF4-FFF2-40B4-BE49-F238E27FC236}">
+                <a16:creationId xmlns:a16="http://schemas.microsoft.com/office/drawing/2014/main" id="{8152B641-2237-FEB2-AEB9-D7C2826F6B35}"/>
+              </a:ext>
+            </a:extLst>
+          </p:cNvPr>
           <p:cNvSpPr txBox="1"/>
           <p:nvPr/>
         </p:nvSpPr>
@@ -7186,12 +7294,12 @@
           </a:ln>
         </p:spPr>
         <p:txBody>
-          <a:bodyPr anchorCtr="0" anchor="t" bIns="91425" lIns="91425" spcFirstLastPara="1" rIns="91425" wrap="square" tIns="91425">
+          <a:bodyPr spcFirstLastPara="1" wrap="square" lIns="91425" tIns="91425" rIns="91425" bIns="91425" anchor="t" anchorCtr="0">
             <a:noAutofit/>
           </a:bodyPr>
           <a:lstStyle/>
           <a:p>
-            <a:pPr indent="0" lvl="0" marL="0" rtl="0" algn="l">
+            <a:pPr marL="0" lvl="0" indent="0" algn="l" rtl="0">
               <a:spcBef>
                 <a:spcPts val="0"/>
               </a:spcBef>
@@ -7201,7 +7309,7 @@
               <a:buNone/>
             </a:pPr>
             <a:r>
-              <a:rPr b="1" lang="en" sz="1700">
+              <a:rPr lang="en" sz="1700" b="1" dirty="0">
                 <a:solidFill>
                   <a:srgbClr val="FF6C4C"/>
                 </a:solidFill>
@@ -7210,9 +7318,9 @@
                 <a:cs typeface="Archivo"/>
                 <a:sym typeface="Archivo"/>
               </a:rPr>
-              <a:t>&lt;&lt;TÍTULO HABILIDAD 2.3&gt;&gt;</a:t>
+              <a:t>&lt;&lt;2_hab_3&gt;&gt;</a:t>
             </a:r>
-            <a:endParaRPr b="1" sz="1700">
+            <a:endParaRPr sz="1700" b="1" dirty="0">
               <a:solidFill>
                 <a:srgbClr val="FF6C4C"/>
               </a:solidFill>
@@ -7226,7 +7334,13 @@
       </p:sp>
       <p:sp>
         <p:nvSpPr>
-          <p:cNvPr id="89" name="Google Shape;89;p18"/>
+          <p:cNvPr id="21" name="Google Shape;73;p16">
+            <a:extLst>
+              <a:ext uri="{FF2B5EF4-FFF2-40B4-BE49-F238E27FC236}">
+                <a16:creationId xmlns:a16="http://schemas.microsoft.com/office/drawing/2014/main" id="{788E408B-A1D8-2950-780A-97D428145B4E}"/>
+              </a:ext>
+            </a:extLst>
+          </p:cNvPr>
           <p:cNvSpPr txBox="1"/>
           <p:nvPr/>
         </p:nvSpPr>
@@ -7244,12 +7358,12 @@
           </a:ln>
         </p:spPr>
         <p:txBody>
-          <a:bodyPr anchorCtr="0" anchor="t" bIns="91425" lIns="91425" spcFirstLastPara="1" rIns="91425" wrap="square" tIns="91425">
+          <a:bodyPr spcFirstLastPara="1" wrap="square" lIns="91425" tIns="91425" rIns="91425" bIns="91425" anchor="t" anchorCtr="0">
             <a:noAutofit/>
           </a:bodyPr>
           <a:lstStyle/>
           <a:p>
-            <a:pPr indent="0" lvl="0" marL="0" rtl="0" algn="just">
+            <a:pPr marL="0" lvl="0" indent="0" algn="just" rtl="0">
               <a:spcBef>
                 <a:spcPts val="0"/>
               </a:spcBef>
@@ -7264,7 +7378,7 @@
               <a:buNone/>
             </a:pPr>
             <a:r>
-              <a:rPr lang="en" sz="1200">
+              <a:rPr lang="en" sz="1200" dirty="0">
                 <a:solidFill>
                   <a:srgbClr val="FAF9FA"/>
                 </a:solidFill>
@@ -7273,21 +7387,9 @@
                 <a:cs typeface="Archivo Medium"/>
                 <a:sym typeface="Archivo Medium"/>
               </a:rPr>
-              <a:t>&lt;&lt;HABILIDAD 2.2&gt;&gt;</a:t>
+              <a:t>&lt;&lt;2_desc_hab_2&gt;&gt; </a:t>
             </a:r>
-            <a:r>
-              <a:rPr lang="en" sz="1200">
-                <a:solidFill>
-                  <a:srgbClr val="FAF9FA"/>
-                </a:solidFill>
-                <a:latin typeface="Archivo Medium"/>
-                <a:ea typeface="Archivo Medium"/>
-                <a:cs typeface="Archivo Medium"/>
-                <a:sym typeface="Archivo Medium"/>
-              </a:rPr>
-              <a:t> </a:t>
-            </a:r>
-            <a:endParaRPr sz="1200">
+            <a:endParaRPr sz="1200" dirty="0">
               <a:solidFill>
                 <a:srgbClr val="595959"/>
               </a:solidFill>
@@ -7301,7 +7403,13 @@
       </p:sp>
       <p:sp>
         <p:nvSpPr>
-          <p:cNvPr id="90" name="Google Shape;90;p18"/>
+          <p:cNvPr id="23" name="Google Shape;74;p16">
+            <a:extLst>
+              <a:ext uri="{FF2B5EF4-FFF2-40B4-BE49-F238E27FC236}">
+                <a16:creationId xmlns:a16="http://schemas.microsoft.com/office/drawing/2014/main" id="{7D6B6BC3-A3EC-81BC-4611-17F00D5F8265}"/>
+              </a:ext>
+            </a:extLst>
+          </p:cNvPr>
           <p:cNvSpPr txBox="1"/>
           <p:nvPr/>
         </p:nvSpPr>
@@ -7319,12 +7427,12 @@
           </a:ln>
         </p:spPr>
         <p:txBody>
-          <a:bodyPr anchorCtr="0" anchor="t" bIns="91425" lIns="91425" spcFirstLastPara="1" rIns="91425" wrap="square" tIns="91425">
+          <a:bodyPr spcFirstLastPara="1" wrap="square" lIns="91425" tIns="91425" rIns="91425" bIns="91425" anchor="t" anchorCtr="0">
             <a:noAutofit/>
           </a:bodyPr>
           <a:lstStyle/>
           <a:p>
-            <a:pPr indent="0" lvl="0" marL="0" rtl="0" algn="l">
+            <a:pPr marL="0" lvl="0" indent="0" algn="l" rtl="0">
               <a:spcBef>
                 <a:spcPts val="0"/>
               </a:spcBef>
@@ -7334,7 +7442,7 @@
               <a:buNone/>
             </a:pPr>
             <a:r>
-              <a:rPr b="1" lang="en" sz="1700">
+              <a:rPr lang="en" sz="1700" b="1" dirty="0">
                 <a:solidFill>
                   <a:srgbClr val="FF6C4C"/>
                 </a:solidFill>
@@ -7343,9 +7451,9 @@
                 <a:cs typeface="Archivo"/>
                 <a:sym typeface="Archivo"/>
               </a:rPr>
-              <a:t>&lt;&lt;TÍTULO HABILIDAD 2.2&gt;&gt;</a:t>
+              <a:t>&lt;&lt;2_hab_2&gt;&gt;</a:t>
             </a:r>
-            <a:endParaRPr b="1" sz="1700">
+            <a:endParaRPr sz="1700" b="1" dirty="0">
               <a:solidFill>
                 <a:srgbClr val="FF6C4C"/>
               </a:solidFill>
@@ -7366,7 +7474,7 @@
 </file>
 
 <file path=ppt/slides/slide7.xml><?xml version="1.0" encoding="utf-8"?>
-<p:sld xmlns:a="http://schemas.openxmlformats.org/drawingml/2006/main" xmlns:r="http://schemas.openxmlformats.org/officeDocument/2006/relationships" xmlns:mc="http://schemas.openxmlformats.org/markup-compatibility/2006" xmlns:mv="urn:schemas-microsoft-com:mac:vml" xmlns:p="http://schemas.openxmlformats.org/presentationml/2006/main" xmlns:c="http://schemas.openxmlformats.org/drawingml/2006/chart" xmlns:dgm="http://schemas.openxmlformats.org/drawingml/2006/diagram" xmlns:o="urn:schemas-microsoft-com:office:office" xmlns:v="urn:schemas-microsoft-com:vml" xmlns:pvml="urn:schemas-microsoft-com:office:powerpoint" xmlns:com="http://schemas.openxmlformats.org/drawingml/2006/compatibility" xmlns:p14="http://schemas.microsoft.com/office/powerpoint/2010/main" xmlns:p15="http://schemas.microsoft.com/office/powerpoint/2012/main" xmlns:ahyp="http://schemas.microsoft.com/office/drawing/2018/hyperlinkcolor">
+<p:sld xmlns:a="http://schemas.openxmlformats.org/drawingml/2006/main" xmlns:r="http://schemas.openxmlformats.org/officeDocument/2006/relationships" xmlns:p="http://schemas.openxmlformats.org/presentationml/2006/main">
   <p:cSld>
     <p:bg>
       <p:bgPr>
@@ -7378,11 +7486,12 @@
             <a:fillRect/>
           </a:stretch>
         </a:blipFill>
+        <a:effectLst/>
       </p:bgPr>
     </p:bg>
     <p:spTree>
       <p:nvGrpSpPr>
-        <p:cNvPr id="94" name="Shape 94"/>
+        <p:cNvPr id="1" name="Shape 94"/>
         <p:cNvGrpSpPr/>
         <p:nvPr/>
       </p:nvGrpSpPr>
@@ -7403,7 +7512,7 @@
 </file>
 
 <file path=ppt/theme/theme1.xml><?xml version="1.0" encoding="utf-8"?>
-<a:theme xmlns:a="http://schemas.openxmlformats.org/drawingml/2006/main" xmlns:r="http://schemas.openxmlformats.org/officeDocument/2006/relationships" name="Simple Light">
+<a:theme xmlns:a="http://schemas.openxmlformats.org/drawingml/2006/main" name="Simple Light">
   <a:themeElements>
     <a:clrScheme name="Simple Light">
       <a:dk1>
@@ -7678,11 +7787,13 @@
       </a:bgFillStyleLst>
     </a:fmtScheme>
   </a:themeElements>
+  <a:objectDefaults/>
+  <a:extraClrSchemeLst/>
 </a:theme>
 </file>
 
 <file path=ppt/theme/theme2.xml><?xml version="1.0" encoding="utf-8"?>
-<a:theme xmlns:a="http://schemas.openxmlformats.org/drawingml/2006/main" xmlns:r="http://schemas.openxmlformats.org/officeDocument/2006/relationships">
+<a:theme xmlns:a="http://schemas.openxmlformats.org/drawingml/2006/main">
   <a:themeElements>
     <a:clrScheme name="Default">
       <a:dk1>
@@ -7957,5 +8068,7 @@
       </a:bgFillStyleLst>
     </a:fmtScheme>
   </a:themeElements>
+  <a:objectDefaults/>
+  <a:extraClrSchemeLst/>
 </a:theme>
 </file>
</xml_diff>